<commit_message>
docs(ppt): add the tracing part and update the figures.
Signed-off-by: Leo Cheng <chengkelfan@qq.com>
</commit_message>
<xml_diff>
--- a/实习总结.pptx
+++ b/实习总结.pptx
@@ -37,9 +37,14 @@
     <p:sldId id="285" r:id="rId31"/>
     <p:sldId id="286" r:id="rId32"/>
     <p:sldId id="287" r:id="rId33"/>
+    <p:sldId id="288" r:id="rId34"/>
+    <p:sldId id="289" r:id="rId35"/>
+    <p:sldId id="290" r:id="rId36"/>
+    <p:sldId id="291" r:id="rId37"/>
+    <p:sldId id="292" r:id="rId38"/>
   </p:sldIdLst>
   <p:notesMasterIdLst>
-    <p:notesMasterId r:id="rId34"/>
+    <p:notesMasterId r:id="rId39"/>
   </p:notesMasterIdLst>
   <p:sldSz cx="12192000" cy="6858000"/>
   <p:notesSz cx="6858000" cy="12192000"/>
@@ -4503,6 +4508,446 @@
             <a:fld id="{F7021451-1387-4CA6-816F-3879F97B5CBC}" type="slidenum">
               <a:rPr lang="en-US"/>
               <a:t>32</a:t>
+            </a:fld>
+            <a:endParaRPr lang="en-US"/>
+          </a:p>
+        </p:txBody>
+      </p:sp>
+    </p:spTree>
+    <p:extLst>
+      <p:ext uri="{BB962C8B-B14F-4D97-AF65-F5344CB8AC3E}">
+        <p14:creationId xmlns:p14="http://schemas.microsoft.com/office/powerpoint/2010/main" val="1024086991"/>
+      </p:ext>
+    </p:extLst>
+  </p:cSld>
+  <p:clrMapOvr>
+    <a:masterClrMapping/>
+  </p:clrMapOvr>
+</p:notes>
+</file>
+
+<file path=ppt/notesSlides/notesSlide33.xml><?xml version="1.0" encoding="utf-8"?>
+<p:notes xmlns:a="http://schemas.openxmlformats.org/drawingml/2006/main" xmlns:r="http://schemas.openxmlformats.org/officeDocument/2006/relationships" xmlns:p="http://schemas.openxmlformats.org/presentationml/2006/main">
+  <p:cSld>
+    <p:spTree>
+      <p:nvGrpSpPr>
+        <p:cNvPr id="1" name=""/>
+        <p:cNvGrpSpPr/>
+        <p:nvPr/>
+      </p:nvGrpSpPr>
+      <p:grpSpPr>
+        <a:xfrm>
+          <a:off x="0" y="0"/>
+          <a:ext cx="0" cy="0"/>
+          <a:chOff x="0" y="0"/>
+          <a:chExt cx="0" cy="0"/>
+        </a:xfrm>
+      </p:grpSpPr>
+      <p:sp>
+        <p:nvSpPr>
+          <p:cNvPr id="2" name="Slide Image Placeholder 1"/>
+          <p:cNvSpPr>
+            <a:spLocks noGrp="1" noRot="1" noChangeAspect="1"/>
+          </p:cNvSpPr>
+          <p:nvPr>
+            <p:ph type="sldImg"/>
+          </p:nvPr>
+        </p:nvSpPr>
+        <p:spPr/>
+      </p:sp>
+      <p:sp>
+        <p:nvSpPr>
+          <p:cNvPr id="3" name="Notes Placeholder 2"/>
+          <p:cNvSpPr>
+            <a:spLocks noGrp="1"/>
+          </p:cNvSpPr>
+          <p:nvPr>
+            <p:ph type="body" idx="1"/>
+          </p:nvPr>
+        </p:nvSpPr>
+        <p:spPr/>
+        <p:txBody>
+          <a:bodyPr/>
+          <a:lstStyle/>
+          <a:p>
+            <a:r>
+              <a:rPr lang="en-US" dirty="0"/>
+              <a:t/>
+            </a:r>
+            <a:endParaRPr lang="en-US" dirty="0"/>
+          </a:p>
+        </p:txBody>
+      </p:sp>
+      <p:sp>
+        <p:nvSpPr>
+          <p:cNvPr id="4" name="Slide Number Placeholder 3"/>
+          <p:cNvSpPr>
+            <a:spLocks noGrp="1"/>
+          </p:cNvSpPr>
+          <p:nvPr>
+            <p:ph type="sldNum" sz="quarter" idx="10"/>
+          </p:nvPr>
+        </p:nvSpPr>
+        <p:spPr/>
+        <p:txBody>
+          <a:bodyPr/>
+          <a:lstStyle/>
+          <a:p>
+            <a:fld id="{F7021451-1387-4CA6-816F-3879F97B5CBC}" type="slidenum">
+              <a:rPr lang="en-US"/>
+              <a:t>33</a:t>
+            </a:fld>
+            <a:endParaRPr lang="en-US"/>
+          </a:p>
+        </p:txBody>
+      </p:sp>
+    </p:spTree>
+    <p:extLst>
+      <p:ext uri="{BB962C8B-B14F-4D97-AF65-F5344CB8AC3E}">
+        <p14:creationId xmlns:p14="http://schemas.microsoft.com/office/powerpoint/2010/main" val="1024086991"/>
+      </p:ext>
+    </p:extLst>
+  </p:cSld>
+  <p:clrMapOvr>
+    <a:masterClrMapping/>
+  </p:clrMapOvr>
+</p:notes>
+</file>
+
+<file path=ppt/notesSlides/notesSlide34.xml><?xml version="1.0" encoding="utf-8"?>
+<p:notes xmlns:a="http://schemas.openxmlformats.org/drawingml/2006/main" xmlns:r="http://schemas.openxmlformats.org/officeDocument/2006/relationships" xmlns:p="http://schemas.openxmlformats.org/presentationml/2006/main">
+  <p:cSld>
+    <p:spTree>
+      <p:nvGrpSpPr>
+        <p:cNvPr id="1" name=""/>
+        <p:cNvGrpSpPr/>
+        <p:nvPr/>
+      </p:nvGrpSpPr>
+      <p:grpSpPr>
+        <a:xfrm>
+          <a:off x="0" y="0"/>
+          <a:ext cx="0" cy="0"/>
+          <a:chOff x="0" y="0"/>
+          <a:chExt cx="0" cy="0"/>
+        </a:xfrm>
+      </p:grpSpPr>
+      <p:sp>
+        <p:nvSpPr>
+          <p:cNvPr id="2" name="Slide Image Placeholder 1"/>
+          <p:cNvSpPr>
+            <a:spLocks noGrp="1" noRot="1" noChangeAspect="1"/>
+          </p:cNvSpPr>
+          <p:nvPr>
+            <p:ph type="sldImg"/>
+          </p:nvPr>
+        </p:nvSpPr>
+        <p:spPr/>
+      </p:sp>
+      <p:sp>
+        <p:nvSpPr>
+          <p:cNvPr id="3" name="Notes Placeholder 2"/>
+          <p:cNvSpPr>
+            <a:spLocks noGrp="1"/>
+          </p:cNvSpPr>
+          <p:nvPr>
+            <p:ph type="body" idx="1"/>
+          </p:nvPr>
+        </p:nvSpPr>
+        <p:spPr/>
+        <p:txBody>
+          <a:bodyPr/>
+          <a:lstStyle/>
+          <a:p>
+            <a:r>
+              <a:rPr lang="en-US" dirty="0"/>
+              <a:t/>
+            </a:r>
+            <a:endParaRPr lang="en-US" dirty="0"/>
+          </a:p>
+        </p:txBody>
+      </p:sp>
+      <p:sp>
+        <p:nvSpPr>
+          <p:cNvPr id="4" name="Slide Number Placeholder 3"/>
+          <p:cNvSpPr>
+            <a:spLocks noGrp="1"/>
+          </p:cNvSpPr>
+          <p:nvPr>
+            <p:ph type="sldNum" sz="quarter" idx="10"/>
+          </p:nvPr>
+        </p:nvSpPr>
+        <p:spPr/>
+        <p:txBody>
+          <a:bodyPr/>
+          <a:lstStyle/>
+          <a:p>
+            <a:fld id="{F7021451-1387-4CA6-816F-3879F97B5CBC}" type="slidenum">
+              <a:rPr lang="en-US"/>
+              <a:t>34</a:t>
+            </a:fld>
+            <a:endParaRPr lang="en-US"/>
+          </a:p>
+        </p:txBody>
+      </p:sp>
+    </p:spTree>
+    <p:extLst>
+      <p:ext uri="{BB962C8B-B14F-4D97-AF65-F5344CB8AC3E}">
+        <p14:creationId xmlns:p14="http://schemas.microsoft.com/office/powerpoint/2010/main" val="1024086991"/>
+      </p:ext>
+    </p:extLst>
+  </p:cSld>
+  <p:clrMapOvr>
+    <a:masterClrMapping/>
+  </p:clrMapOvr>
+</p:notes>
+</file>
+
+<file path=ppt/notesSlides/notesSlide35.xml><?xml version="1.0" encoding="utf-8"?>
+<p:notes xmlns:a="http://schemas.openxmlformats.org/drawingml/2006/main" xmlns:r="http://schemas.openxmlformats.org/officeDocument/2006/relationships" xmlns:p="http://schemas.openxmlformats.org/presentationml/2006/main">
+  <p:cSld>
+    <p:spTree>
+      <p:nvGrpSpPr>
+        <p:cNvPr id="1" name=""/>
+        <p:cNvGrpSpPr/>
+        <p:nvPr/>
+      </p:nvGrpSpPr>
+      <p:grpSpPr>
+        <a:xfrm>
+          <a:off x="0" y="0"/>
+          <a:ext cx="0" cy="0"/>
+          <a:chOff x="0" y="0"/>
+          <a:chExt cx="0" cy="0"/>
+        </a:xfrm>
+      </p:grpSpPr>
+      <p:sp>
+        <p:nvSpPr>
+          <p:cNvPr id="2" name="Slide Image Placeholder 1"/>
+          <p:cNvSpPr>
+            <a:spLocks noGrp="1" noRot="1" noChangeAspect="1"/>
+          </p:cNvSpPr>
+          <p:nvPr>
+            <p:ph type="sldImg"/>
+          </p:nvPr>
+        </p:nvSpPr>
+        <p:spPr/>
+      </p:sp>
+      <p:sp>
+        <p:nvSpPr>
+          <p:cNvPr id="3" name="Notes Placeholder 2"/>
+          <p:cNvSpPr>
+            <a:spLocks noGrp="1"/>
+          </p:cNvSpPr>
+          <p:nvPr>
+            <p:ph type="body" idx="1"/>
+          </p:nvPr>
+        </p:nvSpPr>
+        <p:spPr/>
+        <p:txBody>
+          <a:bodyPr/>
+          <a:lstStyle/>
+          <a:p>
+            <a:r>
+              <a:rPr lang="en-US" dirty="0"/>
+              <a:t/>
+            </a:r>
+            <a:endParaRPr lang="en-US" dirty="0"/>
+          </a:p>
+        </p:txBody>
+      </p:sp>
+      <p:sp>
+        <p:nvSpPr>
+          <p:cNvPr id="4" name="Slide Number Placeholder 3"/>
+          <p:cNvSpPr>
+            <a:spLocks noGrp="1"/>
+          </p:cNvSpPr>
+          <p:nvPr>
+            <p:ph type="sldNum" sz="quarter" idx="10"/>
+          </p:nvPr>
+        </p:nvSpPr>
+        <p:spPr/>
+        <p:txBody>
+          <a:bodyPr/>
+          <a:lstStyle/>
+          <a:p>
+            <a:fld id="{F7021451-1387-4CA6-816F-3879F97B5CBC}" type="slidenum">
+              <a:rPr lang="en-US"/>
+              <a:t>35</a:t>
+            </a:fld>
+            <a:endParaRPr lang="en-US"/>
+          </a:p>
+        </p:txBody>
+      </p:sp>
+    </p:spTree>
+    <p:extLst>
+      <p:ext uri="{BB962C8B-B14F-4D97-AF65-F5344CB8AC3E}">
+        <p14:creationId xmlns:p14="http://schemas.microsoft.com/office/powerpoint/2010/main" val="1024086991"/>
+      </p:ext>
+    </p:extLst>
+  </p:cSld>
+  <p:clrMapOvr>
+    <a:masterClrMapping/>
+  </p:clrMapOvr>
+</p:notes>
+</file>
+
+<file path=ppt/notesSlides/notesSlide36.xml><?xml version="1.0" encoding="utf-8"?>
+<p:notes xmlns:a="http://schemas.openxmlformats.org/drawingml/2006/main" xmlns:r="http://schemas.openxmlformats.org/officeDocument/2006/relationships" xmlns:p="http://schemas.openxmlformats.org/presentationml/2006/main">
+  <p:cSld>
+    <p:spTree>
+      <p:nvGrpSpPr>
+        <p:cNvPr id="1" name=""/>
+        <p:cNvGrpSpPr/>
+        <p:nvPr/>
+      </p:nvGrpSpPr>
+      <p:grpSpPr>
+        <a:xfrm>
+          <a:off x="0" y="0"/>
+          <a:ext cx="0" cy="0"/>
+          <a:chOff x="0" y="0"/>
+          <a:chExt cx="0" cy="0"/>
+        </a:xfrm>
+      </p:grpSpPr>
+      <p:sp>
+        <p:nvSpPr>
+          <p:cNvPr id="2" name="Slide Image Placeholder 1"/>
+          <p:cNvSpPr>
+            <a:spLocks noGrp="1" noRot="1" noChangeAspect="1"/>
+          </p:cNvSpPr>
+          <p:nvPr>
+            <p:ph type="sldImg"/>
+          </p:nvPr>
+        </p:nvSpPr>
+        <p:spPr/>
+      </p:sp>
+      <p:sp>
+        <p:nvSpPr>
+          <p:cNvPr id="3" name="Notes Placeholder 2"/>
+          <p:cNvSpPr>
+            <a:spLocks noGrp="1"/>
+          </p:cNvSpPr>
+          <p:nvPr>
+            <p:ph type="body" idx="1"/>
+          </p:nvPr>
+        </p:nvSpPr>
+        <p:spPr/>
+        <p:txBody>
+          <a:bodyPr/>
+          <a:lstStyle/>
+          <a:p>
+            <a:r>
+              <a:rPr lang="en-US" dirty="0"/>
+              <a:t/>
+            </a:r>
+            <a:endParaRPr lang="en-US" dirty="0"/>
+          </a:p>
+        </p:txBody>
+      </p:sp>
+      <p:sp>
+        <p:nvSpPr>
+          <p:cNvPr id="4" name="Slide Number Placeholder 3"/>
+          <p:cNvSpPr>
+            <a:spLocks noGrp="1"/>
+          </p:cNvSpPr>
+          <p:nvPr>
+            <p:ph type="sldNum" sz="quarter" idx="10"/>
+          </p:nvPr>
+        </p:nvSpPr>
+        <p:spPr/>
+        <p:txBody>
+          <a:bodyPr/>
+          <a:lstStyle/>
+          <a:p>
+            <a:fld id="{F7021451-1387-4CA6-816F-3879F97B5CBC}" type="slidenum">
+              <a:rPr lang="en-US"/>
+              <a:t>36</a:t>
+            </a:fld>
+            <a:endParaRPr lang="en-US"/>
+          </a:p>
+        </p:txBody>
+      </p:sp>
+    </p:spTree>
+    <p:extLst>
+      <p:ext uri="{BB962C8B-B14F-4D97-AF65-F5344CB8AC3E}">
+        <p14:creationId xmlns:p14="http://schemas.microsoft.com/office/powerpoint/2010/main" val="1024086991"/>
+      </p:ext>
+    </p:extLst>
+  </p:cSld>
+  <p:clrMapOvr>
+    <a:masterClrMapping/>
+  </p:clrMapOvr>
+</p:notes>
+</file>
+
+<file path=ppt/notesSlides/notesSlide37.xml><?xml version="1.0" encoding="utf-8"?>
+<p:notes xmlns:a="http://schemas.openxmlformats.org/drawingml/2006/main" xmlns:r="http://schemas.openxmlformats.org/officeDocument/2006/relationships" xmlns:p="http://schemas.openxmlformats.org/presentationml/2006/main">
+  <p:cSld>
+    <p:spTree>
+      <p:nvGrpSpPr>
+        <p:cNvPr id="1" name=""/>
+        <p:cNvGrpSpPr/>
+        <p:nvPr/>
+      </p:nvGrpSpPr>
+      <p:grpSpPr>
+        <a:xfrm>
+          <a:off x="0" y="0"/>
+          <a:ext cx="0" cy="0"/>
+          <a:chOff x="0" y="0"/>
+          <a:chExt cx="0" cy="0"/>
+        </a:xfrm>
+      </p:grpSpPr>
+      <p:sp>
+        <p:nvSpPr>
+          <p:cNvPr id="2" name="Slide Image Placeholder 1"/>
+          <p:cNvSpPr>
+            <a:spLocks noGrp="1" noRot="1" noChangeAspect="1"/>
+          </p:cNvSpPr>
+          <p:nvPr>
+            <p:ph type="sldImg"/>
+          </p:nvPr>
+        </p:nvSpPr>
+        <p:spPr/>
+      </p:sp>
+      <p:sp>
+        <p:nvSpPr>
+          <p:cNvPr id="3" name="Notes Placeholder 2"/>
+          <p:cNvSpPr>
+            <a:spLocks noGrp="1"/>
+          </p:cNvSpPr>
+          <p:nvPr>
+            <p:ph type="body" idx="1"/>
+          </p:nvPr>
+        </p:nvSpPr>
+        <p:spPr/>
+        <p:txBody>
+          <a:bodyPr/>
+          <a:lstStyle/>
+          <a:p>
+            <a:r>
+              <a:rPr lang="en-US" dirty="0"/>
+              <a:t/>
+            </a:r>
+            <a:endParaRPr lang="en-US" dirty="0"/>
+          </a:p>
+        </p:txBody>
+      </p:sp>
+      <p:sp>
+        <p:nvSpPr>
+          <p:cNvPr id="4" name="Slide Number Placeholder 3"/>
+          <p:cNvSpPr>
+            <a:spLocks noGrp="1"/>
+          </p:cNvSpPr>
+          <p:nvPr>
+            <p:ph type="sldNum" sz="quarter" idx="10"/>
+          </p:nvPr>
+        </p:nvSpPr>
+        <p:spPr/>
+        <p:txBody>
+          <a:bodyPr/>
+          <a:lstStyle/>
+          <a:p>
+            <a:fld id="{F7021451-1387-4CA6-816F-3879F97B5CBC}" type="slidenum">
+              <a:rPr lang="en-US"/>
+              <a:t>37</a:t>
             </a:fld>
             <a:endParaRPr lang="en-US"/>
           </a:p>
@@ -5552,7 +5997,7 @@
                 <a:ea typeface="HarmonyOS Sans SC" pitchFamily="34" charset="-122"/>
                 <a:cs typeface="HarmonyOS Sans SC" pitchFamily="34" charset="-120"/>
               </a:rPr>
-              <a:t>应用测试 · 浏览器对照 Linux · Personality</a:t>
+              <a:t>应用测试 · 浏览器对照 Linux · Personality · 溯源</a:t>
             </a:r>
             <a:endParaRPr lang="zh-CN" sz="2000" dirty="0"/>
           </a:p>
@@ -16294,7 +16739,7 @@
                 <a:ea typeface="HarmonyOS Sans SC" pitchFamily="34" charset="-122"/>
                 <a:cs typeface="HarmonyOS Sans SC" pitchFamily="34" charset="-120"/>
               </a:rPr>
-              <a:t>76 个内核补丁逐个对到 Linux 源码与 man 原文</a:t>
+              <a:t>68 个内核补丁全部对到 Linux 源码的具体行与 man 原文</a:t>
             </a:r>
             <a:endParaRPr lang="zh-CN" sz="1300" dirty="0"/>
           </a:p>
@@ -19229,7 +19674,7 @@
       </p:sp>
       <p:pic>
         <p:nvPicPr>
-          <p:cNvPr id="6" name="Image 0" descr="C:\Users\heke\AppData\Local\Temp\claude\C--Users-heke-AllProjects-TempFolder-rcore\1c6e91ee-4f87-4550-9a26-b0faa3d92502\scratchpad\atl\deck\img\p2202-crop.png">    </p:cNvPr>
+          <p:cNvPr id="6" name="Image 0" descr="C:\Users\heke\AppData\Local\Temp\claude\C--Users-heke-AllProjects-TempFolder-rcore\1c6e91ee-4f87-4550-9a26-b0faa3d92502\scratchpad\deck2\img\p2202-crop.png">    </p:cNvPr>
           <p:cNvPicPr>
             <a:picLocks noChangeAspect="1"/>
           </p:cNvPicPr>
@@ -27068,6 +27513,4372 @@
 <file path=ppt/slides/slide32.xml><?xml version="1.0" encoding="utf-8"?>
 <p:sld xmlns:a="http://schemas.openxmlformats.org/drawingml/2006/main" xmlns:r="http://schemas.openxmlformats.org/officeDocument/2006/relationships" xmlns:p="http://schemas.openxmlformats.org/presentationml/2006/main">
   <p:cSld name="Slide 32">
+    <p:bg>
+      <p:bgPr>
+        <a:solidFill>
+          <a:srgbClr val="0B1437"/>
+        </a:solidFill>
+      </p:bgPr>
+    </p:bg>
+    <p:spTree>
+      <p:nvGrpSpPr>
+        <p:cNvPr id="1" name=""/>
+        <p:cNvGrpSpPr/>
+        <p:nvPr/>
+      </p:nvGrpSpPr>
+      <p:grpSpPr>
+        <a:xfrm>
+          <a:off x="0" y="0"/>
+          <a:ext cx="0" cy="0"/>
+          <a:chOff x="0" y="0"/>
+          <a:chExt cx="0" cy="0"/>
+        </a:xfrm>
+      </p:grpSpPr>
+      <p:sp>
+        <p:nvSpPr>
+          <p:cNvPr id="2" name="Shape 0"/>
+          <p:cNvSpPr/>
+          <p:nvPr/>
+        </p:nvSpPr>
+        <p:spPr>
+          <a:xfrm>
+            <a:off x="9692640" y="1188720"/>
+            <a:ext cx="1371600" cy="1371600"/>
+          </a:xfrm>
+          <a:prstGeom prst="star4">
+            <a:avLst/>
+          </a:prstGeom>
+          <a:solidFill>
+            <a:srgbClr val="F2B441"/>
+          </a:solidFill>
+          <a:ln w="12700">
+            <a:solidFill>
+              <a:srgbClr val="F2B441"/>
+            </a:solidFill>
+            <a:prstDash val="solid"/>
+          </a:ln>
+        </p:spPr>
+      </p:sp>
+      <p:sp>
+        <p:nvSpPr>
+          <p:cNvPr id="3" name="Shape 1"/>
+          <p:cNvSpPr/>
+          <p:nvPr/>
+        </p:nvSpPr>
+        <p:spPr>
+          <a:xfrm>
+            <a:off x="10972800" y="2743200"/>
+            <a:ext cx="457200" cy="457200"/>
+          </a:xfrm>
+          <a:prstGeom prst="star4">
+            <a:avLst/>
+          </a:prstGeom>
+          <a:solidFill>
+            <a:srgbClr val="C9D2EA"/>
+          </a:solidFill>
+          <a:ln w="12700">
+            <a:solidFill>
+              <a:srgbClr val="C9D2EA"/>
+            </a:solidFill>
+            <a:prstDash val="solid"/>
+          </a:ln>
+        </p:spPr>
+      </p:sp>
+      <p:sp>
+        <p:nvSpPr>
+          <p:cNvPr id="4" name="Shape 2"/>
+          <p:cNvSpPr/>
+          <p:nvPr/>
+        </p:nvSpPr>
+        <p:spPr>
+          <a:xfrm>
+            <a:off x="9052560" y="3108960"/>
+            <a:ext cx="274320" cy="274320"/>
+          </a:xfrm>
+          <a:prstGeom prst="star4">
+            <a:avLst/>
+          </a:prstGeom>
+          <a:solidFill>
+            <a:srgbClr val="C9D2EA"/>
+          </a:solidFill>
+          <a:ln w="12700">
+            <a:solidFill>
+              <a:srgbClr val="C9D2EA"/>
+            </a:solidFill>
+            <a:prstDash val="solid"/>
+          </a:ln>
+        </p:spPr>
+      </p:sp>
+      <p:sp>
+        <p:nvSpPr>
+          <p:cNvPr id="5" name="Text 3"/>
+          <p:cNvSpPr/>
+          <p:nvPr/>
+        </p:nvSpPr>
+        <p:spPr>
+          <a:xfrm>
+            <a:off x="640080" y="2103120"/>
+            <a:ext cx="2743200" cy="1005840"/>
+          </a:xfrm>
+          <a:prstGeom prst="rect">
+            <a:avLst/>
+          </a:prstGeom>
+          <a:noFill/>
+          <a:ln/>
+        </p:spPr>
+        <p:txBody>
+          <a:bodyPr wrap="square" lIns="0" tIns="0" rIns="0" bIns="0" rtlCol="0" anchor="ctr"/>
+          <a:lstStyle/>
+          <a:p>
+            <a:pPr indent="0" marL="0">
+              <a:buNone/>
+            </a:pPr>
+            <a:r>
+              <a:rPr lang="zh-CN" altLang="en-US" sz="6600" b="1" dirty="0">
+                <a:solidFill>
+                  <a:srgbClr val="F2B441"/>
+                </a:solidFill>
+                <a:latin typeface="JetBrains Mono" pitchFamily="34" charset="0"/>
+                <a:ea typeface="JetBrains Mono" pitchFamily="34" charset="-122"/>
+                <a:cs typeface="JetBrains Mono" pitchFamily="34" charset="-120"/>
+              </a:rPr>
+              <a:t>05</a:t>
+            </a:r>
+            <a:endParaRPr lang="zh-CN" sz="6600" dirty="0"/>
+          </a:p>
+        </p:txBody>
+      </p:sp>
+      <p:sp>
+        <p:nvSpPr>
+          <p:cNvPr id="6" name="Text 4"/>
+          <p:cNvSpPr/>
+          <p:nvPr/>
+        </p:nvSpPr>
+        <p:spPr>
+          <a:xfrm>
+            <a:off x="640080" y="3200400"/>
+            <a:ext cx="8229600" cy="822960"/>
+          </a:xfrm>
+          <a:prstGeom prst="rect">
+            <a:avLst/>
+          </a:prstGeom>
+          <a:noFill/>
+          <a:ln/>
+        </p:spPr>
+        <p:txBody>
+          <a:bodyPr wrap="square" lIns="0" tIns="0" rIns="0" bIns="0" rtlCol="0" anchor="ctr"/>
+          <a:lstStyle/>
+          <a:p>
+            <a:pPr indent="0" marL="0">
+              <a:buNone/>
+            </a:pPr>
+            <a:r>
+              <a:rPr lang="zh-CN" altLang="en-US" sz="3800" b="1" dirty="0">
+                <a:solidFill>
+                  <a:srgbClr val="FFFFFF"/>
+                </a:solidFill>
+                <a:latin typeface="HarmonyOS Sans SC" pitchFamily="34" charset="0"/>
+                <a:ea typeface="HarmonyOS Sans SC" pitchFamily="34" charset="-122"/>
+                <a:cs typeface="HarmonyOS Sans SC" pitchFamily="34" charset="-120"/>
+              </a:rPr>
+              <a:t>溯源</a:t>
+            </a:r>
+            <a:endParaRPr lang="zh-CN" sz="3800" dirty="0"/>
+          </a:p>
+        </p:txBody>
+      </p:sp>
+      <p:sp>
+        <p:nvSpPr>
+          <p:cNvPr id="7" name="Text 5"/>
+          <p:cNvSpPr/>
+          <p:nvPr/>
+        </p:nvSpPr>
+        <p:spPr>
+          <a:xfrm>
+            <a:off x="640080" y="4069080"/>
+            <a:ext cx="8229600" cy="548640"/>
+          </a:xfrm>
+          <a:prstGeom prst="rect">
+            <a:avLst/>
+          </a:prstGeom>
+          <a:noFill/>
+          <a:ln/>
+        </p:spPr>
+        <p:txBody>
+          <a:bodyPr wrap="square" lIns="0" tIns="0" rIns="0" bIns="0" rtlCol="0" anchor="ctr"/>
+          <a:lstStyle/>
+          <a:p>
+            <a:pPr indent="0" marL="0">
+              <a:buNone/>
+            </a:pPr>
+            <a:r>
+              <a:rPr lang="zh-CN" altLang="en-US" sz="1600" dirty="0">
+                <a:solidFill>
+                  <a:srgbClr val="C9D2EA"/>
+                </a:solidFill>
+                <a:latin typeface="HarmonyOS Sans SC" pitchFamily="34" charset="0"/>
+                <a:ea typeface="HarmonyOS Sans SC" pitchFamily="34" charset="-122"/>
+                <a:cs typeface="HarmonyOS Sans SC" pitchFamily="34" charset="-120"/>
+              </a:rPr>
+              <a:t>每个内核补丁对到 Linux 源码的具体行与 man 原文</a:t>
+            </a:r>
+            <a:endParaRPr lang="zh-CN" sz="1600" dirty="0"/>
+          </a:p>
+        </p:txBody>
+      </p:sp>
+    </p:spTree>
+  </p:cSld>
+  <p:clrMapOvr>
+    <a:masterClrMapping/>
+  </p:clrMapOvr>
+</p:sld>
+</file>
+
+<file path=ppt/slides/slide33.xml><?xml version="1.0" encoding="utf-8"?>
+<p:sld xmlns:a="http://schemas.openxmlformats.org/drawingml/2006/main" xmlns:r="http://schemas.openxmlformats.org/officeDocument/2006/relationships" xmlns:p="http://schemas.openxmlformats.org/presentationml/2006/main">
+  <p:cSld name="Slide 33">
+    <p:bg>
+      <p:bgPr>
+        <a:solidFill>
+          <a:srgbClr val="FFFFFF"/>
+        </a:solidFill>
+      </p:bgPr>
+    </p:bg>
+    <p:spTree>
+      <p:nvGrpSpPr>
+        <p:cNvPr id="1" name=""/>
+        <p:cNvGrpSpPr/>
+        <p:nvPr/>
+      </p:nvGrpSpPr>
+      <p:grpSpPr>
+        <a:xfrm>
+          <a:off x="0" y="0"/>
+          <a:ext cx="0" cy="0"/>
+          <a:chOff x="0" y="0"/>
+          <a:chExt cx="0" cy="0"/>
+        </a:xfrm>
+      </p:grpSpPr>
+      <p:sp>
+        <p:nvSpPr>
+          <p:cNvPr id="2" name="Shape 0"/>
+          <p:cNvSpPr/>
+          <p:nvPr/>
+        </p:nvSpPr>
+        <p:spPr>
+          <a:xfrm>
+            <a:off x="640080" y="457200"/>
+            <a:ext cx="201168" cy="201168"/>
+          </a:xfrm>
+          <a:prstGeom prst="star4">
+            <a:avLst/>
+          </a:prstGeom>
+          <a:solidFill>
+            <a:srgbClr val="F2B441"/>
+          </a:solidFill>
+          <a:ln w="12700">
+            <a:solidFill>
+              <a:srgbClr val="F2B441"/>
+            </a:solidFill>
+            <a:prstDash val="solid"/>
+          </a:ln>
+        </p:spPr>
+      </p:sp>
+      <p:sp>
+        <p:nvSpPr>
+          <p:cNvPr id="3" name="Text 1"/>
+          <p:cNvSpPr/>
+          <p:nvPr/>
+        </p:nvSpPr>
+        <p:spPr>
+          <a:xfrm>
+            <a:off x="932688" y="402336"/>
+            <a:ext cx="7315200" cy="310896"/>
+          </a:xfrm>
+          <a:prstGeom prst="rect">
+            <a:avLst/>
+          </a:prstGeom>
+          <a:noFill/>
+          <a:ln/>
+        </p:spPr>
+        <p:txBody>
+          <a:bodyPr wrap="square" lIns="0" tIns="0" rIns="0" bIns="0" rtlCol="0" anchor="ctr"/>
+          <a:lstStyle/>
+          <a:p>
+            <a:pPr indent="0" marL="0">
+              <a:buNone/>
+            </a:pPr>
+            <a:r>
+              <a:rPr lang="zh-CN" altLang="en-US" sz="1200" b="1" dirty="0">
+                <a:solidFill>
+                  <a:srgbClr val="7A859C"/>
+                </a:solidFill>
+                <a:latin typeface="HarmonyOS Sans SC" pitchFamily="34" charset="0"/>
+                <a:ea typeface="HarmonyOS Sans SC" pitchFamily="34" charset="-122"/>
+                <a:cs typeface="HarmonyOS Sans SC" pitchFamily="34" charset="-120"/>
+              </a:rPr>
+              <a:t>05 溯源</a:t>
+            </a:r>
+            <a:endParaRPr lang="zh-CN" sz="1200" dirty="0"/>
+          </a:p>
+        </p:txBody>
+      </p:sp>
+      <p:sp>
+        <p:nvSpPr>
+          <p:cNvPr id="4" name="Text 2"/>
+          <p:cNvSpPr/>
+          <p:nvPr/>
+        </p:nvSpPr>
+        <p:spPr>
+          <a:xfrm>
+            <a:off x="640080" y="786384"/>
+            <a:ext cx="10911535" cy="731520"/>
+          </a:xfrm>
+          <a:prstGeom prst="rect">
+            <a:avLst/>
+          </a:prstGeom>
+          <a:noFill/>
+          <a:ln/>
+        </p:spPr>
+        <p:txBody>
+          <a:bodyPr wrap="square" lIns="0" tIns="0" rIns="0" bIns="0" rtlCol="0" anchor="ctr"/>
+          <a:lstStyle/>
+          <a:p>
+            <a:pPr indent="0" marL="0">
+              <a:buNone/>
+            </a:pPr>
+            <a:r>
+              <a:rPr lang="zh-CN" altLang="en-US" sz="3000" b="1" dirty="0">
+                <a:solidFill>
+                  <a:srgbClr val="1B2340"/>
+                </a:solidFill>
+                <a:latin typeface="HarmonyOS Sans SC" pitchFamily="34" charset="0"/>
+                <a:ea typeface="HarmonyOS Sans SC" pitchFamily="34" charset="-122"/>
+                <a:cs typeface="HarmonyOS Sans SC" pitchFamily="34" charset="-120"/>
+              </a:rPr>
+              <a:t>68 个内核补丁，全部完成溯源</a:t>
+            </a:r>
+            <a:endParaRPr lang="zh-CN" sz="3000" dirty="0"/>
+          </a:p>
+        </p:txBody>
+      </p:sp>
+      <p:sp>
+        <p:nvSpPr>
+          <p:cNvPr id="5" name="Text 3"/>
+          <p:cNvSpPr/>
+          <p:nvPr/>
+        </p:nvSpPr>
+        <p:spPr>
+          <a:xfrm>
+            <a:off x="11002975" y="6400800"/>
+            <a:ext cx="548640" cy="274320"/>
+          </a:xfrm>
+          <a:prstGeom prst="rect">
+            <a:avLst/>
+          </a:prstGeom>
+          <a:noFill/>
+          <a:ln/>
+        </p:spPr>
+        <p:txBody>
+          <a:bodyPr wrap="square" lIns="0" tIns="0" rIns="0" bIns="0" rtlCol="0" anchor="ctr"/>
+          <a:lstStyle/>
+          <a:p>
+            <a:pPr algn="r" indent="0" marL="0">
+              <a:buNone/>
+            </a:pPr>
+            <a:r>
+              <a:rPr lang="zh-CN" altLang="en-US" sz="1000" dirty="0">
+                <a:solidFill>
+                  <a:srgbClr val="7A859C"/>
+                </a:solidFill>
+                <a:latin typeface="JetBrains Mono" pitchFamily="34" charset="0"/>
+                <a:ea typeface="JetBrains Mono" pitchFamily="34" charset="-122"/>
+                <a:cs typeface="JetBrains Mono" pitchFamily="34" charset="-120"/>
+              </a:rPr>
+              <a:t>33</a:t>
+            </a:r>
+            <a:endParaRPr lang="zh-CN" sz="1000" dirty="0"/>
+          </a:p>
+        </p:txBody>
+      </p:sp>
+      <p:sp>
+        <p:nvSpPr>
+          <p:cNvPr id="6" name="Shape 4"/>
+          <p:cNvSpPr/>
+          <p:nvPr/>
+        </p:nvSpPr>
+        <p:spPr>
+          <a:xfrm>
+            <a:off x="640080" y="1783080"/>
+            <a:ext cx="2556434" cy="1463040"/>
+          </a:xfrm>
+          <a:prstGeom prst="roundRect">
+            <a:avLst>
+              <a:gd name="adj" fmla="val 7500"/>
+            </a:avLst>
+          </a:prstGeom>
+          <a:solidFill>
+            <a:srgbClr val="F3F5FA"/>
+          </a:solidFill>
+          <a:ln w="12700">
+            <a:solidFill>
+              <a:srgbClr val="F3F5FA"/>
+            </a:solidFill>
+            <a:prstDash val="solid"/>
+          </a:ln>
+        </p:spPr>
+      </p:sp>
+      <p:sp>
+        <p:nvSpPr>
+          <p:cNvPr id="7" name="Text 5"/>
+          <p:cNvSpPr/>
+          <p:nvPr/>
+        </p:nvSpPr>
+        <p:spPr>
+          <a:xfrm>
+            <a:off x="822960" y="1911096"/>
+            <a:ext cx="2190674" cy="274320"/>
+          </a:xfrm>
+          <a:prstGeom prst="rect">
+            <a:avLst/>
+          </a:prstGeom>
+          <a:noFill/>
+          <a:ln/>
+        </p:spPr>
+        <p:txBody>
+          <a:bodyPr wrap="square" lIns="0" tIns="0" rIns="0" bIns="0" rtlCol="0" anchor="ctr"/>
+          <a:lstStyle/>
+          <a:p>
+            <a:pPr indent="0" marL="0">
+              <a:buNone/>
+            </a:pPr>
+            <a:r>
+              <a:rPr lang="zh-CN" altLang="en-US" sz="1200" b="1" dirty="0">
+                <a:solidFill>
+                  <a:srgbClr val="7A859C"/>
+                </a:solidFill>
+                <a:latin typeface="HarmonyOS Sans SC" pitchFamily="34" charset="0"/>
+                <a:ea typeface="HarmonyOS Sans SC" pitchFamily="34" charset="-122"/>
+                <a:cs typeface="HarmonyOS Sans SC" pitchFamily="34" charset="-120"/>
+              </a:rPr>
+              <a:t>溯源文件</a:t>
+            </a:r>
+            <a:endParaRPr lang="zh-CN" sz="1200" dirty="0"/>
+          </a:p>
+        </p:txBody>
+      </p:sp>
+      <p:sp>
+        <p:nvSpPr>
+          <p:cNvPr id="8" name="Text 6"/>
+          <p:cNvSpPr/>
+          <p:nvPr/>
+        </p:nvSpPr>
+        <p:spPr>
+          <a:xfrm>
+            <a:off x="822960" y="2203704"/>
+            <a:ext cx="2190674" cy="603504"/>
+          </a:xfrm>
+          <a:prstGeom prst="rect">
+            <a:avLst/>
+          </a:prstGeom>
+          <a:noFill/>
+          <a:ln/>
+        </p:spPr>
+        <p:txBody>
+          <a:bodyPr wrap="square" lIns="0" tIns="0" rIns="0" bIns="0" rtlCol="0" anchor="ctr"/>
+          <a:lstStyle/>
+          <a:p>
+            <a:pPr indent="0" marL="0">
+              <a:buNone/>
+            </a:pPr>
+            <a:r>
+              <a:rPr lang="zh-CN" altLang="en-US" sz="3000" b="1" dirty="0">
+                <a:solidFill>
+                  <a:srgbClr val="1FA896"/>
+                </a:solidFill>
+                <a:latin typeface="JetBrains Mono" pitchFamily="34" charset="0"/>
+                <a:ea typeface="JetBrains Mono" pitchFamily="34" charset="-122"/>
+                <a:cs typeface="JetBrains Mono" pitchFamily="34" charset="-120"/>
+              </a:rPr>
+              <a:t>68</a:t>
+            </a:r>
+            <a:endParaRPr lang="zh-CN" sz="3000" dirty="0"/>
+          </a:p>
+        </p:txBody>
+      </p:sp>
+      <p:sp>
+        <p:nvSpPr>
+          <p:cNvPr id="9" name="Text 7"/>
+          <p:cNvSpPr/>
+          <p:nvPr/>
+        </p:nvSpPr>
+        <p:spPr>
+          <a:xfrm>
+            <a:off x="822960" y="2825496"/>
+            <a:ext cx="2190674" cy="274320"/>
+          </a:xfrm>
+          <a:prstGeom prst="rect">
+            <a:avLst/>
+          </a:prstGeom>
+          <a:noFill/>
+          <a:ln/>
+        </p:spPr>
+        <p:txBody>
+          <a:bodyPr wrap="square" lIns="0" tIns="0" rIns="0" bIns="0" rtlCol="0" anchor="ctr"/>
+          <a:lstStyle/>
+          <a:p>
+            <a:pPr indent="0" marL="0">
+              <a:buNone/>
+            </a:pPr>
+            <a:r>
+              <a:rPr lang="zh-CN" altLang="en-US" sz="1200" dirty="0">
+                <a:solidFill>
+                  <a:srgbClr val="7A859C"/>
+                </a:solidFill>
+                <a:latin typeface="HarmonyOS Sans SC" pitchFamily="34" charset="0"/>
+                <a:ea typeface="HarmonyOS Sans SC" pitchFamily="34" charset="-122"/>
+                <a:cs typeface="HarmonyOS Sans SC" pitchFamily="34" charset="-120"/>
+              </a:rPr>
+              <a:t>已合入 65，审查中 3</a:t>
+            </a:r>
+            <a:endParaRPr lang="zh-CN" sz="1200" dirty="0"/>
+          </a:p>
+        </p:txBody>
+      </p:sp>
+      <p:sp>
+        <p:nvSpPr>
+          <p:cNvPr id="10" name="Shape 8"/>
+          <p:cNvSpPr/>
+          <p:nvPr/>
+        </p:nvSpPr>
+        <p:spPr>
+          <a:xfrm>
+            <a:off x="3425114" y="1783080"/>
+            <a:ext cx="2556434" cy="1463040"/>
+          </a:xfrm>
+          <a:prstGeom prst="roundRect">
+            <a:avLst>
+              <a:gd name="adj" fmla="val 7500"/>
+            </a:avLst>
+          </a:prstGeom>
+          <a:solidFill>
+            <a:srgbClr val="F3F5FA"/>
+          </a:solidFill>
+          <a:ln w="12700">
+            <a:solidFill>
+              <a:srgbClr val="F3F5FA"/>
+            </a:solidFill>
+            <a:prstDash val="solid"/>
+          </a:ln>
+        </p:spPr>
+      </p:sp>
+      <p:sp>
+        <p:nvSpPr>
+          <p:cNvPr id="11" name="Text 9"/>
+          <p:cNvSpPr/>
+          <p:nvPr/>
+        </p:nvSpPr>
+        <p:spPr>
+          <a:xfrm>
+            <a:off x="3607994" y="1911096"/>
+            <a:ext cx="2190674" cy="274320"/>
+          </a:xfrm>
+          <a:prstGeom prst="rect">
+            <a:avLst/>
+          </a:prstGeom>
+          <a:noFill/>
+          <a:ln/>
+        </p:spPr>
+        <p:txBody>
+          <a:bodyPr wrap="square" lIns="0" tIns="0" rIns="0" bIns="0" rtlCol="0" anchor="ctr"/>
+          <a:lstStyle/>
+          <a:p>
+            <a:pPr indent="0" marL="0">
+              <a:buNone/>
+            </a:pPr>
+            <a:r>
+              <a:rPr lang="zh-CN" altLang="en-US" sz="1200" b="1" dirty="0">
+                <a:solidFill>
+                  <a:srgbClr val="7A859C"/>
+                </a:solidFill>
+                <a:latin typeface="HarmonyOS Sans SC" pitchFamily="34" charset="0"/>
+                <a:ea typeface="HarmonyOS Sans SC" pitchFamily="34" charset="-122"/>
+                <a:cs typeface="HarmonyOS Sans SC" pitchFamily="34" charset="-120"/>
+              </a:rPr>
+              <a:t>Linux 源码链接</a:t>
+            </a:r>
+            <a:endParaRPr lang="zh-CN" sz="1200" dirty="0"/>
+          </a:p>
+        </p:txBody>
+      </p:sp>
+      <p:sp>
+        <p:nvSpPr>
+          <p:cNvPr id="12" name="Text 10"/>
+          <p:cNvSpPr/>
+          <p:nvPr/>
+        </p:nvSpPr>
+        <p:spPr>
+          <a:xfrm>
+            <a:off x="3607994" y="2203704"/>
+            <a:ext cx="2190674" cy="603504"/>
+          </a:xfrm>
+          <a:prstGeom prst="rect">
+            <a:avLst/>
+          </a:prstGeom>
+          <a:noFill/>
+          <a:ln/>
+        </p:spPr>
+        <p:txBody>
+          <a:bodyPr wrap="square" lIns="0" tIns="0" rIns="0" bIns="0" rtlCol="0" anchor="ctr"/>
+          <a:lstStyle/>
+          <a:p>
+            <a:pPr indent="0" marL="0">
+              <a:buNone/>
+            </a:pPr>
+            <a:r>
+              <a:rPr lang="zh-CN" altLang="en-US" sz="3000" b="1" dirty="0">
+                <a:solidFill>
+                  <a:srgbClr val="1B2340"/>
+                </a:solidFill>
+                <a:latin typeface="JetBrains Mono" pitchFamily="34" charset="0"/>
+                <a:ea typeface="JetBrains Mono" pitchFamily="34" charset="-122"/>
+                <a:cs typeface="JetBrains Mono" pitchFamily="34" charset="-120"/>
+              </a:rPr>
+              <a:t>746</a:t>
+            </a:r>
+            <a:endParaRPr lang="zh-CN" sz="3000" dirty="0"/>
+          </a:p>
+        </p:txBody>
+      </p:sp>
+      <p:sp>
+        <p:nvSpPr>
+          <p:cNvPr id="13" name="Text 11"/>
+          <p:cNvSpPr/>
+          <p:nvPr/>
+        </p:nvSpPr>
+        <p:spPr>
+          <a:xfrm>
+            <a:off x="3607994" y="2825496"/>
+            <a:ext cx="2190674" cy="274320"/>
+          </a:xfrm>
+          <a:prstGeom prst="rect">
+            <a:avLst/>
+          </a:prstGeom>
+          <a:noFill/>
+          <a:ln/>
+        </p:spPr>
+        <p:txBody>
+          <a:bodyPr wrap="square" lIns="0" tIns="0" rIns="0" bIns="0" rtlCol="0" anchor="ctr"/>
+          <a:lstStyle/>
+          <a:p>
+            <a:pPr indent="0" marL="0">
+              <a:buNone/>
+            </a:pPr>
+            <a:r>
+              <a:rPr lang="zh-CN" altLang="en-US" sz="1200" dirty="0">
+                <a:solidFill>
+                  <a:srgbClr val="7A859C"/>
+                </a:solidFill>
+                <a:latin typeface="HarmonyOS Sans SC" pitchFamily="34" charset="0"/>
+                <a:ea typeface="HarmonyOS Sans SC" pitchFamily="34" charset="-122"/>
+                <a:cs typeface="HarmonyOS Sans SC" pitchFamily="34" charset="-120"/>
+              </a:rPr>
+              <a:t>固定到同一提交的具体行</a:t>
+            </a:r>
+            <a:endParaRPr lang="zh-CN" sz="1200" dirty="0"/>
+          </a:p>
+        </p:txBody>
+      </p:sp>
+      <p:sp>
+        <p:nvSpPr>
+          <p:cNvPr id="14" name="Shape 12"/>
+          <p:cNvSpPr/>
+          <p:nvPr/>
+        </p:nvSpPr>
+        <p:spPr>
+          <a:xfrm>
+            <a:off x="6210148" y="1783080"/>
+            <a:ext cx="2556434" cy="1463040"/>
+          </a:xfrm>
+          <a:prstGeom prst="roundRect">
+            <a:avLst>
+              <a:gd name="adj" fmla="val 7500"/>
+            </a:avLst>
+          </a:prstGeom>
+          <a:solidFill>
+            <a:srgbClr val="F3F5FA"/>
+          </a:solidFill>
+          <a:ln w="12700">
+            <a:solidFill>
+              <a:srgbClr val="F3F5FA"/>
+            </a:solidFill>
+            <a:prstDash val="solid"/>
+          </a:ln>
+        </p:spPr>
+      </p:sp>
+      <p:sp>
+        <p:nvSpPr>
+          <p:cNvPr id="15" name="Text 13"/>
+          <p:cNvSpPr/>
+          <p:nvPr/>
+        </p:nvSpPr>
+        <p:spPr>
+          <a:xfrm>
+            <a:off x="6393028" y="1911096"/>
+            <a:ext cx="2190674" cy="274320"/>
+          </a:xfrm>
+          <a:prstGeom prst="rect">
+            <a:avLst/>
+          </a:prstGeom>
+          <a:noFill/>
+          <a:ln/>
+        </p:spPr>
+        <p:txBody>
+          <a:bodyPr wrap="square" lIns="0" tIns="0" rIns="0" bIns="0" rtlCol="0" anchor="ctr"/>
+          <a:lstStyle/>
+          <a:p>
+            <a:pPr indent="0" marL="0">
+              <a:buNone/>
+            </a:pPr>
+            <a:r>
+              <a:rPr lang="zh-CN" altLang="en-US" sz="1200" b="1" dirty="0">
+                <a:solidFill>
+                  <a:srgbClr val="7A859C"/>
+                </a:solidFill>
+                <a:latin typeface="HarmonyOS Sans SC" pitchFamily="34" charset="0"/>
+                <a:ea typeface="HarmonyOS Sans SC" pitchFamily="34" charset="-122"/>
+                <a:cs typeface="HarmonyOS Sans SC" pitchFamily="34" charset="-120"/>
+              </a:rPr>
+              <a:t>man 引文</a:t>
+            </a:r>
+            <a:endParaRPr lang="zh-CN" sz="1200" dirty="0"/>
+          </a:p>
+        </p:txBody>
+      </p:sp>
+      <p:sp>
+        <p:nvSpPr>
+          <p:cNvPr id="16" name="Text 14"/>
+          <p:cNvSpPr/>
+          <p:nvPr/>
+        </p:nvSpPr>
+        <p:spPr>
+          <a:xfrm>
+            <a:off x="6393028" y="2203704"/>
+            <a:ext cx="2190674" cy="603504"/>
+          </a:xfrm>
+          <a:prstGeom prst="rect">
+            <a:avLst/>
+          </a:prstGeom>
+          <a:noFill/>
+          <a:ln/>
+        </p:spPr>
+        <p:txBody>
+          <a:bodyPr wrap="square" lIns="0" tIns="0" rIns="0" bIns="0" rtlCol="0" anchor="ctr"/>
+          <a:lstStyle/>
+          <a:p>
+            <a:pPr indent="0" marL="0">
+              <a:buNone/>
+            </a:pPr>
+            <a:r>
+              <a:rPr lang="zh-CN" altLang="en-US" sz="3000" b="1" dirty="0">
+                <a:solidFill>
+                  <a:srgbClr val="1B2340"/>
+                </a:solidFill>
+                <a:latin typeface="JetBrains Mono" pitchFamily="34" charset="0"/>
+                <a:ea typeface="JetBrains Mono" pitchFamily="34" charset="-122"/>
+                <a:cs typeface="JetBrains Mono" pitchFamily="34" charset="-120"/>
+              </a:rPr>
+              <a:t>207</a:t>
+            </a:r>
+            <a:endParaRPr lang="zh-CN" sz="3000" dirty="0"/>
+          </a:p>
+        </p:txBody>
+      </p:sp>
+      <p:sp>
+        <p:nvSpPr>
+          <p:cNvPr id="17" name="Text 15"/>
+          <p:cNvSpPr/>
+          <p:nvPr/>
+        </p:nvSpPr>
+        <p:spPr>
+          <a:xfrm>
+            <a:off x="6393028" y="2825496"/>
+            <a:ext cx="2190674" cy="274320"/>
+          </a:xfrm>
+          <a:prstGeom prst="rect">
+            <a:avLst/>
+          </a:prstGeom>
+          <a:noFill/>
+          <a:ln/>
+        </p:spPr>
+        <p:txBody>
+          <a:bodyPr wrap="square" lIns="0" tIns="0" rIns="0" bIns="0" rtlCol="0" anchor="ctr"/>
+          <a:lstStyle/>
+          <a:p>
+            <a:pPr indent="0" marL="0">
+              <a:buNone/>
+            </a:pPr>
+            <a:r>
+              <a:rPr lang="zh-CN" altLang="en-US" sz="1200" dirty="0">
+                <a:solidFill>
+                  <a:srgbClr val="7A859C"/>
+                </a:solidFill>
+                <a:latin typeface="HarmonyOS Sans SC" pitchFamily="34" charset="0"/>
+                <a:ea typeface="HarmonyOS Sans SC" pitchFamily="34" charset="-122"/>
+                <a:cs typeface="HarmonyOS Sans SC" pitchFamily="34" charset="-120"/>
+              </a:rPr>
+              <a:t>与 6.19 版原文逐字相同</a:t>
+            </a:r>
+            <a:endParaRPr lang="zh-CN" sz="1200" dirty="0"/>
+          </a:p>
+        </p:txBody>
+      </p:sp>
+      <p:sp>
+        <p:nvSpPr>
+          <p:cNvPr id="18" name="Shape 16"/>
+          <p:cNvSpPr/>
+          <p:nvPr/>
+        </p:nvSpPr>
+        <p:spPr>
+          <a:xfrm>
+            <a:off x="8995181" y="1783080"/>
+            <a:ext cx="2556434" cy="1463040"/>
+          </a:xfrm>
+          <a:prstGeom prst="roundRect">
+            <a:avLst>
+              <a:gd name="adj" fmla="val 7500"/>
+            </a:avLst>
+          </a:prstGeom>
+          <a:solidFill>
+            <a:srgbClr val="F3F5FA"/>
+          </a:solidFill>
+          <a:ln w="12700">
+            <a:solidFill>
+              <a:srgbClr val="F3F5FA"/>
+            </a:solidFill>
+            <a:prstDash val="solid"/>
+          </a:ln>
+        </p:spPr>
+      </p:sp>
+      <p:sp>
+        <p:nvSpPr>
+          <p:cNvPr id="19" name="Text 17"/>
+          <p:cNvSpPr/>
+          <p:nvPr/>
+        </p:nvSpPr>
+        <p:spPr>
+          <a:xfrm>
+            <a:off x="9178061" y="1911096"/>
+            <a:ext cx="2190674" cy="274320"/>
+          </a:xfrm>
+          <a:prstGeom prst="rect">
+            <a:avLst/>
+          </a:prstGeom>
+          <a:noFill/>
+          <a:ln/>
+        </p:spPr>
+        <p:txBody>
+          <a:bodyPr wrap="square" lIns="0" tIns="0" rIns="0" bIns="0" rtlCol="0" anchor="ctr"/>
+          <a:lstStyle/>
+          <a:p>
+            <a:pPr indent="0" marL="0">
+              <a:buNone/>
+            </a:pPr>
+            <a:r>
+              <a:rPr lang="zh-CN" altLang="en-US" sz="1200" b="1" dirty="0">
+                <a:solidFill>
+                  <a:srgbClr val="7A859C"/>
+                </a:solidFill>
+                <a:latin typeface="HarmonyOS Sans SC" pitchFamily="34" charset="0"/>
+                <a:ea typeface="HarmonyOS Sans SC" pitchFamily="34" charset="-122"/>
+                <a:cs typeface="HarmonyOS Sans SC" pitchFamily="34" charset="-120"/>
+              </a:rPr>
+              <a:t>带复核发现</a:t>
+            </a:r>
+            <a:endParaRPr lang="zh-CN" sz="1200" dirty="0"/>
+          </a:p>
+        </p:txBody>
+      </p:sp>
+      <p:sp>
+        <p:nvSpPr>
+          <p:cNvPr id="20" name="Text 18"/>
+          <p:cNvSpPr/>
+          <p:nvPr/>
+        </p:nvSpPr>
+        <p:spPr>
+          <a:xfrm>
+            <a:off x="9178061" y="2203704"/>
+            <a:ext cx="2190674" cy="603504"/>
+          </a:xfrm>
+          <a:prstGeom prst="rect">
+            <a:avLst/>
+          </a:prstGeom>
+          <a:noFill/>
+          <a:ln/>
+        </p:spPr>
+        <p:txBody>
+          <a:bodyPr wrap="square" lIns="0" tIns="0" rIns="0" bIns="0" rtlCol="0" anchor="ctr"/>
+          <a:lstStyle/>
+          <a:p>
+            <a:pPr indent="0" marL="0">
+              <a:buNone/>
+            </a:pPr>
+            <a:r>
+              <a:rPr lang="zh-CN" altLang="en-US" sz="3000" b="1" dirty="0">
+                <a:solidFill>
+                  <a:srgbClr val="E2604F"/>
+                </a:solidFill>
+                <a:latin typeface="JetBrains Mono" pitchFamily="34" charset="0"/>
+                <a:ea typeface="JetBrains Mono" pitchFamily="34" charset="-122"/>
+                <a:cs typeface="JetBrains Mono" pitchFamily="34" charset="-120"/>
+              </a:rPr>
+              <a:t>51</a:t>
+            </a:r>
+            <a:endParaRPr lang="zh-CN" sz="3000" dirty="0"/>
+          </a:p>
+        </p:txBody>
+      </p:sp>
+      <p:sp>
+        <p:nvSpPr>
+          <p:cNvPr id="21" name="Text 19"/>
+          <p:cNvSpPr/>
+          <p:nvPr/>
+        </p:nvSpPr>
+        <p:spPr>
+          <a:xfrm>
+            <a:off x="9178061" y="2825496"/>
+            <a:ext cx="2190674" cy="274320"/>
+          </a:xfrm>
+          <a:prstGeom prst="rect">
+            <a:avLst/>
+          </a:prstGeom>
+          <a:noFill/>
+          <a:ln/>
+        </p:spPr>
+        <p:txBody>
+          <a:bodyPr wrap="square" lIns="0" tIns="0" rIns="0" bIns="0" rtlCol="0" anchor="ctr"/>
+          <a:lstStyle/>
+          <a:p>
+            <a:pPr indent="0" marL="0">
+              <a:buNone/>
+            </a:pPr>
+            <a:r>
+              <a:rPr lang="zh-CN" altLang="en-US" sz="1200" dirty="0">
+                <a:solidFill>
+                  <a:srgbClr val="7A859C"/>
+                </a:solidFill>
+                <a:latin typeface="HarmonyOS Sans SC" pitchFamily="34" charset="0"/>
+                <a:ea typeface="HarmonyOS Sans SC" pitchFamily="34" charset="-122"/>
+                <a:cs typeface="HarmonyOS Sans SC" pitchFamily="34" charset="-120"/>
+              </a:rPr>
+              <a:t>份</a:t>
+            </a:r>
+            <a:endParaRPr lang="zh-CN" sz="1200" dirty="0"/>
+          </a:p>
+        </p:txBody>
+      </p:sp>
+      <p:sp>
+        <p:nvSpPr>
+          <p:cNvPr id="22" name="Shape 20"/>
+          <p:cNvSpPr/>
+          <p:nvPr/>
+        </p:nvSpPr>
+        <p:spPr>
+          <a:xfrm>
+            <a:off x="640080" y="3520440"/>
+            <a:ext cx="5272888" cy="2240280"/>
+          </a:xfrm>
+          <a:prstGeom prst="roundRect">
+            <a:avLst>
+              <a:gd name="adj" fmla="val 4898"/>
+            </a:avLst>
+          </a:prstGeom>
+          <a:solidFill>
+            <a:srgbClr val="F3F5FA"/>
+          </a:solidFill>
+          <a:ln w="12700">
+            <a:solidFill>
+              <a:srgbClr val="F3F5FA"/>
+            </a:solidFill>
+            <a:prstDash val="solid"/>
+          </a:ln>
+        </p:spPr>
+      </p:sp>
+      <p:sp>
+        <p:nvSpPr>
+          <p:cNvPr id="23" name="Shape 21"/>
+          <p:cNvSpPr/>
+          <p:nvPr/>
+        </p:nvSpPr>
+        <p:spPr>
+          <a:xfrm>
+            <a:off x="868680" y="3703320"/>
+            <a:ext cx="1591056" cy="310896"/>
+          </a:xfrm>
+          <a:prstGeom prst="roundRect">
+            <a:avLst>
+              <a:gd name="adj" fmla="val 23529"/>
+            </a:avLst>
+          </a:prstGeom>
+          <a:solidFill>
+            <a:srgbClr val="0B1437"/>
+          </a:solidFill>
+          <a:ln w="12700">
+            <a:solidFill>
+              <a:srgbClr val="0B1437"/>
+            </a:solidFill>
+            <a:prstDash val="solid"/>
+          </a:ln>
+        </p:spPr>
+      </p:sp>
+      <p:sp>
+        <p:nvSpPr>
+          <p:cNvPr id="24" name="Text 22"/>
+          <p:cNvSpPr/>
+          <p:nvPr/>
+        </p:nvSpPr>
+        <p:spPr>
+          <a:xfrm>
+            <a:off x="868680" y="3703320"/>
+            <a:ext cx="1591056" cy="310896"/>
+          </a:xfrm>
+          <a:prstGeom prst="rect">
+            <a:avLst/>
+          </a:prstGeom>
+          <a:noFill/>
+          <a:ln/>
+        </p:spPr>
+        <p:txBody>
+          <a:bodyPr wrap="square" lIns="0" tIns="0" rIns="0" bIns="0" rtlCol="0" anchor="ctr"/>
+          <a:lstStyle/>
+          <a:p>
+            <a:pPr algn="ctr" indent="0" marL="0">
+              <a:buNone/>
+            </a:pPr>
+            <a:r>
+              <a:rPr lang="zh-CN" altLang="en-US" sz="1200" b="1" dirty="0">
+                <a:solidFill>
+                  <a:srgbClr val="FFFFFF"/>
+                </a:solidFill>
+                <a:latin typeface="HarmonyOS Sans SC" pitchFamily="34" charset="0"/>
+                <a:ea typeface="HarmonyOS Sans SC" pitchFamily="34" charset="-122"/>
+                <a:cs typeface="HarmonyOS Sans SC" pitchFamily="34" charset="-120"/>
+              </a:rPr>
+              <a:t>每份文件写什么</a:t>
+            </a:r>
+            <a:endParaRPr lang="zh-CN" sz="1200" dirty="0"/>
+          </a:p>
+        </p:txBody>
+      </p:sp>
+      <p:sp>
+        <p:nvSpPr>
+          <p:cNvPr id="25" name="Text 23"/>
+          <p:cNvSpPr/>
+          <p:nvPr/>
+        </p:nvSpPr>
+        <p:spPr>
+          <a:xfrm>
+            <a:off x="868680" y="4178808"/>
+            <a:ext cx="4815688" cy="1463040"/>
+          </a:xfrm>
+          <a:prstGeom prst="rect">
+            <a:avLst/>
+          </a:prstGeom>
+          <a:noFill/>
+          <a:ln/>
+        </p:spPr>
+        <p:txBody>
+          <a:bodyPr wrap="square" lIns="0" tIns="0" rIns="0" bIns="0" rtlCol="0" anchor="t"/>
+          <a:lstStyle/>
+          <a:p>
+            <a:pPr marL="177800" indent="-177800">
+              <a:spcAft>
+                <a:spcPts val="700"/>
+              </a:spcAft>
+              <a:buSzPct val="100000"/>
+              <a:buChar char="•"/>
+            </a:pPr>
+            <a:r>
+              <a:rPr lang="zh-CN" altLang="en-US" sz="1500" dirty="0">
+                <a:solidFill>
+                  <a:srgbClr val="1B2340"/>
+                </a:solidFill>
+                <a:latin typeface="HarmonyOS Sans SC" pitchFamily="34" charset="0"/>
+                <a:ea typeface="HarmonyOS Sans SC" pitchFamily="34" charset="-122"/>
+                <a:cs typeface="HarmonyOS Sans SC" pitchFamily="34" charset="-120"/>
+              </a:rPr>
+              <a:t>问题与原因；改动与影响范围</a:t>
+            </a:r>
+            <a:endParaRPr lang="zh-CN" sz="1500" dirty="0"/>
+          </a:p>
+          <a:p>
+            <a:pPr marL="177800" indent="-177800">
+              <a:spcAft>
+                <a:spcPts val="700"/>
+              </a:spcAft>
+              <a:buSzPct val="100000"/>
+              <a:buChar char="•"/>
+            </a:pPr>
+            <a:r>
+              <a:rPr lang="zh-CN" altLang="en-US" sz="1500" dirty="0">
+                <a:solidFill>
+                  <a:srgbClr val="1B2340"/>
+                </a:solidFill>
+                <a:latin typeface="HarmonyOS Sans SC" pitchFamily="34" charset="0"/>
+                <a:ea typeface="HarmonyOS Sans SC" pitchFamily="34" charset="-122"/>
+                <a:cs typeface="HarmonyOS Sans SC" pitchFamily="34" charset="-120"/>
+              </a:rPr>
+              <a:t>Linux 依据：函数与行；man 原文</a:t>
+            </a:r>
+            <a:endParaRPr lang="zh-CN" sz="1500" dirty="0"/>
+          </a:p>
+          <a:p>
+            <a:pPr marL="177800" indent="-177800">
+              <a:spcAft>
+                <a:spcPts val="700"/>
+              </a:spcAft>
+              <a:buSzPct val="100000"/>
+              <a:buChar char="•"/>
+            </a:pPr>
+            <a:r>
+              <a:rPr lang="zh-CN" altLang="en-US" sz="1500" dirty="0">
+                <a:solidFill>
+                  <a:srgbClr val="1B2340"/>
+                </a:solidFill>
+                <a:latin typeface="HarmonyOS Sans SC" pitchFamily="34" charset="0"/>
+                <a:ea typeface="HarmonyOS Sans SC" pitchFamily="34" charset="-122"/>
+                <a:cs typeface="HarmonyOS Sans SC" pitchFamily="34" charset="-120"/>
+              </a:rPr>
+              <a:t>这处改动在当前 dev 上还在不在、在哪</a:t>
+            </a:r>
+            <a:endParaRPr lang="zh-CN" sz="1500" dirty="0"/>
+          </a:p>
+          <a:p>
+            <a:pPr marL="177800" indent="-177800">
+              <a:spcAft>
+                <a:spcPts val="700"/>
+              </a:spcAft>
+              <a:buSzPct val="100000"/>
+              <a:buChar char="•"/>
+            </a:pPr>
+            <a:r>
+              <a:rPr lang="zh-CN" altLang="en-US" sz="1500" dirty="0">
+                <a:solidFill>
+                  <a:srgbClr val="1B2340"/>
+                </a:solidFill>
+                <a:latin typeface="HarmonyOS Sans SC" pitchFamily="34" charset="0"/>
+                <a:ea typeface="HarmonyOS Sans SC" pitchFamily="34" charset="-122"/>
+                <a:cs typeface="HarmonyOS Sans SC" pitchFamily="34" charset="-120"/>
+              </a:rPr>
+              <a:t>引用由脚本逐条核对，零错误</a:t>
+            </a:r>
+            <a:endParaRPr lang="zh-CN" sz="1500" dirty="0"/>
+          </a:p>
+        </p:txBody>
+      </p:sp>
+      <p:sp>
+        <p:nvSpPr>
+          <p:cNvPr id="26" name="Shape 24"/>
+          <p:cNvSpPr/>
+          <p:nvPr/>
+        </p:nvSpPr>
+        <p:spPr>
+          <a:xfrm>
+            <a:off x="6278728" y="3520440"/>
+            <a:ext cx="5272888" cy="2240280"/>
+          </a:xfrm>
+          <a:prstGeom prst="roundRect">
+            <a:avLst>
+              <a:gd name="adj" fmla="val 4898"/>
+            </a:avLst>
+          </a:prstGeom>
+          <a:solidFill>
+            <a:srgbClr val="FBE9C4"/>
+          </a:solidFill>
+          <a:ln w="12700">
+            <a:solidFill>
+              <a:srgbClr val="FBE9C4"/>
+            </a:solidFill>
+            <a:prstDash val="solid"/>
+          </a:ln>
+        </p:spPr>
+      </p:sp>
+      <p:sp>
+        <p:nvSpPr>
+          <p:cNvPr id="27" name="Shape 25"/>
+          <p:cNvSpPr/>
+          <p:nvPr/>
+        </p:nvSpPr>
+        <p:spPr>
+          <a:xfrm>
+            <a:off x="6507328" y="3703320"/>
+            <a:ext cx="1225296" cy="310896"/>
+          </a:xfrm>
+          <a:prstGeom prst="roundRect">
+            <a:avLst>
+              <a:gd name="adj" fmla="val 23529"/>
+            </a:avLst>
+          </a:prstGeom>
+          <a:solidFill>
+            <a:srgbClr val="E2604F"/>
+          </a:solidFill>
+          <a:ln w="12700">
+            <a:solidFill>
+              <a:srgbClr val="E2604F"/>
+            </a:solidFill>
+            <a:prstDash val="solid"/>
+          </a:ln>
+        </p:spPr>
+      </p:sp>
+      <p:sp>
+        <p:nvSpPr>
+          <p:cNvPr id="28" name="Text 26"/>
+          <p:cNvSpPr/>
+          <p:nvPr/>
+        </p:nvSpPr>
+        <p:spPr>
+          <a:xfrm>
+            <a:off x="6507328" y="3703320"/>
+            <a:ext cx="1225296" cy="310896"/>
+          </a:xfrm>
+          <a:prstGeom prst="rect">
+            <a:avLst/>
+          </a:prstGeom>
+          <a:noFill/>
+          <a:ln/>
+        </p:spPr>
+        <p:txBody>
+          <a:bodyPr wrap="square" lIns="0" tIns="0" rIns="0" bIns="0" rtlCol="0" anchor="ctr"/>
+          <a:lstStyle/>
+          <a:p>
+            <a:pPr algn="ctr" indent="0" marL="0">
+              <a:buNone/>
+            </a:pPr>
+            <a:r>
+              <a:rPr lang="zh-CN" altLang="en-US" sz="1200" b="1" dirty="0">
+                <a:solidFill>
+                  <a:srgbClr val="FFFFFF"/>
+                </a:solidFill>
+                <a:latin typeface="HarmonyOS Sans SC" pitchFamily="34" charset="0"/>
+                <a:ea typeface="HarmonyOS Sans SC" pitchFamily="34" charset="-122"/>
+                <a:cs typeface="HarmonyOS Sans SC" pitchFamily="34" charset="-120"/>
+              </a:rPr>
+              <a:t>发现分四类</a:t>
+            </a:r>
+            <a:endParaRPr lang="zh-CN" sz="1200" dirty="0"/>
+          </a:p>
+        </p:txBody>
+      </p:sp>
+      <p:sp>
+        <p:nvSpPr>
+          <p:cNvPr id="29" name="Text 27"/>
+          <p:cNvSpPr/>
+          <p:nvPr/>
+        </p:nvSpPr>
+        <p:spPr>
+          <a:xfrm>
+            <a:off x="6507328" y="4178808"/>
+            <a:ext cx="4815688" cy="1463040"/>
+          </a:xfrm>
+          <a:prstGeom prst="rect">
+            <a:avLst/>
+          </a:prstGeom>
+          <a:noFill/>
+          <a:ln/>
+        </p:spPr>
+        <p:txBody>
+          <a:bodyPr wrap="square" lIns="0" tIns="0" rIns="0" bIns="0" rtlCol="0" anchor="t"/>
+          <a:lstStyle/>
+          <a:p>
+            <a:pPr marL="177800" indent="-177800">
+              <a:spcAft>
+                <a:spcPts val="700"/>
+              </a:spcAft>
+              <a:buSzPct val="100000"/>
+              <a:buChar char="•"/>
+            </a:pPr>
+            <a:r>
+              <a:rPr lang="zh-CN" altLang="en-US" sz="1500" dirty="0">
+                <a:solidFill>
+                  <a:srgbClr val="1B2340"/>
+                </a:solidFill>
+                <a:latin typeface="HarmonyOS Sans SC" pitchFamily="34" charset="0"/>
+                <a:ea typeface="HarmonyOS Sans SC" pitchFamily="34" charset="-122"/>
+                <a:cs typeface="HarmonyOS Sans SC" pitchFamily="34" charset="-120"/>
+              </a:rPr>
+              <a:t>补丁的行为与 Linux 仍有出入</a:t>
+            </a:r>
+            <a:endParaRPr lang="zh-CN" sz="1500" dirty="0"/>
+          </a:p>
+          <a:p>
+            <a:pPr marL="177800" indent="-177800">
+              <a:spcAft>
+                <a:spcPts val="700"/>
+              </a:spcAft>
+              <a:buSzPct val="100000"/>
+              <a:buChar char="•"/>
+            </a:pPr>
+            <a:r>
+              <a:rPr lang="zh-CN" altLang="en-US" sz="1500" dirty="0">
+                <a:solidFill>
+                  <a:srgbClr val="1B2340"/>
+                </a:solidFill>
+                <a:latin typeface="HarmonyOS Sans SC" pitchFamily="34" charset="0"/>
+                <a:ea typeface="HarmonyOS Sans SC" pitchFamily="34" charset="-122"/>
+                <a:cs typeface="HarmonyOS Sans SC" pitchFamily="34" charset="-120"/>
+              </a:rPr>
+              <a:t>正文与合入的 diff 不符</a:t>
+            </a:r>
+            <a:endParaRPr lang="zh-CN" sz="1500" dirty="0"/>
+          </a:p>
+          <a:p>
+            <a:pPr marL="177800" indent="-177800">
+              <a:spcAft>
+                <a:spcPts val="700"/>
+              </a:spcAft>
+              <a:buSzPct val="100000"/>
+              <a:buChar char="•"/>
+            </a:pPr>
+            <a:r>
+              <a:rPr lang="zh-CN" altLang="en-US" sz="1500" dirty="0">
+                <a:solidFill>
+                  <a:srgbClr val="1B2340"/>
+                </a:solidFill>
+                <a:latin typeface="HarmonyOS Sans SC" pitchFamily="34" charset="0"/>
+                <a:ea typeface="HarmonyOS Sans SC" pitchFamily="34" charset="-122"/>
+                <a:cs typeface="HarmonyOS Sans SC" pitchFamily="34" charset="-120"/>
+              </a:rPr>
+              <a:t>回归用例拦不住回归</a:t>
+            </a:r>
+            <a:endParaRPr lang="zh-CN" sz="1500" dirty="0"/>
+          </a:p>
+          <a:p>
+            <a:pPr marL="177800" indent="-177800">
+              <a:spcAft>
+                <a:spcPts val="700"/>
+              </a:spcAft>
+              <a:buSzPct val="100000"/>
+              <a:buChar char="•"/>
+            </a:pPr>
+            <a:r>
+              <a:rPr lang="zh-CN" altLang="en-US" sz="1500" dirty="0">
+                <a:solidFill>
+                  <a:srgbClr val="1B2340"/>
+                </a:solidFill>
+                <a:latin typeface="HarmonyOS Sans SC" pitchFamily="34" charset="0"/>
+                <a:ea typeface="HarmonyOS Sans SC" pitchFamily="34" charset="-122"/>
+                <a:cs typeface="HarmonyOS Sans SC" pitchFamily="34" charset="-120"/>
+              </a:rPr>
+              <a:t>改动已被后续提交取代</a:t>
+            </a:r>
+            <a:endParaRPr lang="zh-CN" sz="1500" dirty="0"/>
+          </a:p>
+        </p:txBody>
+      </p:sp>
+    </p:spTree>
+  </p:cSld>
+  <p:clrMapOvr>
+    <a:masterClrMapping/>
+  </p:clrMapOvr>
+</p:sld>
+</file>
+
+<file path=ppt/slides/slide34.xml><?xml version="1.0" encoding="utf-8"?>
+<p:sld xmlns:a="http://schemas.openxmlformats.org/drawingml/2006/main" xmlns:r="http://schemas.openxmlformats.org/officeDocument/2006/relationships" xmlns:p="http://schemas.openxmlformats.org/presentationml/2006/main">
+  <p:cSld name="Slide 34">
+    <p:bg>
+      <p:bgPr>
+        <a:solidFill>
+          <a:srgbClr val="FFFFFF"/>
+        </a:solidFill>
+      </p:bgPr>
+    </p:bg>
+    <p:spTree>
+      <p:nvGrpSpPr>
+        <p:cNvPr id="1" name=""/>
+        <p:cNvGrpSpPr/>
+        <p:nvPr/>
+      </p:nvGrpSpPr>
+      <p:grpSpPr>
+        <a:xfrm>
+          <a:off x="0" y="0"/>
+          <a:ext cx="0" cy="0"/>
+          <a:chOff x="0" y="0"/>
+          <a:chExt cx="0" cy="0"/>
+        </a:xfrm>
+      </p:grpSpPr>
+      <p:sp>
+        <p:nvSpPr>
+          <p:cNvPr id="2" name="Shape 0"/>
+          <p:cNvSpPr/>
+          <p:nvPr/>
+        </p:nvSpPr>
+        <p:spPr>
+          <a:xfrm>
+            <a:off x="640080" y="457200"/>
+            <a:ext cx="201168" cy="201168"/>
+          </a:xfrm>
+          <a:prstGeom prst="star4">
+            <a:avLst/>
+          </a:prstGeom>
+          <a:solidFill>
+            <a:srgbClr val="F2B441"/>
+          </a:solidFill>
+          <a:ln w="12700">
+            <a:solidFill>
+              <a:srgbClr val="F2B441"/>
+            </a:solidFill>
+            <a:prstDash val="solid"/>
+          </a:ln>
+        </p:spPr>
+      </p:sp>
+      <p:sp>
+        <p:nvSpPr>
+          <p:cNvPr id="3" name="Text 1"/>
+          <p:cNvSpPr/>
+          <p:nvPr/>
+        </p:nvSpPr>
+        <p:spPr>
+          <a:xfrm>
+            <a:off x="932688" y="402336"/>
+            <a:ext cx="7315200" cy="310896"/>
+          </a:xfrm>
+          <a:prstGeom prst="rect">
+            <a:avLst/>
+          </a:prstGeom>
+          <a:noFill/>
+          <a:ln/>
+        </p:spPr>
+        <p:txBody>
+          <a:bodyPr wrap="square" lIns="0" tIns="0" rIns="0" bIns="0" rtlCol="0" anchor="ctr"/>
+          <a:lstStyle/>
+          <a:p>
+            <a:pPr indent="0" marL="0">
+              <a:buNone/>
+            </a:pPr>
+            <a:r>
+              <a:rPr lang="zh-CN" altLang="en-US" sz="1200" b="1" dirty="0">
+                <a:solidFill>
+                  <a:srgbClr val="7A859C"/>
+                </a:solidFill>
+                <a:latin typeface="HarmonyOS Sans SC" pitchFamily="34" charset="0"/>
+                <a:ea typeface="HarmonyOS Sans SC" pitchFamily="34" charset="-122"/>
+                <a:cs typeface="HarmonyOS Sans SC" pitchFamily="34" charset="-120"/>
+              </a:rPr>
+              <a:t>05 溯源 · 源码对照</a:t>
+            </a:r>
+            <a:endParaRPr lang="zh-CN" sz="1200" dirty="0"/>
+          </a:p>
+        </p:txBody>
+      </p:sp>
+      <p:sp>
+        <p:nvSpPr>
+          <p:cNvPr id="4" name="Text 2"/>
+          <p:cNvSpPr/>
+          <p:nvPr/>
+        </p:nvSpPr>
+        <p:spPr>
+          <a:xfrm>
+            <a:off x="640080" y="786384"/>
+            <a:ext cx="10911535" cy="731520"/>
+          </a:xfrm>
+          <a:prstGeom prst="rect">
+            <a:avLst/>
+          </a:prstGeom>
+          <a:noFill/>
+          <a:ln/>
+        </p:spPr>
+        <p:txBody>
+          <a:bodyPr wrap="square" lIns="0" tIns="0" rIns="0" bIns="0" rtlCol="0" anchor="ctr"/>
+          <a:lstStyle/>
+          <a:p>
+            <a:pPr indent="0" marL="0">
+              <a:buNone/>
+            </a:pPr>
+            <a:r>
+              <a:rPr lang="zh-CN" altLang="en-US" sz="3000" b="1" dirty="0">
+                <a:solidFill>
+                  <a:srgbClr val="1B2340"/>
+                </a:solidFill>
+                <a:latin typeface="HarmonyOS Sans SC" pitchFamily="34" charset="0"/>
+                <a:ea typeface="HarmonyOS Sans SC" pitchFamily="34" charset="-122"/>
+                <a:cs typeface="HarmonyOS Sans SC" pitchFamily="34" charset="-120"/>
+              </a:rPr>
+              <a:t>mprotect 范围内的空洞（#918）</a:t>
+            </a:r>
+            <a:endParaRPr lang="zh-CN" sz="3000" dirty="0"/>
+          </a:p>
+        </p:txBody>
+      </p:sp>
+      <p:sp>
+        <p:nvSpPr>
+          <p:cNvPr id="5" name="Text 3"/>
+          <p:cNvSpPr/>
+          <p:nvPr/>
+        </p:nvSpPr>
+        <p:spPr>
+          <a:xfrm>
+            <a:off x="11002975" y="6400800"/>
+            <a:ext cx="548640" cy="274320"/>
+          </a:xfrm>
+          <a:prstGeom prst="rect">
+            <a:avLst/>
+          </a:prstGeom>
+          <a:noFill/>
+          <a:ln/>
+        </p:spPr>
+        <p:txBody>
+          <a:bodyPr wrap="square" lIns="0" tIns="0" rIns="0" bIns="0" rtlCol="0" anchor="ctr"/>
+          <a:lstStyle/>
+          <a:p>
+            <a:pPr algn="r" indent="0" marL="0">
+              <a:buNone/>
+            </a:pPr>
+            <a:r>
+              <a:rPr lang="zh-CN" altLang="en-US" sz="1000" dirty="0">
+                <a:solidFill>
+                  <a:srgbClr val="7A859C"/>
+                </a:solidFill>
+                <a:latin typeface="JetBrains Mono" pitchFamily="34" charset="0"/>
+                <a:ea typeface="JetBrains Mono" pitchFamily="34" charset="-122"/>
+                <a:cs typeface="JetBrains Mono" pitchFamily="34" charset="-120"/>
+              </a:rPr>
+              <a:t>34</a:t>
+            </a:r>
+            <a:endParaRPr lang="zh-CN" sz="1000" dirty="0"/>
+          </a:p>
+        </p:txBody>
+      </p:sp>
+      <p:sp>
+        <p:nvSpPr>
+          <p:cNvPr id="6" name="Shape 4"/>
+          <p:cNvSpPr/>
+          <p:nvPr/>
+        </p:nvSpPr>
+        <p:spPr>
+          <a:xfrm>
+            <a:off x="640080" y="1737360"/>
+            <a:ext cx="859536" cy="310896"/>
+          </a:xfrm>
+          <a:prstGeom prst="roundRect">
+            <a:avLst>
+              <a:gd name="adj" fmla="val 23529"/>
+            </a:avLst>
+          </a:prstGeom>
+          <a:solidFill>
+            <a:srgbClr val="E2604F"/>
+          </a:solidFill>
+          <a:ln w="12700">
+            <a:solidFill>
+              <a:srgbClr val="E2604F"/>
+            </a:solidFill>
+            <a:prstDash val="solid"/>
+          </a:ln>
+        </p:spPr>
+      </p:sp>
+      <p:sp>
+        <p:nvSpPr>
+          <p:cNvPr id="7" name="Text 5"/>
+          <p:cNvSpPr/>
+          <p:nvPr/>
+        </p:nvSpPr>
+        <p:spPr>
+          <a:xfrm>
+            <a:off x="640080" y="1737360"/>
+            <a:ext cx="859536" cy="310896"/>
+          </a:xfrm>
+          <a:prstGeom prst="rect">
+            <a:avLst/>
+          </a:prstGeom>
+          <a:noFill/>
+          <a:ln/>
+        </p:spPr>
+        <p:txBody>
+          <a:bodyPr wrap="square" lIns="0" tIns="0" rIns="0" bIns="0" rtlCol="0" anchor="ctr"/>
+          <a:lstStyle/>
+          <a:p>
+            <a:pPr algn="ctr" indent="0" marL="0">
+              <a:buNone/>
+            </a:pPr>
+            <a:r>
+              <a:rPr lang="zh-CN" altLang="en-US" sz="1200" b="1" dirty="0">
+                <a:solidFill>
+                  <a:srgbClr val="FFFFFF"/>
+                </a:solidFill>
+                <a:latin typeface="HarmonyOS Sans SC" pitchFamily="34" charset="0"/>
+                <a:ea typeface="HarmonyOS Sans SC" pitchFamily="34" charset="-122"/>
+                <a:cs typeface="HarmonyOS Sans SC" pitchFamily="34" charset="-120"/>
+              </a:rPr>
+              <a:t>合入前</a:t>
+            </a:r>
+            <a:endParaRPr lang="zh-CN" sz="1200" dirty="0"/>
+          </a:p>
+        </p:txBody>
+      </p:sp>
+      <p:sp>
+        <p:nvSpPr>
+          <p:cNvPr id="8" name="Text 6"/>
+          <p:cNvSpPr/>
+          <p:nvPr/>
+        </p:nvSpPr>
+        <p:spPr>
+          <a:xfrm>
+            <a:off x="640080" y="2121408"/>
+            <a:ext cx="2514600" cy="548640"/>
+          </a:xfrm>
+          <a:prstGeom prst="rect">
+            <a:avLst/>
+          </a:prstGeom>
+          <a:noFill/>
+          <a:ln/>
+        </p:spPr>
+        <p:txBody>
+          <a:bodyPr wrap="square" lIns="0" tIns="0" rIns="0" bIns="0" rtlCol="0" anchor="t"/>
+          <a:lstStyle/>
+          <a:p>
+            <a:pPr indent="0" marL="0">
+              <a:buNone/>
+            </a:pPr>
+            <a:r>
+              <a:rPr lang="zh-CN" altLang="en-US" sz="1200" dirty="0">
+                <a:solidFill>
+                  <a:srgbClr val="7A859C"/>
+                </a:solidFill>
+                <a:latin typeface="HarmonyOS Sans SC" pitchFamily="34" charset="0"/>
+                <a:ea typeface="HarmonyOS Sans SC" pitchFamily="34" charset="-122"/>
+                <a:cs typeface="HarmonyOS Sans SC" pitchFamily="34" charset="-120"/>
+              </a:rPr>
+              <a:t>sys_mprotect 只查起始地址所在的映射</a:t>
+            </a:r>
+            <a:endParaRPr lang="zh-CN" sz="1200" dirty="0"/>
+          </a:p>
+        </p:txBody>
+      </p:sp>
+      <p:sp>
+        <p:nvSpPr>
+          <p:cNvPr id="9" name="Shape 7"/>
+          <p:cNvSpPr/>
+          <p:nvPr/>
+        </p:nvSpPr>
+        <p:spPr>
+          <a:xfrm>
+            <a:off x="3337560" y="1691640"/>
+            <a:ext cx="8214055" cy="1005840"/>
+          </a:xfrm>
+          <a:prstGeom prst="roundRect">
+            <a:avLst>
+              <a:gd name="adj" fmla="val 9091"/>
+            </a:avLst>
+          </a:prstGeom>
+          <a:solidFill>
+            <a:srgbClr val="0B1437"/>
+          </a:solidFill>
+          <a:ln w="12700">
+            <a:solidFill>
+              <a:srgbClr val="0B1437"/>
+            </a:solidFill>
+            <a:prstDash val="solid"/>
+          </a:ln>
+        </p:spPr>
+      </p:sp>
+      <p:sp>
+        <p:nvSpPr>
+          <p:cNvPr id="10" name="Text 8"/>
+          <p:cNvSpPr/>
+          <p:nvPr/>
+        </p:nvSpPr>
+        <p:spPr>
+          <a:xfrm>
+            <a:off x="3566160" y="1828800"/>
+            <a:ext cx="7756855" cy="731520"/>
+          </a:xfrm>
+          <a:prstGeom prst="rect">
+            <a:avLst/>
+          </a:prstGeom>
+          <a:noFill/>
+          <a:ln/>
+        </p:spPr>
+        <p:txBody>
+          <a:bodyPr wrap="square" lIns="0" tIns="0" rIns="0" bIns="0" rtlCol="0" anchor="t"/>
+          <a:lstStyle/>
+          <a:p>
+            <a:pPr indent="0" marL="0">
+              <a:spcAft>
+                <a:spcPts val="200"/>
+              </a:spcAft>
+              <a:buNone/>
+            </a:pPr>
+            <a:r>
+              <a:rPr lang="zh-CN" altLang="en-US" sz="1000" dirty="0">
+                <a:solidFill>
+                  <a:srgbClr val="E6EBFA"/>
+                </a:solidFill>
+                <a:latin typeface="JetBrains Mono" pitchFamily="34" charset="0"/>
+                <a:ea typeface="JetBrains Mono" pitchFamily="34" charset="-122"/>
+                <a:cs typeface="JetBrains Mono" pitchFamily="34" charset="-120"/>
+              </a:rPr>
+              <a:t>let start_addr = VirtAddr::from(addr);</a:t>
+            </a:r>
+            <a:endParaRPr lang="zh-CN" sz="1000" dirty="0"/>
+          </a:p>
+          <a:p>
+            <a:pPr indent="0" marL="0">
+              <a:spcAft>
+                <a:spcPts val="200"/>
+              </a:spcAft>
+              <a:buNone/>
+            </a:pPr>
+            <a:r>
+              <a:rPr lang="zh-CN" altLang="en-US" sz="1000" dirty="0">
+                <a:solidFill>
+                  <a:srgbClr val="E6EBFA"/>
+                </a:solidFill>
+                <a:latin typeface="JetBrains Mono" pitchFamily="34" charset="0"/>
+                <a:ea typeface="JetBrains Mono" pitchFamily="34" charset="-122"/>
+                <a:cs typeface="JetBrains Mono" pitchFamily="34" charset="-120"/>
+              </a:rPr>
+              <a:t>if aspace.find_area(start_addr).is_none() {</a:t>
+            </a:r>
+            <a:endParaRPr lang="zh-CN" sz="1000" dirty="0"/>
+          </a:p>
+          <a:p>
+            <a:pPr indent="0" marL="0">
+              <a:spcAft>
+                <a:spcPts val="200"/>
+              </a:spcAft>
+              <a:buNone/>
+            </a:pPr>
+            <a:r>
+              <a:rPr lang="zh-CN" altLang="en-US" sz="1000" dirty="0">
+                <a:solidFill>
+                  <a:srgbClr val="E6EBFA"/>
+                </a:solidFill>
+                <a:latin typeface="JetBrains Mono" pitchFamily="34" charset="0"/>
+                <a:ea typeface="JetBrains Mono" pitchFamily="34" charset="-122"/>
+                <a:cs typeface="JetBrains Mono" pitchFamily="34" charset="-120"/>
+              </a:rPr>
+              <a:t>    return Err(AxError::NoMemory);</a:t>
+            </a:r>
+            <a:endParaRPr lang="zh-CN" sz="1000" dirty="0"/>
+          </a:p>
+          <a:p>
+            <a:pPr indent="0" marL="0">
+              <a:spcAft>
+                <a:spcPts val="200"/>
+              </a:spcAft>
+              <a:buNone/>
+            </a:pPr>
+            <a:r>
+              <a:rPr lang="zh-CN" altLang="en-US" sz="1000" dirty="0">
+                <a:solidFill>
+                  <a:srgbClr val="E6EBFA"/>
+                </a:solidFill>
+                <a:latin typeface="JetBrains Mono" pitchFamily="34" charset="0"/>
+                <a:ea typeface="JetBrains Mono" pitchFamily="34" charset="-122"/>
+                <a:cs typeface="JetBrains Mono" pitchFamily="34" charset="-120"/>
+              </a:rPr>
+              <a:t>}</a:t>
+            </a:r>
+            <a:endParaRPr lang="zh-CN" sz="1000" dirty="0"/>
+          </a:p>
+        </p:txBody>
+      </p:sp>
+      <p:sp>
+        <p:nvSpPr>
+          <p:cNvPr id="11" name="Shape 9"/>
+          <p:cNvSpPr/>
+          <p:nvPr/>
+        </p:nvSpPr>
+        <p:spPr>
+          <a:xfrm>
+            <a:off x="640080" y="2852928"/>
+            <a:ext cx="1175004" cy="310896"/>
+          </a:xfrm>
+          <a:prstGeom prst="roundRect">
+            <a:avLst>
+              <a:gd name="adj" fmla="val 23529"/>
+            </a:avLst>
+          </a:prstGeom>
+          <a:solidFill>
+            <a:srgbClr val="0B1437"/>
+          </a:solidFill>
+          <a:ln w="12700">
+            <a:solidFill>
+              <a:srgbClr val="0B1437"/>
+            </a:solidFill>
+            <a:prstDash val="solid"/>
+          </a:ln>
+        </p:spPr>
+      </p:sp>
+      <p:sp>
+        <p:nvSpPr>
+          <p:cNvPr id="12" name="Text 10"/>
+          <p:cNvSpPr/>
+          <p:nvPr/>
+        </p:nvSpPr>
+        <p:spPr>
+          <a:xfrm>
+            <a:off x="640080" y="2852928"/>
+            <a:ext cx="1175004" cy="310896"/>
+          </a:xfrm>
+          <a:prstGeom prst="rect">
+            <a:avLst/>
+          </a:prstGeom>
+          <a:noFill/>
+          <a:ln/>
+        </p:spPr>
+        <p:txBody>
+          <a:bodyPr wrap="square" lIns="0" tIns="0" rIns="0" bIns="0" rtlCol="0" anchor="ctr"/>
+          <a:lstStyle/>
+          <a:p>
+            <a:pPr algn="ctr" indent="0" marL="0">
+              <a:buNone/>
+            </a:pPr>
+            <a:r>
+              <a:rPr lang="zh-CN" altLang="en-US" sz="1200" b="1" dirty="0">
+                <a:solidFill>
+                  <a:srgbClr val="FFFFFF"/>
+                </a:solidFill>
+                <a:latin typeface="HarmonyOS Sans SC" pitchFamily="34" charset="0"/>
+                <a:ea typeface="HarmonyOS Sans SC" pitchFamily="34" charset="-122"/>
+                <a:cs typeface="HarmonyOS Sans SC" pitchFamily="34" charset="-120"/>
+              </a:rPr>
+              <a:t>Linux 7.1</a:t>
+            </a:r>
+            <a:endParaRPr lang="zh-CN" sz="1200" dirty="0"/>
+          </a:p>
+        </p:txBody>
+      </p:sp>
+      <p:sp>
+        <p:nvSpPr>
+          <p:cNvPr id="13" name="Text 11"/>
+          <p:cNvSpPr/>
+          <p:nvPr/>
+        </p:nvSpPr>
+        <p:spPr>
+          <a:xfrm>
+            <a:off x="640080" y="3236976"/>
+            <a:ext cx="2514600" cy="548640"/>
+          </a:xfrm>
+          <a:prstGeom prst="rect">
+            <a:avLst/>
+          </a:prstGeom>
+          <a:noFill/>
+          <a:ln/>
+        </p:spPr>
+        <p:txBody>
+          <a:bodyPr wrap="square" lIns="0" tIns="0" rIns="0" bIns="0" rtlCol="0" anchor="t"/>
+          <a:lstStyle/>
+          <a:p>
+            <a:pPr indent="0" marL="0">
+              <a:buNone/>
+            </a:pPr>
+            <a:r>
+              <a:rPr lang="zh-CN" altLang="en-US" sz="1200" dirty="0">
+                <a:solidFill>
+                  <a:srgbClr val="7A859C"/>
+                </a:solidFill>
+                <a:latin typeface="HarmonyOS Sans SC" pitchFamily="34" charset="0"/>
+                <a:ea typeface="HarmonyOS Sans SC" pitchFamily="34" charset="-122"/>
+                <a:cs typeface="HarmonyOS Sans SC" pitchFamily="34" charset="-120"/>
+              </a:rPr>
+              <a:t>mm/mprotect.c 第 909 至 918 行、第 977 至 978 行</a:t>
+            </a:r>
+            <a:endParaRPr lang="zh-CN" sz="1200" dirty="0"/>
+          </a:p>
+        </p:txBody>
+      </p:sp>
+      <p:sp>
+        <p:nvSpPr>
+          <p:cNvPr id="14" name="Shape 12"/>
+          <p:cNvSpPr/>
+          <p:nvPr/>
+        </p:nvSpPr>
+        <p:spPr>
+          <a:xfrm>
+            <a:off x="3337560" y="2807208"/>
+            <a:ext cx="8214055" cy="2103120"/>
+          </a:xfrm>
+          <a:prstGeom prst="roundRect">
+            <a:avLst>
+              <a:gd name="adj" fmla="val 4348"/>
+            </a:avLst>
+          </a:prstGeom>
+          <a:solidFill>
+            <a:srgbClr val="0B1437"/>
+          </a:solidFill>
+          <a:ln w="12700">
+            <a:solidFill>
+              <a:srgbClr val="0B1437"/>
+            </a:solidFill>
+            <a:prstDash val="solid"/>
+          </a:ln>
+        </p:spPr>
+      </p:sp>
+      <p:sp>
+        <p:nvSpPr>
+          <p:cNvPr id="15" name="Text 13"/>
+          <p:cNvSpPr/>
+          <p:nvPr/>
+        </p:nvSpPr>
+        <p:spPr>
+          <a:xfrm>
+            <a:off x="3566160" y="2944368"/>
+            <a:ext cx="7756855" cy="1828800"/>
+          </a:xfrm>
+          <a:prstGeom prst="rect">
+            <a:avLst/>
+          </a:prstGeom>
+          <a:noFill/>
+          <a:ln/>
+        </p:spPr>
+        <p:txBody>
+          <a:bodyPr wrap="square" lIns="0" tIns="0" rIns="0" bIns="0" rtlCol="0" anchor="t"/>
+          <a:lstStyle/>
+          <a:p>
+            <a:pPr indent="0" marL="0">
+              <a:spcAft>
+                <a:spcPts val="200"/>
+              </a:spcAft>
+              <a:buNone/>
+            </a:pPr>
+            <a:r>
+              <a:rPr lang="zh-CN" altLang="en-US" sz="1000" dirty="0">
+                <a:solidFill>
+                  <a:srgbClr val="E6EBFA"/>
+                </a:solidFill>
+                <a:latin typeface="JetBrains Mono" pitchFamily="34" charset="0"/>
+                <a:ea typeface="JetBrains Mono" pitchFamily="34" charset="-122"/>
+                <a:cs typeface="JetBrains Mono" pitchFamily="34" charset="-120"/>
+              </a:rPr>
+              <a:t>for_each_vma_range(vmi, vma, end) {</a:t>
+            </a:r>
+            <a:endParaRPr lang="zh-CN" sz="1000" dirty="0"/>
+          </a:p>
+          <a:p>
+            <a:pPr indent="0" marL="0">
+              <a:spcAft>
+                <a:spcPts val="200"/>
+              </a:spcAft>
+              <a:buNone/>
+            </a:pPr>
+            <a:r>
+              <a:rPr lang="zh-CN" altLang="en-US" sz="1000" dirty="0">
+                <a:solidFill>
+                  <a:srgbClr val="E6EBFA"/>
+                </a:solidFill>
+                <a:latin typeface="JetBrains Mono" pitchFamily="34" charset="0"/>
+                <a:ea typeface="JetBrains Mono" pitchFamily="34" charset="-122"/>
+                <a:cs typeface="JetBrains Mono" pitchFamily="34" charset="-120"/>
+              </a:rPr>
+              <a:t>    // ...</a:t>
+            </a:r>
+            <a:endParaRPr lang="zh-CN" sz="1000" dirty="0"/>
+          </a:p>
+          <a:p>
+            <a:pPr indent="0" marL="0">
+              <a:spcAft>
+                <a:spcPts val="200"/>
+              </a:spcAft>
+              <a:buNone/>
+            </a:pPr>
+            <a:r>
+              <a:rPr lang="zh-CN" altLang="en-US" sz="1000" dirty="0">
+                <a:solidFill>
+                  <a:srgbClr val="E6EBFA"/>
+                </a:solidFill>
+                <a:latin typeface="JetBrains Mono" pitchFamily="34" charset="0"/>
+                <a:ea typeface="JetBrains Mono" pitchFamily="34" charset="-122"/>
+                <a:cs typeface="JetBrains Mono" pitchFamily="34" charset="-120"/>
+              </a:rPr>
+              <a:t>    if (vma-&gt;vm_start != tmp) {</a:t>
+            </a:r>
+            <a:endParaRPr lang="zh-CN" sz="1000" dirty="0"/>
+          </a:p>
+          <a:p>
+            <a:pPr indent="0" marL="0">
+              <a:spcAft>
+                <a:spcPts val="200"/>
+              </a:spcAft>
+              <a:buNone/>
+            </a:pPr>
+            <a:r>
+              <a:rPr lang="zh-CN" altLang="en-US" sz="1000" dirty="0">
+                <a:solidFill>
+                  <a:srgbClr val="E6EBFA"/>
+                </a:solidFill>
+                <a:latin typeface="JetBrains Mono" pitchFamily="34" charset="0"/>
+                <a:ea typeface="JetBrains Mono" pitchFamily="34" charset="-122"/>
+                <a:cs typeface="JetBrains Mono" pitchFamily="34" charset="-120"/>
+              </a:rPr>
+              <a:t>        error = -ENOMEM;</a:t>
+            </a:r>
+            <a:endParaRPr lang="zh-CN" sz="1000" dirty="0"/>
+          </a:p>
+          <a:p>
+            <a:pPr indent="0" marL="0">
+              <a:spcAft>
+                <a:spcPts val="200"/>
+              </a:spcAft>
+              <a:buNone/>
+            </a:pPr>
+            <a:r>
+              <a:rPr lang="zh-CN" altLang="en-US" sz="1000" dirty="0">
+                <a:solidFill>
+                  <a:srgbClr val="E6EBFA"/>
+                </a:solidFill>
+                <a:latin typeface="JetBrains Mono" pitchFamily="34" charset="0"/>
+                <a:ea typeface="JetBrains Mono" pitchFamily="34" charset="-122"/>
+                <a:cs typeface="JetBrains Mono" pitchFamily="34" charset="-120"/>
+              </a:rPr>
+              <a:t>        break;</a:t>
+            </a:r>
+            <a:endParaRPr lang="zh-CN" sz="1000" dirty="0"/>
+          </a:p>
+          <a:p>
+            <a:pPr indent="0" marL="0">
+              <a:spcAft>
+                <a:spcPts val="200"/>
+              </a:spcAft>
+              <a:buNone/>
+            </a:pPr>
+            <a:r>
+              <a:rPr lang="zh-CN" altLang="en-US" sz="1000" dirty="0">
+                <a:solidFill>
+                  <a:srgbClr val="E6EBFA"/>
+                </a:solidFill>
+                <a:latin typeface="JetBrains Mono" pitchFamily="34" charset="0"/>
+                <a:ea typeface="JetBrains Mono" pitchFamily="34" charset="-122"/>
+                <a:cs typeface="JetBrains Mono" pitchFamily="34" charset="-120"/>
+              </a:rPr>
+              <a:t>    }</a:t>
+            </a:r>
+            <a:endParaRPr lang="zh-CN" sz="1000" dirty="0"/>
+          </a:p>
+          <a:p>
+            <a:pPr indent="0" marL="0">
+              <a:spcAft>
+                <a:spcPts val="200"/>
+              </a:spcAft>
+              <a:buNone/>
+            </a:pPr>
+            <a:r>
+              <a:rPr lang="zh-CN" altLang="en-US" sz="1000" dirty="0">
+                <a:solidFill>
+                  <a:srgbClr val="E6EBFA"/>
+                </a:solidFill>
+                <a:latin typeface="JetBrains Mono" pitchFamily="34" charset="0"/>
+                <a:ea typeface="JetBrains Mono" pitchFamily="34" charset="-122"/>
+                <a:cs typeface="JetBrains Mono" pitchFamily="34" charset="-120"/>
+              </a:rPr>
+              <a:t>    // ...</a:t>
+            </a:r>
+            <a:endParaRPr lang="zh-CN" sz="1000" dirty="0"/>
+          </a:p>
+          <a:p>
+            <a:pPr indent="0" marL="0">
+              <a:spcAft>
+                <a:spcPts val="200"/>
+              </a:spcAft>
+              <a:buNone/>
+            </a:pPr>
+            <a:r>
+              <a:rPr lang="zh-CN" altLang="en-US" sz="1000" dirty="0">
+                <a:solidFill>
+                  <a:srgbClr val="E6EBFA"/>
+                </a:solidFill>
+                <a:latin typeface="JetBrains Mono" pitchFamily="34" charset="0"/>
+                <a:ea typeface="JetBrains Mono" pitchFamily="34" charset="-122"/>
+                <a:cs typeface="JetBrains Mono" pitchFamily="34" charset="-120"/>
+              </a:rPr>
+              <a:t>}</a:t>
+            </a:r>
+            <a:endParaRPr lang="zh-CN" sz="1000" dirty="0"/>
+          </a:p>
+          <a:p>
+            <a:pPr indent="0" marL="0">
+              <a:spcAft>
+                <a:spcPts val="200"/>
+              </a:spcAft>
+              <a:buNone/>
+            </a:pPr>
+            <a:r>
+              <a:rPr lang="zh-CN" altLang="en-US" sz="1000" dirty="0">
+                <a:solidFill>
+                  <a:srgbClr val="E6EBFA"/>
+                </a:solidFill>
+                <a:latin typeface="JetBrains Mono" pitchFamily="34" charset="0"/>
+                <a:ea typeface="JetBrains Mono" pitchFamily="34" charset="-122"/>
+                <a:cs typeface="JetBrains Mono" pitchFamily="34" charset="-120"/>
+              </a:rPr>
+              <a:t>if (!error &amp;&amp; tmp &lt; end)</a:t>
+            </a:r>
+            <a:endParaRPr lang="zh-CN" sz="1000" dirty="0"/>
+          </a:p>
+          <a:p>
+            <a:pPr indent="0" marL="0">
+              <a:spcAft>
+                <a:spcPts val="200"/>
+              </a:spcAft>
+              <a:buNone/>
+            </a:pPr>
+            <a:r>
+              <a:rPr lang="zh-CN" altLang="en-US" sz="1000" dirty="0">
+                <a:solidFill>
+                  <a:srgbClr val="E6EBFA"/>
+                </a:solidFill>
+                <a:latin typeface="JetBrains Mono" pitchFamily="34" charset="0"/>
+                <a:ea typeface="JetBrains Mono" pitchFamily="34" charset="-122"/>
+                <a:cs typeface="JetBrains Mono" pitchFamily="34" charset="-120"/>
+              </a:rPr>
+              <a:t>    error = -ENOMEM;</a:t>
+            </a:r>
+            <a:endParaRPr lang="zh-CN" sz="1000" dirty="0"/>
+          </a:p>
+        </p:txBody>
+      </p:sp>
+      <p:sp>
+        <p:nvSpPr>
+          <p:cNvPr id="16" name="Shape 14"/>
+          <p:cNvSpPr/>
+          <p:nvPr/>
+        </p:nvSpPr>
+        <p:spPr>
+          <a:xfrm>
+            <a:off x="640080" y="5065776"/>
+            <a:ext cx="859536" cy="310896"/>
+          </a:xfrm>
+          <a:prstGeom prst="roundRect">
+            <a:avLst>
+              <a:gd name="adj" fmla="val 23529"/>
+            </a:avLst>
+          </a:prstGeom>
+          <a:solidFill>
+            <a:srgbClr val="1FA896"/>
+          </a:solidFill>
+          <a:ln w="12700">
+            <a:solidFill>
+              <a:srgbClr val="1FA896"/>
+            </a:solidFill>
+            <a:prstDash val="solid"/>
+          </a:ln>
+        </p:spPr>
+      </p:sp>
+      <p:sp>
+        <p:nvSpPr>
+          <p:cNvPr id="17" name="Text 15"/>
+          <p:cNvSpPr/>
+          <p:nvPr/>
+        </p:nvSpPr>
+        <p:spPr>
+          <a:xfrm>
+            <a:off x="640080" y="5065776"/>
+            <a:ext cx="859536" cy="310896"/>
+          </a:xfrm>
+          <a:prstGeom prst="rect">
+            <a:avLst/>
+          </a:prstGeom>
+          <a:noFill/>
+          <a:ln/>
+        </p:spPr>
+        <p:txBody>
+          <a:bodyPr wrap="square" lIns="0" tIns="0" rIns="0" bIns="0" rtlCol="0" anchor="ctr"/>
+          <a:lstStyle/>
+          <a:p>
+            <a:pPr algn="ctr" indent="0" marL="0">
+              <a:buNone/>
+            </a:pPr>
+            <a:r>
+              <a:rPr lang="zh-CN" altLang="en-US" sz="1200" b="1" dirty="0">
+                <a:solidFill>
+                  <a:srgbClr val="FFFFFF"/>
+                </a:solidFill>
+                <a:latin typeface="HarmonyOS Sans SC" pitchFamily="34" charset="0"/>
+                <a:ea typeface="HarmonyOS Sans SC" pitchFamily="34" charset="-122"/>
+                <a:cs typeface="HarmonyOS Sans SC" pitchFamily="34" charset="-120"/>
+              </a:rPr>
+              <a:t>合入后</a:t>
+            </a:r>
+            <a:endParaRPr lang="zh-CN" sz="1200" dirty="0"/>
+          </a:p>
+        </p:txBody>
+      </p:sp>
+      <p:sp>
+        <p:nvSpPr>
+          <p:cNvPr id="18" name="Text 16"/>
+          <p:cNvSpPr/>
+          <p:nvPr/>
+        </p:nvSpPr>
+        <p:spPr>
+          <a:xfrm>
+            <a:off x="640080" y="5449824"/>
+            <a:ext cx="2514600" cy="548640"/>
+          </a:xfrm>
+          <a:prstGeom prst="rect">
+            <a:avLst/>
+          </a:prstGeom>
+          <a:noFill/>
+          <a:ln/>
+        </p:spPr>
+        <p:txBody>
+          <a:bodyPr wrap="square" lIns="0" tIns="0" rIns="0" bIns="0" rtlCol="0" anchor="t"/>
+          <a:lstStyle/>
+          <a:p>
+            <a:pPr indent="0" marL="0">
+              <a:buNone/>
+            </a:pPr>
+            <a:r>
+              <a:rPr lang="zh-CN" altLang="en-US" sz="1200" dirty="0">
+                <a:solidFill>
+                  <a:srgbClr val="7A859C"/>
+                </a:solidFill>
+                <a:latin typeface="HarmonyOS Sans SC" pitchFamily="34" charset="0"/>
+                <a:ea typeface="HarmonyOS Sans SC" pitchFamily="34" charset="-122"/>
+                <a:cs typeface="HarmonyOS Sans SC" pitchFamily="34" charset="-120"/>
+              </a:rPr>
+              <a:t>修改之前先检查整段是否连续覆盖</a:t>
+            </a:r>
+            <a:endParaRPr lang="zh-CN" sz="1200" dirty="0"/>
+          </a:p>
+        </p:txBody>
+      </p:sp>
+      <p:sp>
+        <p:nvSpPr>
+          <p:cNvPr id="19" name="Shape 17"/>
+          <p:cNvSpPr/>
+          <p:nvPr/>
+        </p:nvSpPr>
+        <p:spPr>
+          <a:xfrm>
+            <a:off x="3337560" y="5020056"/>
+            <a:ext cx="8214055" cy="822960"/>
+          </a:xfrm>
+          <a:prstGeom prst="roundRect">
+            <a:avLst>
+              <a:gd name="adj" fmla="val 11111"/>
+            </a:avLst>
+          </a:prstGeom>
+          <a:solidFill>
+            <a:srgbClr val="0B1437"/>
+          </a:solidFill>
+          <a:ln w="12700">
+            <a:solidFill>
+              <a:srgbClr val="0B1437"/>
+            </a:solidFill>
+            <a:prstDash val="solid"/>
+          </a:ln>
+        </p:spPr>
+      </p:sp>
+      <p:sp>
+        <p:nvSpPr>
+          <p:cNvPr id="20" name="Text 18"/>
+          <p:cNvSpPr/>
+          <p:nvPr/>
+        </p:nvSpPr>
+        <p:spPr>
+          <a:xfrm>
+            <a:off x="3566160" y="5157216"/>
+            <a:ext cx="7756855" cy="548640"/>
+          </a:xfrm>
+          <a:prstGeom prst="rect">
+            <a:avLst/>
+          </a:prstGeom>
+          <a:noFill/>
+          <a:ln/>
+        </p:spPr>
+        <p:txBody>
+          <a:bodyPr wrap="square" lIns="0" tIns="0" rIns="0" bIns="0" rtlCol="0" anchor="t"/>
+          <a:lstStyle/>
+          <a:p>
+            <a:pPr indent="0" marL="0">
+              <a:spcAft>
+                <a:spcPts val="200"/>
+              </a:spcAft>
+              <a:buNone/>
+            </a:pPr>
+            <a:r>
+              <a:rPr lang="zh-CN" altLang="en-US" sz="1000" dirty="0">
+                <a:solidFill>
+                  <a:srgbClr val="E6EBFA"/>
+                </a:solidFill>
+                <a:latin typeface="JetBrains Mono" pitchFamily="34" charset="0"/>
+                <a:ea typeface="JetBrains Mono" pitchFamily="34" charset="-122"/>
+                <a:cs typeface="JetBrains Mono" pitchFamily="34" charset="-120"/>
+              </a:rPr>
+              <a:t>if !aspace.can_access_range(start_addr, length, MappingFlags::empty()) {</a:t>
+            </a:r>
+            <a:endParaRPr lang="zh-CN" sz="1000" dirty="0"/>
+          </a:p>
+          <a:p>
+            <a:pPr indent="0" marL="0">
+              <a:spcAft>
+                <a:spcPts val="200"/>
+              </a:spcAft>
+              <a:buNone/>
+            </a:pPr>
+            <a:r>
+              <a:rPr lang="zh-CN" altLang="en-US" sz="1000" dirty="0">
+                <a:solidFill>
+                  <a:srgbClr val="E6EBFA"/>
+                </a:solidFill>
+                <a:latin typeface="JetBrains Mono" pitchFamily="34" charset="0"/>
+                <a:ea typeface="JetBrains Mono" pitchFamily="34" charset="-122"/>
+                <a:cs typeface="JetBrains Mono" pitchFamily="34" charset="-120"/>
+              </a:rPr>
+              <a:t>    return Err(AxError::NoMemory);</a:t>
+            </a:r>
+            <a:endParaRPr lang="zh-CN" sz="1000" dirty="0"/>
+          </a:p>
+          <a:p>
+            <a:pPr indent="0" marL="0">
+              <a:spcAft>
+                <a:spcPts val="200"/>
+              </a:spcAft>
+              <a:buNone/>
+            </a:pPr>
+            <a:r>
+              <a:rPr lang="zh-CN" altLang="en-US" sz="1000" dirty="0">
+                <a:solidFill>
+                  <a:srgbClr val="E6EBFA"/>
+                </a:solidFill>
+                <a:latin typeface="JetBrains Mono" pitchFamily="34" charset="0"/>
+                <a:ea typeface="JetBrains Mono" pitchFamily="34" charset="-122"/>
+                <a:cs typeface="JetBrains Mono" pitchFamily="34" charset="-120"/>
+              </a:rPr>
+              <a:t>}</a:t>
+            </a:r>
+            <a:endParaRPr lang="zh-CN" sz="1000" dirty="0"/>
+          </a:p>
+        </p:txBody>
+      </p:sp>
+      <p:sp>
+        <p:nvSpPr>
+          <p:cNvPr id="21" name="Text 19"/>
+          <p:cNvSpPr/>
+          <p:nvPr/>
+        </p:nvSpPr>
+        <p:spPr>
+          <a:xfrm>
+            <a:off x="640080" y="6108192"/>
+            <a:ext cx="10180015" cy="365760"/>
+          </a:xfrm>
+          <a:prstGeom prst="rect">
+            <a:avLst/>
+          </a:prstGeom>
+          <a:noFill/>
+          <a:ln/>
+        </p:spPr>
+        <p:txBody>
+          <a:bodyPr wrap="square" lIns="0" tIns="0" rIns="0" bIns="0" rtlCol="0" anchor="ctr"/>
+          <a:lstStyle/>
+          <a:p>
+            <a:pPr indent="0" marL="0">
+              <a:buNone/>
+            </a:pPr>
+            <a:r>
+              <a:rPr lang="zh-CN" altLang="en-US" sz="1300" dirty="0">
+                <a:solidFill>
+                  <a:srgbClr val="7A859C"/>
+                </a:solidFill>
+                <a:latin typeface="HarmonyOS Sans SC" pitchFamily="34" charset="0"/>
+                <a:ea typeface="HarmonyOS Sans SC" pitchFamily="34" charset="-122"/>
+                <a:cs typeface="HarmonyOS Sans SC" pitchFamily="34" charset="-120"/>
+              </a:rPr>
+              <a:t>复核：Linux 遇到空洞时，空洞之前的部分已经生效；当前 dev 已由 #2261 改成同样的逐段提交。</a:t>
+            </a:r>
+            <a:endParaRPr lang="zh-CN" sz="1300" dirty="0"/>
+          </a:p>
+        </p:txBody>
+      </p:sp>
+    </p:spTree>
+  </p:cSld>
+  <p:clrMapOvr>
+    <a:masterClrMapping/>
+  </p:clrMapOvr>
+</p:sld>
+</file>
+
+<file path=ppt/slides/slide35.xml><?xml version="1.0" encoding="utf-8"?>
+<p:sld xmlns:a="http://schemas.openxmlformats.org/drawingml/2006/main" xmlns:r="http://schemas.openxmlformats.org/officeDocument/2006/relationships" xmlns:p="http://schemas.openxmlformats.org/presentationml/2006/main">
+  <p:cSld name="Slide 35">
+    <p:bg>
+      <p:bgPr>
+        <a:solidFill>
+          <a:srgbClr val="FFFFFF"/>
+        </a:solidFill>
+      </p:bgPr>
+    </p:bg>
+    <p:spTree>
+      <p:nvGrpSpPr>
+        <p:cNvPr id="1" name=""/>
+        <p:cNvGrpSpPr/>
+        <p:nvPr/>
+      </p:nvGrpSpPr>
+      <p:grpSpPr>
+        <a:xfrm>
+          <a:off x="0" y="0"/>
+          <a:ext cx="0" cy="0"/>
+          <a:chOff x="0" y="0"/>
+          <a:chExt cx="0" cy="0"/>
+        </a:xfrm>
+      </p:grpSpPr>
+      <p:sp>
+        <p:nvSpPr>
+          <p:cNvPr id="2" name="Shape 0"/>
+          <p:cNvSpPr/>
+          <p:nvPr/>
+        </p:nvSpPr>
+        <p:spPr>
+          <a:xfrm>
+            <a:off x="640080" y="457200"/>
+            <a:ext cx="201168" cy="201168"/>
+          </a:xfrm>
+          <a:prstGeom prst="star4">
+            <a:avLst/>
+          </a:prstGeom>
+          <a:solidFill>
+            <a:srgbClr val="F2B441"/>
+          </a:solidFill>
+          <a:ln w="12700">
+            <a:solidFill>
+              <a:srgbClr val="F2B441"/>
+            </a:solidFill>
+            <a:prstDash val="solid"/>
+          </a:ln>
+        </p:spPr>
+      </p:sp>
+      <p:sp>
+        <p:nvSpPr>
+          <p:cNvPr id="3" name="Text 1"/>
+          <p:cNvSpPr/>
+          <p:nvPr/>
+        </p:nvSpPr>
+        <p:spPr>
+          <a:xfrm>
+            <a:off x="932688" y="402336"/>
+            <a:ext cx="7315200" cy="310896"/>
+          </a:xfrm>
+          <a:prstGeom prst="rect">
+            <a:avLst/>
+          </a:prstGeom>
+          <a:noFill/>
+          <a:ln/>
+        </p:spPr>
+        <p:txBody>
+          <a:bodyPr wrap="square" lIns="0" tIns="0" rIns="0" bIns="0" rtlCol="0" anchor="ctr"/>
+          <a:lstStyle/>
+          <a:p>
+            <a:pPr indent="0" marL="0">
+              <a:buNone/>
+            </a:pPr>
+            <a:r>
+              <a:rPr lang="zh-CN" altLang="en-US" sz="1200" b="1" dirty="0">
+                <a:solidFill>
+                  <a:srgbClr val="7A859C"/>
+                </a:solidFill>
+                <a:latin typeface="HarmonyOS Sans SC" pitchFamily="34" charset="0"/>
+                <a:ea typeface="HarmonyOS Sans SC" pitchFamily="34" charset="-122"/>
+                <a:cs typeface="HarmonyOS Sans SC" pitchFamily="34" charset="-120"/>
+              </a:rPr>
+              <a:t>05 溯源 · 源码对照</a:t>
+            </a:r>
+            <a:endParaRPr lang="zh-CN" sz="1200" dirty="0"/>
+          </a:p>
+        </p:txBody>
+      </p:sp>
+      <p:sp>
+        <p:nvSpPr>
+          <p:cNvPr id="4" name="Text 2"/>
+          <p:cNvSpPr/>
+          <p:nvPr/>
+        </p:nvSpPr>
+        <p:spPr>
+          <a:xfrm>
+            <a:off x="640080" y="786384"/>
+            <a:ext cx="10911535" cy="731520"/>
+          </a:xfrm>
+          <a:prstGeom prst="rect">
+            <a:avLst/>
+          </a:prstGeom>
+          <a:noFill/>
+          <a:ln/>
+        </p:spPr>
+        <p:txBody>
+          <a:bodyPr wrap="square" lIns="0" tIns="0" rIns="0" bIns="0" rtlCol="0" anchor="ctr"/>
+          <a:lstStyle/>
+          <a:p>
+            <a:pPr indent="0" marL="0">
+              <a:buNone/>
+            </a:pPr>
+            <a:r>
+              <a:rPr lang="zh-CN" altLang="en-US" sz="3000" b="1" dirty="0">
+                <a:solidFill>
+                  <a:srgbClr val="1B2340"/>
+                </a:solidFill>
+                <a:latin typeface="HarmonyOS Sans SC" pitchFamily="34" charset="0"/>
+                <a:ea typeface="HarmonyOS Sans SC" pitchFamily="34" charset="-122"/>
+                <a:cs typeface="HarmonyOS Sans SC" pitchFamily="34" charset="-120"/>
+              </a:rPr>
+              <a:t>VMA 区间查找（#2302）</a:t>
+            </a:r>
+            <a:endParaRPr lang="zh-CN" sz="3000" dirty="0"/>
+          </a:p>
+        </p:txBody>
+      </p:sp>
+      <p:sp>
+        <p:nvSpPr>
+          <p:cNvPr id="5" name="Text 3"/>
+          <p:cNvSpPr/>
+          <p:nvPr/>
+        </p:nvSpPr>
+        <p:spPr>
+          <a:xfrm>
+            <a:off x="11002975" y="6400800"/>
+            <a:ext cx="548640" cy="274320"/>
+          </a:xfrm>
+          <a:prstGeom prst="rect">
+            <a:avLst/>
+          </a:prstGeom>
+          <a:noFill/>
+          <a:ln/>
+        </p:spPr>
+        <p:txBody>
+          <a:bodyPr wrap="square" lIns="0" tIns="0" rIns="0" bIns="0" rtlCol="0" anchor="ctr"/>
+          <a:lstStyle/>
+          <a:p>
+            <a:pPr algn="r" indent="0" marL="0">
+              <a:buNone/>
+            </a:pPr>
+            <a:r>
+              <a:rPr lang="zh-CN" altLang="en-US" sz="1000" dirty="0">
+                <a:solidFill>
+                  <a:srgbClr val="7A859C"/>
+                </a:solidFill>
+                <a:latin typeface="JetBrains Mono" pitchFamily="34" charset="0"/>
+                <a:ea typeface="JetBrains Mono" pitchFamily="34" charset="-122"/>
+                <a:cs typeface="JetBrains Mono" pitchFamily="34" charset="-120"/>
+              </a:rPr>
+              <a:t>35</a:t>
+            </a:r>
+            <a:endParaRPr lang="zh-CN" sz="1000" dirty="0"/>
+          </a:p>
+        </p:txBody>
+      </p:sp>
+      <p:sp>
+        <p:nvSpPr>
+          <p:cNvPr id="6" name="Shape 4"/>
+          <p:cNvSpPr/>
+          <p:nvPr/>
+        </p:nvSpPr>
+        <p:spPr>
+          <a:xfrm>
+            <a:off x="640080" y="1737360"/>
+            <a:ext cx="859536" cy="310896"/>
+          </a:xfrm>
+          <a:prstGeom prst="roundRect">
+            <a:avLst>
+              <a:gd name="adj" fmla="val 23529"/>
+            </a:avLst>
+          </a:prstGeom>
+          <a:solidFill>
+            <a:srgbClr val="E2604F"/>
+          </a:solidFill>
+          <a:ln w="12700">
+            <a:solidFill>
+              <a:srgbClr val="E2604F"/>
+            </a:solidFill>
+            <a:prstDash val="solid"/>
+          </a:ln>
+        </p:spPr>
+      </p:sp>
+      <p:sp>
+        <p:nvSpPr>
+          <p:cNvPr id="7" name="Text 5"/>
+          <p:cNvSpPr/>
+          <p:nvPr/>
+        </p:nvSpPr>
+        <p:spPr>
+          <a:xfrm>
+            <a:off x="640080" y="1737360"/>
+            <a:ext cx="859536" cy="310896"/>
+          </a:xfrm>
+          <a:prstGeom prst="rect">
+            <a:avLst/>
+          </a:prstGeom>
+          <a:noFill/>
+          <a:ln/>
+        </p:spPr>
+        <p:txBody>
+          <a:bodyPr wrap="square" lIns="0" tIns="0" rIns="0" bIns="0" rtlCol="0" anchor="ctr"/>
+          <a:lstStyle/>
+          <a:p>
+            <a:pPr algn="ctr" indent="0" marL="0">
+              <a:buNone/>
+            </a:pPr>
+            <a:r>
+              <a:rPr lang="zh-CN" altLang="en-US" sz="1200" b="1" dirty="0">
+                <a:solidFill>
+                  <a:srgbClr val="FFFFFF"/>
+                </a:solidFill>
+                <a:latin typeface="HarmonyOS Sans SC" pitchFamily="34" charset="0"/>
+                <a:ea typeface="HarmonyOS Sans SC" pitchFamily="34" charset="-122"/>
+                <a:cs typeface="HarmonyOS Sans SC" pitchFamily="34" charset="-120"/>
+              </a:rPr>
+              <a:t>合入前</a:t>
+            </a:r>
+            <a:endParaRPr lang="zh-CN" sz="1200" dirty="0"/>
+          </a:p>
+        </p:txBody>
+      </p:sp>
+      <p:sp>
+        <p:nvSpPr>
+          <p:cNvPr id="8" name="Text 6"/>
+          <p:cNvSpPr/>
+          <p:nvPr/>
+        </p:nvSpPr>
+        <p:spPr>
+          <a:xfrm>
+            <a:off x="640080" y="2121408"/>
+            <a:ext cx="2514600" cy="548640"/>
+          </a:xfrm>
+          <a:prstGeom prst="rect">
+            <a:avLst/>
+          </a:prstGeom>
+          <a:noFill/>
+          <a:ln/>
+        </p:spPr>
+        <p:txBody>
+          <a:bodyPr wrap="square" lIns="0" tIns="0" rIns="0" bIns="0" rtlCol="0" anchor="t"/>
+          <a:lstStyle/>
+          <a:p>
+            <a:pPr indent="0" marL="0">
+              <a:buNone/>
+            </a:pPr>
+            <a:r>
+              <a:rPr lang="zh-CN" altLang="en-US" sz="1200" dirty="0">
+                <a:solidFill>
+                  <a:srgbClr val="7A859C"/>
+                </a:solidFill>
+                <a:latin typeface="HarmonyOS Sans SC" pitchFamily="34" charset="0"/>
+                <a:ea typeface="HarmonyOS Sans SC" pitchFamily="34" charset="-122"/>
+                <a:cs typeface="HarmonyOS Sans SC" pitchFamily="34" charset="-120"/>
+              </a:rPr>
+              <a:t>iter() 先把整棵树展开成向量，再丢掉不相交的项</a:t>
+            </a:r>
+            <a:endParaRPr lang="zh-CN" sz="1200" dirty="0"/>
+          </a:p>
+        </p:txBody>
+      </p:sp>
+      <p:sp>
+        <p:nvSpPr>
+          <p:cNvPr id="9" name="Shape 7"/>
+          <p:cNvSpPr/>
+          <p:nvPr/>
+        </p:nvSpPr>
+        <p:spPr>
+          <a:xfrm>
+            <a:off x="3337560" y="1691640"/>
+            <a:ext cx="8214055" cy="1188720"/>
+          </a:xfrm>
+          <a:prstGeom prst="roundRect">
+            <a:avLst>
+              <a:gd name="adj" fmla="val 7692"/>
+            </a:avLst>
+          </a:prstGeom>
+          <a:solidFill>
+            <a:srgbClr val="0B1437"/>
+          </a:solidFill>
+          <a:ln w="12700">
+            <a:solidFill>
+              <a:srgbClr val="0B1437"/>
+            </a:solidFill>
+            <a:prstDash val="solid"/>
+          </a:ln>
+        </p:spPr>
+      </p:sp>
+      <p:sp>
+        <p:nvSpPr>
+          <p:cNvPr id="10" name="Text 8"/>
+          <p:cNvSpPr/>
+          <p:nvPr/>
+        </p:nvSpPr>
+        <p:spPr>
+          <a:xfrm>
+            <a:off x="3566160" y="1828800"/>
+            <a:ext cx="7756855" cy="914400"/>
+          </a:xfrm>
+          <a:prstGeom prst="rect">
+            <a:avLst/>
+          </a:prstGeom>
+          <a:noFill/>
+          <a:ln/>
+        </p:spPr>
+        <p:txBody>
+          <a:bodyPr wrap="square" lIns="0" tIns="0" rIns="0" bIns="0" rtlCol="0" anchor="t"/>
+          <a:lstStyle/>
+          <a:p>
+            <a:pPr indent="0" marL="0">
+              <a:spcAft>
+                <a:spcPts val="200"/>
+              </a:spcAft>
+              <a:buNone/>
+            </a:pPr>
+            <a:r>
+              <a:rPr lang="zh-CN" altLang="en-US" sz="1000" dirty="0">
+                <a:solidFill>
+                  <a:srgbClr val="E6EBFA"/>
+                </a:solidFill>
+                <a:latin typeface="JetBrains Mono" pitchFamily="34" charset="0"/>
+                <a:ea typeface="JetBrains Mono" pitchFamily="34" charset="-122"/>
+                <a:cs typeface="JetBrains Mono" pitchFamily="34" charset="-120"/>
+              </a:rPr>
+              <a:t>pub fn lookup_range(&amp;self, range: VirtAddrRange) -&gt; Vec&lt;Arc&lt;VmaSnapshot&gt;&gt; {</a:t>
+            </a:r>
+            <a:endParaRPr lang="zh-CN" sz="1000" dirty="0"/>
+          </a:p>
+          <a:p>
+            <a:pPr indent="0" marL="0">
+              <a:spcAft>
+                <a:spcPts val="200"/>
+              </a:spcAft>
+              <a:buNone/>
+            </a:pPr>
+            <a:r>
+              <a:rPr lang="zh-CN" altLang="en-US" sz="1000" dirty="0">
+                <a:solidFill>
+                  <a:srgbClr val="E6EBFA"/>
+                </a:solidFill>
+                <a:latin typeface="JetBrains Mono" pitchFamily="34" charset="0"/>
+                <a:ea typeface="JetBrains Mono" pitchFamily="34" charset="-122"/>
+                <a:cs typeface="JetBrains Mono" pitchFamily="34" charset="-120"/>
+              </a:rPr>
+              <a:t>    self.iter()</a:t>
+            </a:r>
+            <a:endParaRPr lang="zh-CN" sz="1000" dirty="0"/>
+          </a:p>
+          <a:p>
+            <a:pPr indent="0" marL="0">
+              <a:spcAft>
+                <a:spcPts val="200"/>
+              </a:spcAft>
+              <a:buNone/>
+            </a:pPr>
+            <a:r>
+              <a:rPr lang="zh-CN" altLang="en-US" sz="1000" dirty="0">
+                <a:solidFill>
+                  <a:srgbClr val="E6EBFA"/>
+                </a:solidFill>
+                <a:latin typeface="JetBrains Mono" pitchFamily="34" charset="0"/>
+                <a:ea typeface="JetBrains Mono" pitchFamily="34" charset="-122"/>
+                <a:cs typeface="JetBrains Mono" pitchFamily="34" charset="-120"/>
+              </a:rPr>
+              <a:t>        .filter(|vma| vma.range.overlaps(range))</a:t>
+            </a:r>
+            <a:endParaRPr lang="zh-CN" sz="1000" dirty="0"/>
+          </a:p>
+          <a:p>
+            <a:pPr indent="0" marL="0">
+              <a:spcAft>
+                <a:spcPts val="200"/>
+              </a:spcAft>
+              <a:buNone/>
+            </a:pPr>
+            <a:r>
+              <a:rPr lang="zh-CN" altLang="en-US" sz="1000" dirty="0">
+                <a:solidFill>
+                  <a:srgbClr val="E6EBFA"/>
+                </a:solidFill>
+                <a:latin typeface="JetBrains Mono" pitchFamily="34" charset="0"/>
+                <a:ea typeface="JetBrains Mono" pitchFamily="34" charset="-122"/>
+                <a:cs typeface="JetBrains Mono" pitchFamily="34" charset="-120"/>
+              </a:rPr>
+              <a:t>        .collect()</a:t>
+            </a:r>
+            <a:endParaRPr lang="zh-CN" sz="1000" dirty="0"/>
+          </a:p>
+          <a:p>
+            <a:pPr indent="0" marL="0">
+              <a:spcAft>
+                <a:spcPts val="200"/>
+              </a:spcAft>
+              <a:buNone/>
+            </a:pPr>
+            <a:r>
+              <a:rPr lang="zh-CN" altLang="en-US" sz="1000" dirty="0">
+                <a:solidFill>
+                  <a:srgbClr val="E6EBFA"/>
+                </a:solidFill>
+                <a:latin typeface="JetBrains Mono" pitchFamily="34" charset="0"/>
+                <a:ea typeface="JetBrains Mono" pitchFamily="34" charset="-122"/>
+                <a:cs typeface="JetBrains Mono" pitchFamily="34" charset="-120"/>
+              </a:rPr>
+              <a:t>}</a:t>
+            </a:r>
+            <a:endParaRPr lang="zh-CN" sz="1000" dirty="0"/>
+          </a:p>
+        </p:txBody>
+      </p:sp>
+      <p:sp>
+        <p:nvSpPr>
+          <p:cNvPr id="11" name="Shape 9"/>
+          <p:cNvSpPr/>
+          <p:nvPr/>
+        </p:nvSpPr>
+        <p:spPr>
+          <a:xfrm>
+            <a:off x="640080" y="3035808"/>
+            <a:ext cx="1175004" cy="310896"/>
+          </a:xfrm>
+          <a:prstGeom prst="roundRect">
+            <a:avLst>
+              <a:gd name="adj" fmla="val 23529"/>
+            </a:avLst>
+          </a:prstGeom>
+          <a:solidFill>
+            <a:srgbClr val="0B1437"/>
+          </a:solidFill>
+          <a:ln w="12700">
+            <a:solidFill>
+              <a:srgbClr val="0B1437"/>
+            </a:solidFill>
+            <a:prstDash val="solid"/>
+          </a:ln>
+        </p:spPr>
+      </p:sp>
+      <p:sp>
+        <p:nvSpPr>
+          <p:cNvPr id="12" name="Text 10"/>
+          <p:cNvSpPr/>
+          <p:nvPr/>
+        </p:nvSpPr>
+        <p:spPr>
+          <a:xfrm>
+            <a:off x="640080" y="3035808"/>
+            <a:ext cx="1175004" cy="310896"/>
+          </a:xfrm>
+          <a:prstGeom prst="rect">
+            <a:avLst/>
+          </a:prstGeom>
+          <a:noFill/>
+          <a:ln/>
+        </p:spPr>
+        <p:txBody>
+          <a:bodyPr wrap="square" lIns="0" tIns="0" rIns="0" bIns="0" rtlCol="0" anchor="ctr"/>
+          <a:lstStyle/>
+          <a:p>
+            <a:pPr algn="ctr" indent="0" marL="0">
+              <a:buNone/>
+            </a:pPr>
+            <a:r>
+              <a:rPr lang="zh-CN" altLang="en-US" sz="1200" b="1" dirty="0">
+                <a:solidFill>
+                  <a:srgbClr val="FFFFFF"/>
+                </a:solidFill>
+                <a:latin typeface="HarmonyOS Sans SC" pitchFamily="34" charset="0"/>
+                <a:ea typeface="HarmonyOS Sans SC" pitchFamily="34" charset="-122"/>
+                <a:cs typeface="HarmonyOS Sans SC" pitchFamily="34" charset="-120"/>
+              </a:rPr>
+              <a:t>Linux 7.1</a:t>
+            </a:r>
+            <a:endParaRPr lang="zh-CN" sz="1200" dirty="0"/>
+          </a:p>
+        </p:txBody>
+      </p:sp>
+      <p:sp>
+        <p:nvSpPr>
+          <p:cNvPr id="13" name="Text 11"/>
+          <p:cNvSpPr/>
+          <p:nvPr/>
+        </p:nvSpPr>
+        <p:spPr>
+          <a:xfrm>
+            <a:off x="640080" y="3419856"/>
+            <a:ext cx="2514600" cy="548640"/>
+          </a:xfrm>
+          <a:prstGeom prst="rect">
+            <a:avLst/>
+          </a:prstGeom>
+          <a:noFill/>
+          <a:ln/>
+        </p:spPr>
+        <p:txBody>
+          <a:bodyPr wrap="square" lIns="0" tIns="0" rIns="0" bIns="0" rtlCol="0" anchor="t"/>
+          <a:lstStyle/>
+          <a:p>
+            <a:pPr indent="0" marL="0">
+              <a:buNone/>
+            </a:pPr>
+            <a:r>
+              <a:rPr lang="zh-CN" altLang="en-US" sz="1200" dirty="0">
+                <a:solidFill>
+                  <a:srgbClr val="7A859C"/>
+                </a:solidFill>
+                <a:latin typeface="HarmonyOS Sans SC" pitchFamily="34" charset="0"/>
+                <a:ea typeface="HarmonyOS Sans SC" pitchFamily="34" charset="-122"/>
+                <a:cs typeface="HarmonyOS Sans SC" pitchFamily="34" charset="-120"/>
+              </a:rPr>
+              <a:t>find_vma_intersection()，mm/mmap.c 第 888 至 891 行</a:t>
+            </a:r>
+            <a:endParaRPr lang="zh-CN" sz="1200" dirty="0"/>
+          </a:p>
+        </p:txBody>
+      </p:sp>
+      <p:sp>
+        <p:nvSpPr>
+          <p:cNvPr id="14" name="Shape 12"/>
+          <p:cNvSpPr/>
+          <p:nvPr/>
+        </p:nvSpPr>
+        <p:spPr>
+          <a:xfrm>
+            <a:off x="3337560" y="2990088"/>
+            <a:ext cx="8214055" cy="1005840"/>
+          </a:xfrm>
+          <a:prstGeom prst="roundRect">
+            <a:avLst>
+              <a:gd name="adj" fmla="val 9091"/>
+            </a:avLst>
+          </a:prstGeom>
+          <a:solidFill>
+            <a:srgbClr val="0B1437"/>
+          </a:solidFill>
+          <a:ln w="12700">
+            <a:solidFill>
+              <a:srgbClr val="0B1437"/>
+            </a:solidFill>
+            <a:prstDash val="solid"/>
+          </a:ln>
+        </p:spPr>
+      </p:sp>
+      <p:sp>
+        <p:nvSpPr>
+          <p:cNvPr id="15" name="Text 13"/>
+          <p:cNvSpPr/>
+          <p:nvPr/>
+        </p:nvSpPr>
+        <p:spPr>
+          <a:xfrm>
+            <a:off x="3566160" y="3127248"/>
+            <a:ext cx="7756855" cy="731520"/>
+          </a:xfrm>
+          <a:prstGeom prst="rect">
+            <a:avLst/>
+          </a:prstGeom>
+          <a:noFill/>
+          <a:ln/>
+        </p:spPr>
+        <p:txBody>
+          <a:bodyPr wrap="square" lIns="0" tIns="0" rIns="0" bIns="0" rtlCol="0" anchor="t"/>
+          <a:lstStyle/>
+          <a:p>
+            <a:pPr indent="0" marL="0">
+              <a:spcAft>
+                <a:spcPts val="200"/>
+              </a:spcAft>
+              <a:buNone/>
+            </a:pPr>
+            <a:r>
+              <a:rPr lang="zh-CN" altLang="en-US" sz="1000" dirty="0">
+                <a:solidFill>
+                  <a:srgbClr val="E6EBFA"/>
+                </a:solidFill>
+                <a:latin typeface="JetBrains Mono" pitchFamily="34" charset="0"/>
+                <a:ea typeface="JetBrains Mono" pitchFamily="34" charset="-122"/>
+                <a:cs typeface="JetBrains Mono" pitchFamily="34" charset="-120"/>
+              </a:rPr>
+              <a:t>unsigned long index = start_addr;</a:t>
+            </a:r>
+            <a:endParaRPr lang="zh-CN" sz="1000" dirty="0"/>
+          </a:p>
+          <a:p>
+            <a:pPr indent="0" marL="0">
+              <a:spcAft>
+                <a:spcPts val="200"/>
+              </a:spcAft>
+              <a:buNone/>
+            </a:pPr>
+            <a:endParaRPr lang="zh-CN" sz="1000" dirty="0"/>
+          </a:p>
+          <a:p>
+            <a:pPr indent="0" marL="0">
+              <a:spcAft>
+                <a:spcPts val="200"/>
+              </a:spcAft>
+              <a:buNone/>
+            </a:pPr>
+            <a:r>
+              <a:rPr lang="zh-CN" altLang="en-US" sz="1000" dirty="0">
+                <a:solidFill>
+                  <a:srgbClr val="E6EBFA"/>
+                </a:solidFill>
+                <a:latin typeface="JetBrains Mono" pitchFamily="34" charset="0"/>
+                <a:ea typeface="JetBrains Mono" pitchFamily="34" charset="-122"/>
+                <a:cs typeface="JetBrains Mono" pitchFamily="34" charset="-120"/>
+              </a:rPr>
+              <a:t>mmap_assert_locked(mm);</a:t>
+            </a:r>
+            <a:endParaRPr lang="zh-CN" sz="1000" dirty="0"/>
+          </a:p>
+          <a:p>
+            <a:pPr indent="0" marL="0">
+              <a:spcAft>
+                <a:spcPts val="200"/>
+              </a:spcAft>
+              <a:buNone/>
+            </a:pPr>
+            <a:r>
+              <a:rPr lang="zh-CN" altLang="en-US" sz="1000" dirty="0">
+                <a:solidFill>
+                  <a:srgbClr val="E6EBFA"/>
+                </a:solidFill>
+                <a:latin typeface="JetBrains Mono" pitchFamily="34" charset="0"/>
+                <a:ea typeface="JetBrains Mono" pitchFamily="34" charset="-122"/>
+                <a:cs typeface="JetBrains Mono" pitchFamily="34" charset="-120"/>
+              </a:rPr>
+              <a:t>return mt_find(&amp;mm-&gt;mm_mt, &amp;index, end_addr - 1);</a:t>
+            </a:r>
+            <a:endParaRPr lang="zh-CN" sz="1000" dirty="0"/>
+          </a:p>
+        </p:txBody>
+      </p:sp>
+      <p:sp>
+        <p:nvSpPr>
+          <p:cNvPr id="16" name="Shape 14"/>
+          <p:cNvSpPr/>
+          <p:nvPr/>
+        </p:nvSpPr>
+        <p:spPr>
+          <a:xfrm>
+            <a:off x="640080" y="4151376"/>
+            <a:ext cx="859536" cy="310896"/>
+          </a:xfrm>
+          <a:prstGeom prst="roundRect">
+            <a:avLst>
+              <a:gd name="adj" fmla="val 23529"/>
+            </a:avLst>
+          </a:prstGeom>
+          <a:solidFill>
+            <a:srgbClr val="1FA896"/>
+          </a:solidFill>
+          <a:ln w="12700">
+            <a:solidFill>
+              <a:srgbClr val="1FA896"/>
+            </a:solidFill>
+            <a:prstDash val="solid"/>
+          </a:ln>
+        </p:spPr>
+      </p:sp>
+      <p:sp>
+        <p:nvSpPr>
+          <p:cNvPr id="17" name="Text 15"/>
+          <p:cNvSpPr/>
+          <p:nvPr/>
+        </p:nvSpPr>
+        <p:spPr>
+          <a:xfrm>
+            <a:off x="640080" y="4151376"/>
+            <a:ext cx="859536" cy="310896"/>
+          </a:xfrm>
+          <a:prstGeom prst="rect">
+            <a:avLst/>
+          </a:prstGeom>
+          <a:noFill/>
+          <a:ln/>
+        </p:spPr>
+        <p:txBody>
+          <a:bodyPr wrap="square" lIns="0" tIns="0" rIns="0" bIns="0" rtlCol="0" anchor="ctr"/>
+          <a:lstStyle/>
+          <a:p>
+            <a:pPr algn="ctr" indent="0" marL="0">
+              <a:buNone/>
+            </a:pPr>
+            <a:r>
+              <a:rPr lang="zh-CN" altLang="en-US" sz="1200" b="1" dirty="0">
+                <a:solidFill>
+                  <a:srgbClr val="FFFFFF"/>
+                </a:solidFill>
+                <a:latin typeface="HarmonyOS Sans SC" pitchFamily="34" charset="0"/>
+                <a:ea typeface="HarmonyOS Sans SC" pitchFamily="34" charset="-122"/>
+                <a:cs typeface="HarmonyOS Sans SC" pitchFamily="34" charset="-120"/>
+              </a:rPr>
+              <a:t>合入后</a:t>
+            </a:r>
+            <a:endParaRPr lang="zh-CN" sz="1200" dirty="0"/>
+          </a:p>
+        </p:txBody>
+      </p:sp>
+      <p:sp>
+        <p:nvSpPr>
+          <p:cNvPr id="18" name="Text 16"/>
+          <p:cNvSpPr/>
+          <p:nvPr/>
+        </p:nvSpPr>
+        <p:spPr>
+          <a:xfrm>
+            <a:off x="640080" y="4535424"/>
+            <a:ext cx="2514600" cy="548640"/>
+          </a:xfrm>
+          <a:prstGeom prst="rect">
+            <a:avLst/>
+          </a:prstGeom>
+          <a:noFill/>
+          <a:ln/>
+        </p:spPr>
+        <p:txBody>
+          <a:bodyPr wrap="square" lIns="0" tIns="0" rIns="0" bIns="0" rtlCol="0" anchor="t"/>
+          <a:lstStyle/>
+          <a:p>
+            <a:pPr indent="0" marL="0">
+              <a:buNone/>
+            </a:pPr>
+            <a:r>
+              <a:rPr lang="zh-CN" altLang="en-US" sz="1200" dirty="0">
+                <a:solidFill>
+                  <a:srgbClr val="7A859C"/>
+                </a:solidFill>
+                <a:latin typeface="HarmonyOS Sans SC" pitchFamily="34" charset="0"/>
+                <a:ea typeface="HarmonyOS Sans SC" pitchFamily="34" charset="-122"/>
+                <a:cs typeface="HarmonyOS Sans SC" pitchFamily="34" charset="-120"/>
+              </a:rPr>
+              <a:t>沿树下降，只访问与区间相交的节点</a:t>
+            </a:r>
+            <a:endParaRPr lang="zh-CN" sz="1200" dirty="0"/>
+          </a:p>
+        </p:txBody>
+      </p:sp>
+      <p:sp>
+        <p:nvSpPr>
+          <p:cNvPr id="19" name="Shape 17"/>
+          <p:cNvSpPr/>
+          <p:nvPr/>
+        </p:nvSpPr>
+        <p:spPr>
+          <a:xfrm>
+            <a:off x="3337560" y="4105656"/>
+            <a:ext cx="8214055" cy="1920240"/>
+          </a:xfrm>
+          <a:prstGeom prst="roundRect">
+            <a:avLst>
+              <a:gd name="adj" fmla="val 4762"/>
+            </a:avLst>
+          </a:prstGeom>
+          <a:solidFill>
+            <a:srgbClr val="0B1437"/>
+          </a:solidFill>
+          <a:ln w="12700">
+            <a:solidFill>
+              <a:srgbClr val="0B1437"/>
+            </a:solidFill>
+            <a:prstDash val="solid"/>
+          </a:ln>
+        </p:spPr>
+      </p:sp>
+      <p:sp>
+        <p:nvSpPr>
+          <p:cNvPr id="20" name="Text 18"/>
+          <p:cNvSpPr/>
+          <p:nvPr/>
+        </p:nvSpPr>
+        <p:spPr>
+          <a:xfrm>
+            <a:off x="3566160" y="4242816"/>
+            <a:ext cx="7756855" cy="1645920"/>
+          </a:xfrm>
+          <a:prstGeom prst="rect">
+            <a:avLst/>
+          </a:prstGeom>
+          <a:noFill/>
+          <a:ln/>
+        </p:spPr>
+        <p:txBody>
+          <a:bodyPr wrap="square" lIns="0" tIns="0" rIns="0" bIns="0" rtlCol="0" anchor="t"/>
+          <a:lstStyle/>
+          <a:p>
+            <a:pPr indent="0" marL="0">
+              <a:spcAft>
+                <a:spcPts val="200"/>
+              </a:spcAft>
+              <a:buNone/>
+            </a:pPr>
+            <a:r>
+              <a:rPr lang="zh-CN" altLang="en-US" sz="1000" dirty="0">
+                <a:solidFill>
+                  <a:srgbClr val="E6EBFA"/>
+                </a:solidFill>
+                <a:latin typeface="JetBrains Mono" pitchFamily="34" charset="0"/>
+                <a:ea typeface="JetBrains Mono" pitchFamily="34" charset="-122"/>
+                <a:cs typeface="JetBrains Mono" pitchFamily="34" charset="-120"/>
+              </a:rPr>
+              <a:t>let vma = current.entry.snapshot.range;</a:t>
+            </a:r>
+            <a:endParaRPr lang="zh-CN" sz="1000" dirty="0"/>
+          </a:p>
+          <a:p>
+            <a:pPr indent="0" marL="0">
+              <a:spcAft>
+                <a:spcPts val="200"/>
+              </a:spcAft>
+              <a:buNone/>
+            </a:pPr>
+            <a:r>
+              <a:rPr lang="zh-CN" altLang="en-US" sz="1000" dirty="0">
+                <a:solidFill>
+                  <a:srgbClr val="E6EBFA"/>
+                </a:solidFill>
+                <a:latin typeface="JetBrains Mono" pitchFamily="34" charset="0"/>
+                <a:ea typeface="JetBrains Mono" pitchFamily="34" charset="-122"/>
+                <a:cs typeface="JetBrains Mono" pitchFamily="34" charset="-120"/>
+              </a:rPr>
+              <a:t>if range.start &lt; vma.start</a:t>
+            </a:r>
+            <a:endParaRPr lang="zh-CN" sz="1000" dirty="0"/>
+          </a:p>
+          <a:p>
+            <a:pPr indent="0" marL="0">
+              <a:spcAft>
+                <a:spcPts val="200"/>
+              </a:spcAft>
+              <a:buNone/>
+            </a:pPr>
+            <a:r>
+              <a:rPr lang="zh-CN" altLang="en-US" sz="1000" dirty="0">
+                <a:solidFill>
+                  <a:srgbClr val="E6EBFA"/>
+                </a:solidFill>
+                <a:latin typeface="JetBrains Mono" pitchFamily="34" charset="0"/>
+                <a:ea typeface="JetBrains Mono" pitchFamily="34" charset="-122"/>
+                <a:cs typeface="JetBrains Mono" pitchFamily="34" charset="-120"/>
+              </a:rPr>
+              <a:t>    &amp;&amp; !Self::visit_overlapping(&amp;current.left, range, visited, visit)</a:t>
+            </a:r>
+            <a:endParaRPr lang="zh-CN" sz="1000" dirty="0"/>
+          </a:p>
+          <a:p>
+            <a:pPr indent="0" marL="0">
+              <a:spcAft>
+                <a:spcPts val="200"/>
+              </a:spcAft>
+              <a:buNone/>
+            </a:pPr>
+            <a:r>
+              <a:rPr lang="zh-CN" altLang="en-US" sz="1000" dirty="0">
+                <a:solidFill>
+                  <a:srgbClr val="E6EBFA"/>
+                </a:solidFill>
+                <a:latin typeface="JetBrains Mono" pitchFamily="34" charset="0"/>
+                <a:ea typeface="JetBrains Mono" pitchFamily="34" charset="-122"/>
+                <a:cs typeface="JetBrains Mono" pitchFamily="34" charset="-120"/>
+              </a:rPr>
+              <a:t>{</a:t>
+            </a:r>
+            <a:endParaRPr lang="zh-CN" sz="1000" dirty="0"/>
+          </a:p>
+          <a:p>
+            <a:pPr indent="0" marL="0">
+              <a:spcAft>
+                <a:spcPts val="200"/>
+              </a:spcAft>
+              <a:buNone/>
+            </a:pPr>
+            <a:r>
+              <a:rPr lang="zh-CN" altLang="en-US" sz="1000" dirty="0">
+                <a:solidFill>
+                  <a:srgbClr val="E6EBFA"/>
+                </a:solidFill>
+                <a:latin typeface="JetBrains Mono" pitchFamily="34" charset="0"/>
+                <a:ea typeface="JetBrains Mono" pitchFamily="34" charset="-122"/>
+                <a:cs typeface="JetBrains Mono" pitchFamily="34" charset="-120"/>
+              </a:rPr>
+              <a:t>    return false;</a:t>
+            </a:r>
+            <a:endParaRPr lang="zh-CN" sz="1000" dirty="0"/>
+          </a:p>
+          <a:p>
+            <a:pPr indent="0" marL="0">
+              <a:spcAft>
+                <a:spcPts val="200"/>
+              </a:spcAft>
+              <a:buNone/>
+            </a:pPr>
+            <a:r>
+              <a:rPr lang="zh-CN" altLang="en-US" sz="1000" dirty="0">
+                <a:solidFill>
+                  <a:srgbClr val="E6EBFA"/>
+                </a:solidFill>
+                <a:latin typeface="JetBrains Mono" pitchFamily="34" charset="0"/>
+                <a:ea typeface="JetBrains Mono" pitchFamily="34" charset="-122"/>
+                <a:cs typeface="JetBrains Mono" pitchFamily="34" charset="-120"/>
+              </a:rPr>
+              <a:t>}</a:t>
+            </a:r>
+            <a:endParaRPr lang="zh-CN" sz="1000" dirty="0"/>
+          </a:p>
+          <a:p>
+            <a:pPr indent="0" marL="0">
+              <a:spcAft>
+                <a:spcPts val="200"/>
+              </a:spcAft>
+              <a:buNone/>
+            </a:pPr>
+            <a:r>
+              <a:rPr lang="zh-CN" altLang="en-US" sz="1000" dirty="0">
+                <a:solidFill>
+                  <a:srgbClr val="E6EBFA"/>
+                </a:solidFill>
+                <a:latin typeface="JetBrains Mono" pitchFamily="34" charset="0"/>
+                <a:ea typeface="JetBrains Mono" pitchFamily="34" charset="-122"/>
+                <a:cs typeface="JetBrains Mono" pitchFamily="34" charset="-120"/>
+              </a:rPr>
+              <a:t>if vma.overlaps(range) &amp;&amp; !visit(&amp;current.entry) {</a:t>
+            </a:r>
+            <a:endParaRPr lang="zh-CN" sz="1000" dirty="0"/>
+          </a:p>
+          <a:p>
+            <a:pPr indent="0" marL="0">
+              <a:spcAft>
+                <a:spcPts val="200"/>
+              </a:spcAft>
+              <a:buNone/>
+            </a:pPr>
+            <a:r>
+              <a:rPr lang="zh-CN" altLang="en-US" sz="1000" dirty="0">
+                <a:solidFill>
+                  <a:srgbClr val="E6EBFA"/>
+                </a:solidFill>
+                <a:latin typeface="JetBrains Mono" pitchFamily="34" charset="0"/>
+                <a:ea typeface="JetBrains Mono" pitchFamily="34" charset="-122"/>
+                <a:cs typeface="JetBrains Mono" pitchFamily="34" charset="-120"/>
+              </a:rPr>
+              <a:t>    return false;</a:t>
+            </a:r>
+            <a:endParaRPr lang="zh-CN" sz="1000" dirty="0"/>
+          </a:p>
+          <a:p>
+            <a:pPr indent="0" marL="0">
+              <a:spcAft>
+                <a:spcPts val="200"/>
+              </a:spcAft>
+              <a:buNone/>
+            </a:pPr>
+            <a:r>
+              <a:rPr lang="zh-CN" altLang="en-US" sz="1000" dirty="0">
+                <a:solidFill>
+                  <a:srgbClr val="E6EBFA"/>
+                </a:solidFill>
+                <a:latin typeface="JetBrains Mono" pitchFamily="34" charset="0"/>
+                <a:ea typeface="JetBrains Mono" pitchFamily="34" charset="-122"/>
+                <a:cs typeface="JetBrains Mono" pitchFamily="34" charset="-120"/>
+              </a:rPr>
+              <a:t>}</a:t>
+            </a:r>
+            <a:endParaRPr lang="zh-CN" sz="1000" dirty="0"/>
+          </a:p>
+        </p:txBody>
+      </p:sp>
+      <p:sp>
+        <p:nvSpPr>
+          <p:cNvPr id="21" name="Text 19"/>
+          <p:cNvSpPr/>
+          <p:nvPr/>
+        </p:nvSpPr>
+        <p:spPr>
+          <a:xfrm>
+            <a:off x="640080" y="6108192"/>
+            <a:ext cx="10180015" cy="365760"/>
+          </a:xfrm>
+          <a:prstGeom prst="rect">
+            <a:avLst/>
+          </a:prstGeom>
+          <a:noFill/>
+          <a:ln/>
+        </p:spPr>
+        <p:txBody>
+          <a:bodyPr wrap="square" lIns="0" tIns="0" rIns="0" bIns="0" rtlCol="0" anchor="ctr"/>
+          <a:lstStyle/>
+          <a:p>
+            <a:pPr indent="0" marL="0">
+              <a:buNone/>
+            </a:pPr>
+            <a:r>
+              <a:rPr lang="zh-CN" altLang="en-US" sz="1300" dirty="0">
+                <a:solidFill>
+                  <a:srgbClr val="7A859C"/>
+                </a:solidFill>
+                <a:latin typeface="HarmonyOS Sans SC" pitchFamily="34" charset="0"/>
+                <a:ea typeface="HarmonyOS Sans SC" pitchFamily="34" charset="-122"/>
+                <a:cs typeface="HarmonyOS Sans SC" pitchFamily="34" charset="-120"/>
+              </a:rPr>
+              <a:t>256 个 VMA 的树里查 1 个：访问的节点数从 256 降到搜索路径的长度。</a:t>
+            </a:r>
+            <a:endParaRPr lang="zh-CN" sz="1300" dirty="0"/>
+          </a:p>
+        </p:txBody>
+      </p:sp>
+    </p:spTree>
+  </p:cSld>
+  <p:clrMapOvr>
+    <a:masterClrMapping/>
+  </p:clrMapOvr>
+</p:sld>
+</file>
+
+<file path=ppt/slides/slide36.xml><?xml version="1.0" encoding="utf-8"?>
+<p:sld xmlns:a="http://schemas.openxmlformats.org/drawingml/2006/main" xmlns:r="http://schemas.openxmlformats.org/officeDocument/2006/relationships" xmlns:p="http://schemas.openxmlformats.org/presentationml/2006/main">
+  <p:cSld name="Slide 36">
+    <p:bg>
+      <p:bgPr>
+        <a:solidFill>
+          <a:srgbClr val="FFFFFF"/>
+        </a:solidFill>
+      </p:bgPr>
+    </p:bg>
+    <p:spTree>
+      <p:nvGrpSpPr>
+        <p:cNvPr id="1" name=""/>
+        <p:cNvGrpSpPr/>
+        <p:nvPr/>
+      </p:nvGrpSpPr>
+      <p:grpSpPr>
+        <a:xfrm>
+          <a:off x="0" y="0"/>
+          <a:ext cx="0" cy="0"/>
+          <a:chOff x="0" y="0"/>
+          <a:chExt cx="0" cy="0"/>
+        </a:xfrm>
+      </p:grpSpPr>
+      <p:sp>
+        <p:nvSpPr>
+          <p:cNvPr id="2" name="Shape 0"/>
+          <p:cNvSpPr/>
+          <p:nvPr/>
+        </p:nvSpPr>
+        <p:spPr>
+          <a:xfrm>
+            <a:off x="640080" y="457200"/>
+            <a:ext cx="201168" cy="201168"/>
+          </a:xfrm>
+          <a:prstGeom prst="star4">
+            <a:avLst/>
+          </a:prstGeom>
+          <a:solidFill>
+            <a:srgbClr val="F2B441"/>
+          </a:solidFill>
+          <a:ln w="12700">
+            <a:solidFill>
+              <a:srgbClr val="F2B441"/>
+            </a:solidFill>
+            <a:prstDash val="solid"/>
+          </a:ln>
+        </p:spPr>
+      </p:sp>
+      <p:sp>
+        <p:nvSpPr>
+          <p:cNvPr id="3" name="Text 1"/>
+          <p:cNvSpPr/>
+          <p:nvPr/>
+        </p:nvSpPr>
+        <p:spPr>
+          <a:xfrm>
+            <a:off x="932688" y="402336"/>
+            <a:ext cx="7315200" cy="310896"/>
+          </a:xfrm>
+          <a:prstGeom prst="rect">
+            <a:avLst/>
+          </a:prstGeom>
+          <a:noFill/>
+          <a:ln/>
+        </p:spPr>
+        <p:txBody>
+          <a:bodyPr wrap="square" lIns="0" tIns="0" rIns="0" bIns="0" rtlCol="0" anchor="ctr"/>
+          <a:lstStyle/>
+          <a:p>
+            <a:pPr indent="0" marL="0">
+              <a:buNone/>
+            </a:pPr>
+            <a:r>
+              <a:rPr lang="zh-CN" altLang="en-US" sz="1200" b="1" dirty="0">
+                <a:solidFill>
+                  <a:srgbClr val="7A859C"/>
+                </a:solidFill>
+                <a:latin typeface="HarmonyOS Sans SC" pitchFamily="34" charset="0"/>
+                <a:ea typeface="HarmonyOS Sans SC" pitchFamily="34" charset="-122"/>
+                <a:cs typeface="HarmonyOS Sans SC" pitchFamily="34" charset="-120"/>
+              </a:rPr>
+              <a:t>05 溯源 · 源码对照</a:t>
+            </a:r>
+            <a:endParaRPr lang="zh-CN" sz="1200" dirty="0"/>
+          </a:p>
+        </p:txBody>
+      </p:sp>
+      <p:sp>
+        <p:nvSpPr>
+          <p:cNvPr id="4" name="Text 2"/>
+          <p:cNvSpPr/>
+          <p:nvPr/>
+        </p:nvSpPr>
+        <p:spPr>
+          <a:xfrm>
+            <a:off x="640080" y="786384"/>
+            <a:ext cx="10911535" cy="731520"/>
+          </a:xfrm>
+          <a:prstGeom prst="rect">
+            <a:avLst/>
+          </a:prstGeom>
+          <a:noFill/>
+          <a:ln/>
+        </p:spPr>
+        <p:txBody>
+          <a:bodyPr wrap="square" lIns="0" tIns="0" rIns="0" bIns="0" rtlCol="0" anchor="ctr"/>
+          <a:lstStyle/>
+          <a:p>
+            <a:pPr indent="0" marL="0">
+              <a:buNone/>
+            </a:pPr>
+            <a:r>
+              <a:rPr lang="zh-CN" altLang="en-US" sz="3000" b="1" dirty="0">
+                <a:solidFill>
+                  <a:srgbClr val="1B2340"/>
+                </a:solidFill>
+                <a:latin typeface="HarmonyOS Sans SC" pitchFamily="34" charset="0"/>
+                <a:ea typeface="HarmonyOS Sans SC" pitchFamily="34" charset="-122"/>
+                <a:cs typeface="HarmonyOS Sans SC" pitchFamily="34" charset="-120"/>
+              </a:rPr>
+              <a:t>FIFO 的非阻塞写打开（#720）</a:t>
+            </a:r>
+            <a:endParaRPr lang="zh-CN" sz="3000" dirty="0"/>
+          </a:p>
+        </p:txBody>
+      </p:sp>
+      <p:sp>
+        <p:nvSpPr>
+          <p:cNvPr id="5" name="Text 3"/>
+          <p:cNvSpPr/>
+          <p:nvPr/>
+        </p:nvSpPr>
+        <p:spPr>
+          <a:xfrm>
+            <a:off x="11002975" y="6400800"/>
+            <a:ext cx="548640" cy="274320"/>
+          </a:xfrm>
+          <a:prstGeom prst="rect">
+            <a:avLst/>
+          </a:prstGeom>
+          <a:noFill/>
+          <a:ln/>
+        </p:spPr>
+        <p:txBody>
+          <a:bodyPr wrap="square" lIns="0" tIns="0" rIns="0" bIns="0" rtlCol="0" anchor="ctr"/>
+          <a:lstStyle/>
+          <a:p>
+            <a:pPr algn="r" indent="0" marL="0">
+              <a:buNone/>
+            </a:pPr>
+            <a:r>
+              <a:rPr lang="zh-CN" altLang="en-US" sz="1000" dirty="0">
+                <a:solidFill>
+                  <a:srgbClr val="7A859C"/>
+                </a:solidFill>
+                <a:latin typeface="JetBrains Mono" pitchFamily="34" charset="0"/>
+                <a:ea typeface="JetBrains Mono" pitchFamily="34" charset="-122"/>
+                <a:cs typeface="JetBrains Mono" pitchFamily="34" charset="-120"/>
+              </a:rPr>
+              <a:t>36</a:t>
+            </a:r>
+            <a:endParaRPr lang="zh-CN" sz="1000" dirty="0"/>
+          </a:p>
+        </p:txBody>
+      </p:sp>
+      <p:sp>
+        <p:nvSpPr>
+          <p:cNvPr id="6" name="Shape 4"/>
+          <p:cNvSpPr/>
+          <p:nvPr/>
+        </p:nvSpPr>
+        <p:spPr>
+          <a:xfrm>
+            <a:off x="640080" y="1737360"/>
+            <a:ext cx="781812" cy="310896"/>
+          </a:xfrm>
+          <a:prstGeom prst="roundRect">
+            <a:avLst>
+              <a:gd name="adj" fmla="val 23529"/>
+            </a:avLst>
+          </a:prstGeom>
+          <a:solidFill>
+            <a:srgbClr val="E2604F"/>
+          </a:solidFill>
+          <a:ln w="12700">
+            <a:solidFill>
+              <a:srgbClr val="E2604F"/>
+            </a:solidFill>
+            <a:prstDash val="solid"/>
+          </a:ln>
+        </p:spPr>
+      </p:sp>
+      <p:sp>
+        <p:nvSpPr>
+          <p:cNvPr id="7" name="Text 5"/>
+          <p:cNvSpPr/>
+          <p:nvPr/>
+        </p:nvSpPr>
+        <p:spPr>
+          <a:xfrm>
+            <a:off x="640080" y="1737360"/>
+            <a:ext cx="781812" cy="310896"/>
+          </a:xfrm>
+          <a:prstGeom prst="rect">
+            <a:avLst/>
+          </a:prstGeom>
+          <a:noFill/>
+          <a:ln/>
+        </p:spPr>
+        <p:txBody>
+          <a:bodyPr wrap="square" lIns="0" tIns="0" rIns="0" bIns="0" rtlCol="0" anchor="ctr"/>
+          <a:lstStyle/>
+          <a:p>
+            <a:pPr algn="ctr" indent="0" marL="0">
+              <a:buNone/>
+            </a:pPr>
+            <a:r>
+              <a:rPr lang="zh-CN" altLang="en-US" sz="1200" b="1" dirty="0">
+                <a:solidFill>
+                  <a:srgbClr val="FFFFFF"/>
+                </a:solidFill>
+                <a:latin typeface="HarmonyOS Sans SC" pitchFamily="34" charset="0"/>
+                <a:ea typeface="HarmonyOS Sans SC" pitchFamily="34" charset="-122"/>
+                <a:cs typeface="HarmonyOS Sans SC" pitchFamily="34" charset="-120"/>
+              </a:rPr>
+              <a:t>本 PR</a:t>
+            </a:r>
+            <a:endParaRPr lang="zh-CN" sz="1200" dirty="0"/>
+          </a:p>
+        </p:txBody>
+      </p:sp>
+      <p:sp>
+        <p:nvSpPr>
+          <p:cNvPr id="8" name="Text 6"/>
+          <p:cNvSpPr/>
+          <p:nvPr/>
+        </p:nvSpPr>
+        <p:spPr>
+          <a:xfrm>
+            <a:off x="640080" y="2121408"/>
+            <a:ext cx="2514600" cy="548640"/>
+          </a:xfrm>
+          <a:prstGeom prst="rect">
+            <a:avLst/>
+          </a:prstGeom>
+          <a:noFill/>
+          <a:ln/>
+        </p:spPr>
+        <p:txBody>
+          <a:bodyPr wrap="square" lIns="0" tIns="0" rIns="0" bIns="0" rtlCol="0" anchor="t"/>
+          <a:lstStyle/>
+          <a:p>
+            <a:pPr indent="0" marL="0">
+              <a:buNone/>
+            </a:pPr>
+            <a:r>
+              <a:rPr lang="zh-CN" altLang="en-US" sz="1200" dirty="0">
+                <a:solidFill>
+                  <a:srgbClr val="7A859C"/>
+                </a:solidFill>
+                <a:latin typeface="HarmonyOS Sans SC" pitchFamily="34" charset="0"/>
+                <a:ea typeface="HarmonyOS Sans SC" pitchFamily="34" charset="-122"/>
+                <a:cs typeface="HarmonyOS Sans SC" pitchFamily="34" charset="-120"/>
+              </a:rPr>
+              <a:t>2026-05 合入：不看有没有读端，一律返回 ENXIO</a:t>
+            </a:r>
+            <a:endParaRPr lang="zh-CN" sz="1200" dirty="0"/>
+          </a:p>
+        </p:txBody>
+      </p:sp>
+      <p:sp>
+        <p:nvSpPr>
+          <p:cNvPr id="9" name="Shape 7"/>
+          <p:cNvSpPr/>
+          <p:nvPr/>
+        </p:nvSpPr>
+        <p:spPr>
+          <a:xfrm>
+            <a:off x="3337560" y="1691640"/>
+            <a:ext cx="8214055" cy="1737360"/>
+          </a:xfrm>
+          <a:prstGeom prst="roundRect">
+            <a:avLst>
+              <a:gd name="adj" fmla="val 5263"/>
+            </a:avLst>
+          </a:prstGeom>
+          <a:solidFill>
+            <a:srgbClr val="0B1437"/>
+          </a:solidFill>
+          <a:ln w="12700">
+            <a:solidFill>
+              <a:srgbClr val="0B1437"/>
+            </a:solidFill>
+            <a:prstDash val="solid"/>
+          </a:ln>
+        </p:spPr>
+      </p:sp>
+      <p:sp>
+        <p:nvSpPr>
+          <p:cNvPr id="10" name="Text 8"/>
+          <p:cNvSpPr/>
+          <p:nvPr/>
+        </p:nvSpPr>
+        <p:spPr>
+          <a:xfrm>
+            <a:off x="3566160" y="1828800"/>
+            <a:ext cx="7756855" cy="1463040"/>
+          </a:xfrm>
+          <a:prstGeom prst="rect">
+            <a:avLst/>
+          </a:prstGeom>
+          <a:noFill/>
+          <a:ln/>
+        </p:spPr>
+        <p:txBody>
+          <a:bodyPr wrap="square" lIns="0" tIns="0" rIns="0" bIns="0" rtlCol="0" anchor="t"/>
+          <a:lstStyle/>
+          <a:p>
+            <a:pPr indent="0" marL="0">
+              <a:spcAft>
+                <a:spcPts val="200"/>
+              </a:spcAft>
+              <a:buNone/>
+            </a:pPr>
+            <a:r>
+              <a:rPr lang="zh-CN" altLang="en-US" sz="1000" dirty="0">
+                <a:solidFill>
+                  <a:srgbClr val="E6EBFA"/>
+                </a:solidFill>
+                <a:latin typeface="JetBrains Mono" pitchFamily="34" charset="0"/>
+                <a:ea typeface="JetBrains Mono" pitchFamily="34" charset="-122"/>
+                <a:cs typeface="JetBrains Mono" pitchFamily="34" charset="-120"/>
+              </a:rPr>
+              <a:t>if flags &amp; O_NONBLOCK != 0</a:t>
+            </a:r>
+            <a:endParaRPr lang="zh-CN" sz="1000" dirty="0"/>
+          </a:p>
+          <a:p>
+            <a:pPr indent="0" marL="0">
+              <a:spcAft>
+                <a:spcPts val="200"/>
+              </a:spcAft>
+              <a:buNone/>
+            </a:pPr>
+            <a:r>
+              <a:rPr lang="zh-CN" altLang="en-US" sz="1000" dirty="0">
+                <a:solidFill>
+                  <a:srgbClr val="E6EBFA"/>
+                </a:solidFill>
+                <a:latin typeface="JetBrains Mono" pitchFamily="34" charset="0"/>
+                <a:ea typeface="JetBrains Mono" pitchFamily="34" charset="-122"/>
+                <a:cs typeface="JetBrains Mono" pitchFamily="34" charset="-120"/>
+              </a:rPr>
+              <a:t>    &amp;&amp; flags &amp; 0b11 == O_WRONLY</a:t>
+            </a:r>
+            <a:endParaRPr lang="zh-CN" sz="1000" dirty="0"/>
+          </a:p>
+          <a:p>
+            <a:pPr indent="0" marL="0">
+              <a:spcAft>
+                <a:spcPts val="200"/>
+              </a:spcAft>
+              <a:buNone/>
+            </a:pPr>
+            <a:r>
+              <a:rPr lang="zh-CN" altLang="en-US" sz="1000" dirty="0">
+                <a:solidFill>
+                  <a:srgbClr val="E6EBFA"/>
+                </a:solidFill>
+                <a:latin typeface="JetBrains Mono" pitchFamily="34" charset="0"/>
+                <a:ea typeface="JetBrains Mono" pitchFamily="34" charset="-122"/>
+                <a:cs typeface="JetBrains Mono" pitchFamily="34" charset="-120"/>
+              </a:rPr>
+              <a:t>    &amp;&amp; let OpenResult::File(ref f) = result</a:t>
+            </a:r>
+            <a:endParaRPr lang="zh-CN" sz="1000" dirty="0"/>
+          </a:p>
+          <a:p>
+            <a:pPr indent="0" marL="0">
+              <a:spcAft>
+                <a:spcPts val="200"/>
+              </a:spcAft>
+              <a:buNone/>
+            </a:pPr>
+            <a:r>
+              <a:rPr lang="zh-CN" altLang="en-US" sz="1000" dirty="0">
+                <a:solidFill>
+                  <a:srgbClr val="E6EBFA"/>
+                </a:solidFill>
+                <a:latin typeface="JetBrains Mono" pitchFamily="34" charset="0"/>
+                <a:ea typeface="JetBrains Mono" pitchFamily="34" charset="-122"/>
+                <a:cs typeface="JetBrains Mono" pitchFamily="34" charset="-120"/>
+              </a:rPr>
+              <a:t>    &amp;&amp; let Ok(meta) = f.location().metadata()</a:t>
+            </a:r>
+            <a:endParaRPr lang="zh-CN" sz="1000" dirty="0"/>
+          </a:p>
+          <a:p>
+            <a:pPr indent="0" marL="0">
+              <a:spcAft>
+                <a:spcPts val="200"/>
+              </a:spcAft>
+              <a:buNone/>
+            </a:pPr>
+            <a:r>
+              <a:rPr lang="zh-CN" altLang="en-US" sz="1000" dirty="0">
+                <a:solidFill>
+                  <a:srgbClr val="E6EBFA"/>
+                </a:solidFill>
+                <a:latin typeface="JetBrains Mono" pitchFamily="34" charset="0"/>
+                <a:ea typeface="JetBrains Mono" pitchFamily="34" charset="-122"/>
+                <a:cs typeface="JetBrains Mono" pitchFamily="34" charset="-120"/>
+              </a:rPr>
+              <a:t>    &amp;&amp; meta.node_type == NodeType::Fifo</a:t>
+            </a:r>
+            <a:endParaRPr lang="zh-CN" sz="1000" dirty="0"/>
+          </a:p>
+          <a:p>
+            <a:pPr indent="0" marL="0">
+              <a:spcAft>
+                <a:spcPts val="200"/>
+              </a:spcAft>
+              <a:buNone/>
+            </a:pPr>
+            <a:r>
+              <a:rPr lang="zh-CN" altLang="en-US" sz="1000" dirty="0">
+                <a:solidFill>
+                  <a:srgbClr val="E6EBFA"/>
+                </a:solidFill>
+                <a:latin typeface="JetBrains Mono" pitchFamily="34" charset="0"/>
+                <a:ea typeface="JetBrains Mono" pitchFamily="34" charset="-122"/>
+                <a:cs typeface="JetBrains Mono" pitchFamily="34" charset="-120"/>
+              </a:rPr>
+              <a:t>{</a:t>
+            </a:r>
+            <a:endParaRPr lang="zh-CN" sz="1000" dirty="0"/>
+          </a:p>
+          <a:p>
+            <a:pPr indent="0" marL="0">
+              <a:spcAft>
+                <a:spcPts val="200"/>
+              </a:spcAft>
+              <a:buNone/>
+            </a:pPr>
+            <a:r>
+              <a:rPr lang="zh-CN" altLang="en-US" sz="1000" dirty="0">
+                <a:solidFill>
+                  <a:srgbClr val="E6EBFA"/>
+                </a:solidFill>
+                <a:latin typeface="JetBrains Mono" pitchFamily="34" charset="0"/>
+                <a:ea typeface="JetBrains Mono" pitchFamily="34" charset="-122"/>
+                <a:cs typeface="JetBrains Mono" pitchFamily="34" charset="-120"/>
+              </a:rPr>
+              <a:t>    return Err(AxError::NoSuchDeviceOrAddress);</a:t>
+            </a:r>
+            <a:endParaRPr lang="zh-CN" sz="1000" dirty="0"/>
+          </a:p>
+          <a:p>
+            <a:pPr indent="0" marL="0">
+              <a:spcAft>
+                <a:spcPts val="200"/>
+              </a:spcAft>
+              <a:buNone/>
+            </a:pPr>
+            <a:r>
+              <a:rPr lang="zh-CN" altLang="en-US" sz="1000" dirty="0">
+                <a:solidFill>
+                  <a:srgbClr val="E6EBFA"/>
+                </a:solidFill>
+                <a:latin typeface="JetBrains Mono" pitchFamily="34" charset="0"/>
+                <a:ea typeface="JetBrains Mono" pitchFamily="34" charset="-122"/>
+                <a:cs typeface="JetBrains Mono" pitchFamily="34" charset="-120"/>
+              </a:rPr>
+              <a:t>}</a:t>
+            </a:r>
+            <a:endParaRPr lang="zh-CN" sz="1000" dirty="0"/>
+          </a:p>
+        </p:txBody>
+      </p:sp>
+      <p:sp>
+        <p:nvSpPr>
+          <p:cNvPr id="11" name="Shape 9"/>
+          <p:cNvSpPr/>
+          <p:nvPr/>
+        </p:nvSpPr>
+        <p:spPr>
+          <a:xfrm>
+            <a:off x="640080" y="3584448"/>
+            <a:ext cx="1175004" cy="310896"/>
+          </a:xfrm>
+          <a:prstGeom prst="roundRect">
+            <a:avLst>
+              <a:gd name="adj" fmla="val 23529"/>
+            </a:avLst>
+          </a:prstGeom>
+          <a:solidFill>
+            <a:srgbClr val="0B1437"/>
+          </a:solidFill>
+          <a:ln w="12700">
+            <a:solidFill>
+              <a:srgbClr val="0B1437"/>
+            </a:solidFill>
+            <a:prstDash val="solid"/>
+          </a:ln>
+        </p:spPr>
+      </p:sp>
+      <p:sp>
+        <p:nvSpPr>
+          <p:cNvPr id="12" name="Text 10"/>
+          <p:cNvSpPr/>
+          <p:nvPr/>
+        </p:nvSpPr>
+        <p:spPr>
+          <a:xfrm>
+            <a:off x="640080" y="3584448"/>
+            <a:ext cx="1175004" cy="310896"/>
+          </a:xfrm>
+          <a:prstGeom prst="rect">
+            <a:avLst/>
+          </a:prstGeom>
+          <a:noFill/>
+          <a:ln/>
+        </p:spPr>
+        <p:txBody>
+          <a:bodyPr wrap="square" lIns="0" tIns="0" rIns="0" bIns="0" rtlCol="0" anchor="ctr"/>
+          <a:lstStyle/>
+          <a:p>
+            <a:pPr algn="ctr" indent="0" marL="0">
+              <a:buNone/>
+            </a:pPr>
+            <a:r>
+              <a:rPr lang="zh-CN" altLang="en-US" sz="1200" b="1" dirty="0">
+                <a:solidFill>
+                  <a:srgbClr val="FFFFFF"/>
+                </a:solidFill>
+                <a:latin typeface="HarmonyOS Sans SC" pitchFamily="34" charset="0"/>
+                <a:ea typeface="HarmonyOS Sans SC" pitchFamily="34" charset="-122"/>
+                <a:cs typeface="HarmonyOS Sans SC" pitchFamily="34" charset="-120"/>
+              </a:rPr>
+              <a:t>Linux 7.1</a:t>
+            </a:r>
+            <a:endParaRPr lang="zh-CN" sz="1200" dirty="0"/>
+          </a:p>
+        </p:txBody>
+      </p:sp>
+      <p:sp>
+        <p:nvSpPr>
+          <p:cNvPr id="13" name="Text 11"/>
+          <p:cNvSpPr/>
+          <p:nvPr/>
+        </p:nvSpPr>
+        <p:spPr>
+          <a:xfrm>
+            <a:off x="640080" y="3968496"/>
+            <a:ext cx="2514600" cy="548640"/>
+          </a:xfrm>
+          <a:prstGeom prst="rect">
+            <a:avLst/>
+          </a:prstGeom>
+          <a:noFill/>
+          <a:ln/>
+        </p:spPr>
+        <p:txBody>
+          <a:bodyPr wrap="square" lIns="0" tIns="0" rIns="0" bIns="0" rtlCol="0" anchor="t"/>
+          <a:lstStyle/>
+          <a:p>
+            <a:pPr indent="0" marL="0">
+              <a:buNone/>
+            </a:pPr>
+            <a:r>
+              <a:rPr lang="zh-CN" altLang="en-US" sz="1200" dirty="0">
+                <a:solidFill>
+                  <a:srgbClr val="7A859C"/>
+                </a:solidFill>
+                <a:latin typeface="HarmonyOS Sans SC" pitchFamily="34" charset="0"/>
+                <a:ea typeface="HarmonyOS Sans SC" pitchFamily="34" charset="-122"/>
+                <a:cs typeface="HarmonyOS Sans SC" pitchFamily="34" charset="-120"/>
+              </a:rPr>
+              <a:t>fs/pipe.c 第 1188 至 1190 行</a:t>
+            </a:r>
+            <a:endParaRPr lang="zh-CN" sz="1200" dirty="0"/>
+          </a:p>
+        </p:txBody>
+      </p:sp>
+      <p:sp>
+        <p:nvSpPr>
+          <p:cNvPr id="14" name="Shape 12"/>
+          <p:cNvSpPr/>
+          <p:nvPr/>
+        </p:nvSpPr>
+        <p:spPr>
+          <a:xfrm>
+            <a:off x="3337560" y="3538728"/>
+            <a:ext cx="8214055" cy="822960"/>
+          </a:xfrm>
+          <a:prstGeom prst="roundRect">
+            <a:avLst>
+              <a:gd name="adj" fmla="val 11111"/>
+            </a:avLst>
+          </a:prstGeom>
+          <a:solidFill>
+            <a:srgbClr val="0B1437"/>
+          </a:solidFill>
+          <a:ln w="12700">
+            <a:solidFill>
+              <a:srgbClr val="0B1437"/>
+            </a:solidFill>
+            <a:prstDash val="solid"/>
+          </a:ln>
+        </p:spPr>
+      </p:sp>
+      <p:sp>
+        <p:nvSpPr>
+          <p:cNvPr id="15" name="Text 13"/>
+          <p:cNvSpPr/>
+          <p:nvPr/>
+        </p:nvSpPr>
+        <p:spPr>
+          <a:xfrm>
+            <a:off x="3566160" y="3675888"/>
+            <a:ext cx="7756855" cy="548640"/>
+          </a:xfrm>
+          <a:prstGeom prst="rect">
+            <a:avLst/>
+          </a:prstGeom>
+          <a:noFill/>
+          <a:ln/>
+        </p:spPr>
+        <p:txBody>
+          <a:bodyPr wrap="square" lIns="0" tIns="0" rIns="0" bIns="0" rtlCol="0" anchor="t"/>
+          <a:lstStyle/>
+          <a:p>
+            <a:pPr indent="0" marL="0">
+              <a:spcAft>
+                <a:spcPts val="200"/>
+              </a:spcAft>
+              <a:buNone/>
+            </a:pPr>
+            <a:r>
+              <a:rPr lang="zh-CN" altLang="en-US" sz="1000" dirty="0">
+                <a:solidFill>
+                  <a:srgbClr val="E6EBFA"/>
+                </a:solidFill>
+                <a:latin typeface="JetBrains Mono" pitchFamily="34" charset="0"/>
+                <a:ea typeface="JetBrains Mono" pitchFamily="34" charset="-122"/>
+                <a:cs typeface="JetBrains Mono" pitchFamily="34" charset="-120"/>
+              </a:rPr>
+              <a:t>ret = -ENXIO;</a:t>
+            </a:r>
+            <a:endParaRPr lang="zh-CN" sz="1000" dirty="0"/>
+          </a:p>
+          <a:p>
+            <a:pPr indent="0" marL="0">
+              <a:spcAft>
+                <a:spcPts val="200"/>
+              </a:spcAft>
+              <a:buNone/>
+            </a:pPr>
+            <a:r>
+              <a:rPr lang="zh-CN" altLang="en-US" sz="1000" dirty="0">
+                <a:solidFill>
+                  <a:srgbClr val="E6EBFA"/>
+                </a:solidFill>
+                <a:latin typeface="JetBrains Mono" pitchFamily="34" charset="0"/>
+                <a:ea typeface="JetBrains Mono" pitchFamily="34" charset="-122"/>
+                <a:cs typeface="JetBrains Mono" pitchFamily="34" charset="-120"/>
+              </a:rPr>
+              <a:t>if (!is_pipe &amp;&amp; (filp-&gt;f_flags &amp; O_NONBLOCK) &amp;&amp; !pipe-&gt;readers)</a:t>
+            </a:r>
+            <a:endParaRPr lang="zh-CN" sz="1000" dirty="0"/>
+          </a:p>
+          <a:p>
+            <a:pPr indent="0" marL="0">
+              <a:spcAft>
+                <a:spcPts val="200"/>
+              </a:spcAft>
+              <a:buNone/>
+            </a:pPr>
+            <a:r>
+              <a:rPr lang="zh-CN" altLang="en-US" sz="1000" dirty="0">
+                <a:solidFill>
+                  <a:srgbClr val="E6EBFA"/>
+                </a:solidFill>
+                <a:latin typeface="JetBrains Mono" pitchFamily="34" charset="0"/>
+                <a:ea typeface="JetBrains Mono" pitchFamily="34" charset="-122"/>
+                <a:cs typeface="JetBrains Mono" pitchFamily="34" charset="-120"/>
+              </a:rPr>
+              <a:t>    goto err;</a:t>
+            </a:r>
+            <a:endParaRPr lang="zh-CN" sz="1000" dirty="0"/>
+          </a:p>
+        </p:txBody>
+      </p:sp>
+      <p:sp>
+        <p:nvSpPr>
+          <p:cNvPr id="16" name="Shape 14"/>
+          <p:cNvSpPr/>
+          <p:nvPr/>
+        </p:nvSpPr>
+        <p:spPr>
+          <a:xfrm>
+            <a:off x="640080" y="4517136"/>
+            <a:ext cx="1060704" cy="310896"/>
+          </a:xfrm>
+          <a:prstGeom prst="roundRect">
+            <a:avLst>
+              <a:gd name="adj" fmla="val 23529"/>
+            </a:avLst>
+          </a:prstGeom>
+          <a:solidFill>
+            <a:srgbClr val="1FA896"/>
+          </a:solidFill>
+          <a:ln w="12700">
+            <a:solidFill>
+              <a:srgbClr val="1FA896"/>
+            </a:solidFill>
+            <a:prstDash val="solid"/>
+          </a:ln>
+        </p:spPr>
+      </p:sp>
+      <p:sp>
+        <p:nvSpPr>
+          <p:cNvPr id="17" name="Text 15"/>
+          <p:cNvSpPr/>
+          <p:nvPr/>
+        </p:nvSpPr>
+        <p:spPr>
+          <a:xfrm>
+            <a:off x="640080" y="4517136"/>
+            <a:ext cx="1060704" cy="310896"/>
+          </a:xfrm>
+          <a:prstGeom prst="rect">
+            <a:avLst/>
+          </a:prstGeom>
+          <a:noFill/>
+          <a:ln/>
+        </p:spPr>
+        <p:txBody>
+          <a:bodyPr wrap="square" lIns="0" tIns="0" rIns="0" bIns="0" rtlCol="0" anchor="ctr"/>
+          <a:lstStyle/>
+          <a:p>
+            <a:pPr algn="ctr" indent="0" marL="0">
+              <a:buNone/>
+            </a:pPr>
+            <a:r>
+              <a:rPr lang="zh-CN" altLang="en-US" sz="1200" b="1" dirty="0">
+                <a:solidFill>
+                  <a:srgbClr val="FFFFFF"/>
+                </a:solidFill>
+                <a:latin typeface="HarmonyOS Sans SC" pitchFamily="34" charset="0"/>
+                <a:ea typeface="HarmonyOS Sans SC" pitchFamily="34" charset="-122"/>
+                <a:cs typeface="HarmonyOS Sans SC" pitchFamily="34" charset="-120"/>
+              </a:rPr>
+              <a:t>当前 dev</a:t>
+            </a:r>
+            <a:endParaRPr lang="zh-CN" sz="1200" dirty="0"/>
+          </a:p>
+        </p:txBody>
+      </p:sp>
+      <p:sp>
+        <p:nvSpPr>
+          <p:cNvPr id="18" name="Text 16"/>
+          <p:cNvSpPr/>
+          <p:nvPr/>
+        </p:nvSpPr>
+        <p:spPr>
+          <a:xfrm>
+            <a:off x="640080" y="4901184"/>
+            <a:ext cx="2514600" cy="548640"/>
+          </a:xfrm>
+          <a:prstGeom prst="rect">
+            <a:avLst/>
+          </a:prstGeom>
+          <a:noFill/>
+          <a:ln/>
+        </p:spPr>
+        <p:txBody>
+          <a:bodyPr wrap="square" lIns="0" tIns="0" rIns="0" bIns="0" rtlCol="0" anchor="t"/>
+          <a:lstStyle/>
+          <a:p>
+            <a:pPr indent="0" marL="0">
+              <a:buNone/>
+            </a:pPr>
+            <a:r>
+              <a:rPr lang="zh-CN" altLang="en-US" sz="1200" dirty="0">
+                <a:solidFill>
+                  <a:srgbClr val="7A859C"/>
+                </a:solidFill>
+                <a:latin typeface="HarmonyOS Sans SC" pitchFamily="34" charset="0"/>
+                <a:ea typeface="HarmonyOS Sans SC" pitchFamily="34" charset="-122"/>
+                <a:cs typeface="HarmonyOS Sans SC" pitchFamily="34" charset="-120"/>
+              </a:rPr>
+              <a:t>file/pipe/named.rs：按读端计数</a:t>
+            </a:r>
+            <a:endParaRPr lang="zh-CN" sz="1200" dirty="0"/>
+          </a:p>
+        </p:txBody>
+      </p:sp>
+      <p:sp>
+        <p:nvSpPr>
+          <p:cNvPr id="19" name="Shape 17"/>
+          <p:cNvSpPr/>
+          <p:nvPr/>
+        </p:nvSpPr>
+        <p:spPr>
+          <a:xfrm>
+            <a:off x="3337560" y="4471416"/>
+            <a:ext cx="8214055" cy="822960"/>
+          </a:xfrm>
+          <a:prstGeom prst="roundRect">
+            <a:avLst>
+              <a:gd name="adj" fmla="val 11111"/>
+            </a:avLst>
+          </a:prstGeom>
+          <a:solidFill>
+            <a:srgbClr val="0B1437"/>
+          </a:solidFill>
+          <a:ln w="12700">
+            <a:solidFill>
+              <a:srgbClr val="0B1437"/>
+            </a:solidFill>
+            <a:prstDash val="solid"/>
+          </a:ln>
+        </p:spPr>
+      </p:sp>
+      <p:sp>
+        <p:nvSpPr>
+          <p:cNvPr id="20" name="Text 18"/>
+          <p:cNvSpPr/>
+          <p:nvPr/>
+        </p:nvSpPr>
+        <p:spPr>
+          <a:xfrm>
+            <a:off x="3566160" y="4608576"/>
+            <a:ext cx="7756855" cy="548640"/>
+          </a:xfrm>
+          <a:prstGeom prst="rect">
+            <a:avLst/>
+          </a:prstGeom>
+          <a:noFill/>
+          <a:ln/>
+        </p:spPr>
+        <p:txBody>
+          <a:bodyPr wrap="square" lIns="0" tIns="0" rIns="0" bIns="0" rtlCol="0" anchor="t"/>
+          <a:lstStyle/>
+          <a:p>
+            <a:pPr indent="0" marL="0">
+              <a:spcAft>
+                <a:spcPts val="200"/>
+              </a:spcAft>
+              <a:buNone/>
+            </a:pPr>
+            <a:r>
+              <a:rPr lang="zh-CN" altLang="en-US" sz="1000" dirty="0">
+                <a:solidFill>
+                  <a:srgbClr val="E6EBFA"/>
+                </a:solidFill>
+                <a:latin typeface="JetBrains Mono" pitchFamily="34" charset="0"/>
+                <a:ea typeface="JetBrains Mono" pitchFamily="34" charset="-122"/>
+                <a:cs typeface="JetBrains Mono" pitchFamily="34" charset="-120"/>
+              </a:rPr>
+              <a:t>if access == PipeAccess::Write &amp;&amp; nonblocking &amp;&amp; state.readers == 0 {</a:t>
+            </a:r>
+            <a:endParaRPr lang="zh-CN" sz="1000" dirty="0"/>
+          </a:p>
+          <a:p>
+            <a:pPr indent="0" marL="0">
+              <a:spcAft>
+                <a:spcPts val="200"/>
+              </a:spcAft>
+              <a:buNone/>
+            </a:pPr>
+            <a:r>
+              <a:rPr lang="zh-CN" altLang="en-US" sz="1000" dirty="0">
+                <a:solidFill>
+                  <a:srgbClr val="E6EBFA"/>
+                </a:solidFill>
+                <a:latin typeface="JetBrains Mono" pitchFamily="34" charset="0"/>
+                <a:ea typeface="JetBrains Mono" pitchFamily="34" charset="-122"/>
+                <a:cs typeface="JetBrains Mono" pitchFamily="34" charset="-120"/>
+              </a:rPr>
+              <a:t>    return Err(StarryError::NoSuchDeviceOrAddress);</a:t>
+            </a:r>
+            <a:endParaRPr lang="zh-CN" sz="1000" dirty="0"/>
+          </a:p>
+          <a:p>
+            <a:pPr indent="0" marL="0">
+              <a:spcAft>
+                <a:spcPts val="200"/>
+              </a:spcAft>
+              <a:buNone/>
+            </a:pPr>
+            <a:r>
+              <a:rPr lang="zh-CN" altLang="en-US" sz="1000" dirty="0">
+                <a:solidFill>
+                  <a:srgbClr val="E6EBFA"/>
+                </a:solidFill>
+                <a:latin typeface="JetBrains Mono" pitchFamily="34" charset="0"/>
+                <a:ea typeface="JetBrains Mono" pitchFamily="34" charset="-122"/>
+                <a:cs typeface="JetBrains Mono" pitchFamily="34" charset="-120"/>
+              </a:rPr>
+              <a:t>}</a:t>
+            </a:r>
+            <a:endParaRPr lang="zh-CN" sz="1000" dirty="0"/>
+          </a:p>
+        </p:txBody>
+      </p:sp>
+      <p:sp>
+        <p:nvSpPr>
+          <p:cNvPr id="21" name="Text 19"/>
+          <p:cNvSpPr/>
+          <p:nvPr/>
+        </p:nvSpPr>
+        <p:spPr>
+          <a:xfrm>
+            <a:off x="640080" y="6108192"/>
+            <a:ext cx="10180015" cy="365760"/>
+          </a:xfrm>
+          <a:prstGeom prst="rect">
+            <a:avLst/>
+          </a:prstGeom>
+          <a:noFill/>
+          <a:ln/>
+        </p:spPr>
+        <p:txBody>
+          <a:bodyPr wrap="square" lIns="0" tIns="0" rIns="0" bIns="0" rtlCol="0" anchor="ctr"/>
+          <a:lstStyle/>
+          <a:p>
+            <a:pPr indent="0" marL="0">
+              <a:buNone/>
+            </a:pPr>
+            <a:r>
+              <a:rPr lang="zh-CN" altLang="en-US" sz="1300" dirty="0">
+                <a:solidFill>
+                  <a:srgbClr val="7A859C"/>
+                </a:solidFill>
+                <a:latin typeface="HarmonyOS Sans SC" pitchFamily="34" charset="0"/>
+                <a:ea typeface="HarmonyOS Sans SC" pitchFamily="34" charset="-122"/>
+                <a:cs typeface="HarmonyOS Sans SC" pitchFamily="34" charset="-120"/>
+              </a:rPr>
+              <a:t>溯源查出的偏差：有读端时补丁仍返回 ENXIO，与 Linux 不符；当前 dev 已改对。</a:t>
+            </a:r>
+            <a:endParaRPr lang="zh-CN" sz="1300" dirty="0"/>
+          </a:p>
+        </p:txBody>
+      </p:sp>
+    </p:spTree>
+  </p:cSld>
+  <p:clrMapOvr>
+    <a:masterClrMapping/>
+  </p:clrMapOvr>
+</p:sld>
+</file>
+
+<file path=ppt/slides/slide37.xml><?xml version="1.0" encoding="utf-8"?>
+<p:sld xmlns:a="http://schemas.openxmlformats.org/drawingml/2006/main" xmlns:r="http://schemas.openxmlformats.org/officeDocument/2006/relationships" xmlns:p="http://schemas.openxmlformats.org/presentationml/2006/main">
+  <p:cSld name="Slide 37">
     <p:bg>
       <p:bgPr>
         <a:solidFill>
@@ -31476,7 +36287,7 @@
       </p:sp>
       <p:pic>
         <p:nvPicPr>
-          <p:cNvPr id="25" name="Image 0" descr="C:\Users\heke\AppData\Local\Temp\claude\C--Users-heke-AllProjects-TempFolder-rcore\1c6e91ee-4f87-4550-9a26-b0faa3d92502\scratchpad\atl\deck\img\4399-c-starry.png">    </p:cNvPr>
+          <p:cNvPr id="25" name="Image 0" descr="C:\Users\heke\AppData\Local\Temp\claude\C--Users-heke-AllProjects-TempFolder-rcore\1c6e91ee-4f87-4550-9a26-b0faa3d92502\scratchpad\deck2\img\4399-c-starry.png">    </p:cNvPr>
           <p:cNvPicPr>
             <a:picLocks noChangeAspect="1"/>
           </p:cNvPicPr>
@@ -31539,7 +36350,7 @@
       </p:sp>
       <p:pic>
         <p:nvPicPr>
-          <p:cNvPr id="27" name="Image 1" descr="C:\Users\heke\AppData\Local\Temp\claude\C--Users-heke-AllProjects-TempFolder-rcore\1c6e91ee-4f87-4550-9a26-b0faa3d92502\scratchpad\atl\deck\img\4399-c-linux.png">    </p:cNvPr>
+          <p:cNvPr id="27" name="Image 1" descr="C:\Users\heke\AppData\Local\Temp\claude\C--Users-heke-AllProjects-TempFolder-rcore\1c6e91ee-4f87-4550-9a26-b0faa3d92502\scratchpad\deck2\img\4399-c-linux.png">    </p:cNvPr>
           <p:cNvPicPr>
             <a:picLocks noChangeAspect="1"/>
           </p:cNvPicPr>
@@ -31602,7 +36413,7 @@
       </p:sp>
       <p:pic>
         <p:nvPicPr>
-          <p:cNvPr id="29" name="Image 2" descr="C:\Users\heke\AppData\Local\Temp\claude\C--Users-heke-AllProjects-TempFolder-rcore\1c6e91ee-4f87-4550-9a26-b0faa3d92502\scratchpad\atl\deck\img\4399-g-starry.png">    </p:cNvPr>
+          <p:cNvPr id="29" name="Image 2" descr="C:\Users\heke\AppData\Local\Temp\claude\C--Users-heke-AllProjects-TempFolder-rcore\1c6e91ee-4f87-4550-9a26-b0faa3d92502\scratchpad\deck2\img\4399-g-starry.png">    </p:cNvPr>
           <p:cNvPicPr>
             <a:picLocks noChangeAspect="1"/>
           </p:cNvPicPr>
@@ -31665,7 +36476,7 @@
       </p:sp>
       <p:pic>
         <p:nvPicPr>
-          <p:cNvPr id="31" name="Image 3" descr="C:\Users\heke\AppData\Local\Temp\claude\C--Users-heke-AllProjects-TempFolder-rcore\1c6e91ee-4f87-4550-9a26-b0faa3d92502\scratchpad\atl\deck\img\4399-g-linux.png">    </p:cNvPr>
+          <p:cNvPr id="31" name="Image 3" descr="C:\Users\heke\AppData\Local\Temp\claude\C--Users-heke-AllProjects-TempFolder-rcore\1c6e91ee-4f87-4550-9a26-b0faa3d92502\scratchpad\deck2\img\4399-g-linux.png">    </p:cNvPr>
           <p:cNvPicPr>
             <a:picLocks noChangeAspect="1"/>
           </p:cNvPicPr>

</xml_diff>